<commit_message>
fixing mmap and threads compute functions
</commit_message>
<xml_diff>
--- a/project_slides.pptx
+++ b/project_slides.pptx
@@ -17566,15 +17566,8 @@
                 <a:ea typeface="Consolas" pitchFamily="34" charset="-122"/>
                 <a:cs typeface="Consolas" pitchFamily="34" charset="-120"/>
               </a:rPr>
-              <a:t>unsigned long
-</a:t>
-            </a:r>
-            <a:endParaRPr lang="en-US" sz="1200" dirty="0"/>
-          </a:p>
-          <a:p>
-            <a:pPr marL="0" indent="0">
-              <a:buNone/>
-            </a:pPr>
+              <a:t>unsigned long</a:t>
+            </a:r>
             <a:r>
               <a:rPr lang="en-US" sz="1200" dirty="0">
                 <a:solidFill>
@@ -17585,8 +17578,6 @@
                 <a:cs typeface="Calibri" pitchFamily="34" charset="-120"/>
               </a:rPr>
               <a:t>
-Input must be non-negative integers.
-Negatives are skipped with a warning.
 </a:t>
             </a:r>
             <a:endParaRPr lang="en-US" sz="1200" dirty="0"/>
@@ -18004,11 +17995,10 @@
             <a:endParaRPr lang="en-US" sz="1080" dirty="0"/>
           </a:p>
           <a:p>
-            <a:pPr marL="0" indent="0">
+            <a:pPr>
               <a:spcAft>
                 <a:spcPts val="100"/>
               </a:spcAft>
-              <a:buNone/>
             </a:pPr>
             <a:r>
               <a:rPr lang="en-US" sz="1080" dirty="0">
@@ -18019,16 +18009,94 @@
                 <a:ea typeface="Consolas" pitchFamily="34" charset="-122"/>
                 <a:cs typeface="Consolas" pitchFamily="34" charset="-120"/>
               </a:rPr>
-              <a:t>6. result = f(partials[0..n-1])</a:t>
-            </a:r>
-            <a:endParaRPr lang="en-US" sz="1080" dirty="0"/>
-          </a:p>
-          <a:p>
-            <a:pPr marL="0" indent="0">
+              <a:t>6. result = partials[0]</a:t>
+            </a:r>
+          </a:p>
+          <a:p>
+            <a:pPr>
               <a:spcAft>
                 <a:spcPts val="100"/>
               </a:spcAft>
-              <a:buNone/>
+            </a:pPr>
+            <a:r>
+              <a:rPr lang="en-US" sz="1080" dirty="0">
+                <a:solidFill>
+                  <a:srgbClr val="79C0FF"/>
+                </a:solidFill>
+                <a:latin typeface="Consolas" pitchFamily="34" charset="0"/>
+                <a:ea typeface="Consolas" pitchFamily="34" charset="-122"/>
+                <a:cs typeface="Consolas" pitchFamily="34" charset="-120"/>
+              </a:rPr>
+              <a:t>   FOR </a:t>
+            </a:r>
+            <a:r>
+              <a:rPr lang="en-US" sz="1080" dirty="0" err="1">
+                <a:solidFill>
+                  <a:srgbClr val="79C0FF"/>
+                </a:solidFill>
+                <a:latin typeface="Consolas" pitchFamily="34" charset="0"/>
+                <a:ea typeface="Consolas" pitchFamily="34" charset="-122"/>
+                <a:cs typeface="Consolas" pitchFamily="34" charset="-120"/>
+              </a:rPr>
+              <a:t>i</a:t>
+            </a:r>
+            <a:r>
+              <a:rPr lang="en-US" sz="1080" dirty="0">
+                <a:solidFill>
+                  <a:srgbClr val="79C0FF"/>
+                </a:solidFill>
+                <a:latin typeface="Consolas" pitchFamily="34" charset="0"/>
+                <a:ea typeface="Consolas" pitchFamily="34" charset="-122"/>
+                <a:cs typeface="Consolas" pitchFamily="34" charset="-120"/>
+              </a:rPr>
+              <a:t> = 1 to n_proc-1:</a:t>
+            </a:r>
+          </a:p>
+          <a:p>
+            <a:pPr>
+              <a:spcAft>
+                <a:spcPts val="100"/>
+              </a:spcAft>
+            </a:pPr>
+            <a:r>
+              <a:rPr lang="en-US" sz="1080" dirty="0">
+                <a:solidFill>
+                  <a:srgbClr val="79C0FF"/>
+                </a:solidFill>
+                <a:latin typeface="Consolas" pitchFamily="34" charset="0"/>
+                <a:ea typeface="Consolas" pitchFamily="34" charset="-122"/>
+                <a:cs typeface="Consolas" pitchFamily="34" charset="-120"/>
+              </a:rPr>
+              <a:t>     result = f((int)result, (int)partials[</a:t>
+            </a:r>
+            <a:r>
+              <a:rPr lang="en-US" sz="1080" dirty="0" err="1">
+                <a:solidFill>
+                  <a:srgbClr val="79C0FF"/>
+                </a:solidFill>
+                <a:latin typeface="Consolas" pitchFamily="34" charset="0"/>
+                <a:ea typeface="Consolas" pitchFamily="34" charset="-122"/>
+                <a:cs typeface="Consolas" pitchFamily="34" charset="-120"/>
+              </a:rPr>
+              <a:t>i</a:t>
+            </a:r>
+            <a:r>
+              <a:rPr lang="en-US" sz="1080" dirty="0">
+                <a:solidFill>
+                  <a:srgbClr val="79C0FF"/>
+                </a:solidFill>
+                <a:latin typeface="Consolas" pitchFamily="34" charset="0"/>
+                <a:ea typeface="Consolas" pitchFamily="34" charset="-122"/>
+                <a:cs typeface="Consolas" pitchFamily="34" charset="-120"/>
+              </a:rPr>
+              <a:t>])</a:t>
+            </a:r>
+          </a:p>
+          <a:p>
+            <a:pPr>
+              <a:spcAft>
+                <a:spcPts val="100"/>
+              </a:spcAft>
             </a:pPr>
             <a:r>
               <a:rPr lang="en-US" sz="1080" dirty="0">
@@ -18600,11 +18668,10 @@
             <a:endParaRPr lang="en-US" sz="1080" dirty="0"/>
           </a:p>
           <a:p>
-            <a:pPr marL="0" indent="0">
+            <a:pPr>
               <a:spcAft>
                 <a:spcPts val="100"/>
               </a:spcAft>
-              <a:buNone/>
             </a:pPr>
             <a:r>
               <a:rPr lang="en-US" sz="1080" dirty="0">
@@ -18615,16 +18682,36 @@
                 <a:ea typeface="Consolas" pitchFamily="34" charset="-122"/>
                 <a:cs typeface="Consolas" pitchFamily="34" charset="-120"/>
               </a:rPr>
-              <a:t>4. FOR i = 0 to n_threads-1:</a:t>
-            </a:r>
-            <a:endParaRPr lang="en-US" sz="1080" dirty="0"/>
-          </a:p>
-          <a:p>
-            <a:pPr marL="0" indent="0">
+              <a:t>4. FOR </a:t>
+            </a:r>
+            <a:r>
+              <a:rPr lang="en-US" sz="1080" dirty="0" err="1">
+                <a:solidFill>
+                  <a:srgbClr val="79C0FF"/>
+                </a:solidFill>
+                <a:latin typeface="Consolas" pitchFamily="34" charset="0"/>
+                <a:ea typeface="Consolas" pitchFamily="34" charset="-122"/>
+                <a:cs typeface="Consolas" pitchFamily="34" charset="-120"/>
+              </a:rPr>
+              <a:t>i</a:t>
+            </a:r>
+            <a:r>
+              <a:rPr lang="en-US" sz="1080" dirty="0">
+                <a:solidFill>
+                  <a:srgbClr val="79C0FF"/>
+                </a:solidFill>
+                <a:latin typeface="Consolas" pitchFamily="34" charset="0"/>
+                <a:ea typeface="Consolas" pitchFamily="34" charset="-122"/>
+                <a:cs typeface="Consolas" pitchFamily="34" charset="-120"/>
+              </a:rPr>
+              <a:t> = 0 to n_threads-1:</a:t>
+            </a:r>
+          </a:p>
+          <a:p>
+            <a:pPr>
               <a:spcAft>
                 <a:spcPts val="100"/>
               </a:spcAft>
-              <a:buNone/>
             </a:pPr>
             <a:r>
               <a:rPr lang="en-US" sz="1080" dirty="0">
@@ -18635,16 +18722,36 @@
                 <a:ea typeface="Consolas" pitchFamily="34" charset="-122"/>
                 <a:cs typeface="Consolas" pitchFamily="34" charset="-120"/>
               </a:rPr>
-              <a:t>     args[i] = { nums, start, end,</a:t>
-            </a:r>
-            <a:endParaRPr lang="en-US" sz="1080" dirty="0"/>
-          </a:p>
-          <a:p>
-            <a:pPr marL="0" indent="0">
+              <a:t>     start = </a:t>
+            </a:r>
+            <a:r>
+              <a:rPr lang="en-US" sz="1080" dirty="0" err="1">
+                <a:solidFill>
+                  <a:srgbClr val="79C0FF"/>
+                </a:solidFill>
+                <a:latin typeface="Consolas" pitchFamily="34" charset="0"/>
+                <a:ea typeface="Consolas" pitchFamily="34" charset="-122"/>
+                <a:cs typeface="Consolas" pitchFamily="34" charset="-120"/>
+              </a:rPr>
+              <a:t>i</a:t>
+            </a:r>
+            <a:r>
+              <a:rPr lang="en-US" sz="1080" dirty="0">
+                <a:solidFill>
+                  <a:srgbClr val="79C0FF"/>
+                </a:solidFill>
+                <a:latin typeface="Consolas" pitchFamily="34" charset="0"/>
+                <a:ea typeface="Consolas" pitchFamily="34" charset="-122"/>
+                <a:cs typeface="Consolas" pitchFamily="34" charset="-120"/>
+              </a:rPr>
+              <a:t> * chunk</a:t>
+            </a:r>
+          </a:p>
+          <a:p>
+            <a:pPr>
               <a:spcAft>
                 <a:spcPts val="100"/>
               </a:spcAft>
-              <a:buNone/>
             </a:pPr>
             <a:r>
               <a:rPr lang="en-US" sz="1080" dirty="0">
@@ -18655,16 +18762,14 @@
                 <a:ea typeface="Consolas" pitchFamily="34" charset="-122"/>
                 <a:cs typeface="Consolas" pitchFamily="34" charset="-120"/>
               </a:rPr>
-              <a:t>                  f, &amp;partials[i] }</a:t>
-            </a:r>
-            <a:endParaRPr lang="en-US" sz="1080" dirty="0"/>
-          </a:p>
-          <a:p>
-            <a:pPr marL="0" indent="0">
+              <a:t>     end = start + chunk - 1</a:t>
+            </a:r>
+          </a:p>
+          <a:p>
+            <a:pPr>
               <a:spcAft>
                 <a:spcPts val="100"/>
               </a:spcAft>
-              <a:buNone/>
             </a:pPr>
             <a:r>
               <a:rPr lang="en-US" sz="1080" dirty="0">
@@ -18677,34 +18782,118 @@
               </a:rPr>
               <a:t>     if last: end += remainder</a:t>
             </a:r>
-            <a:endParaRPr lang="en-US" sz="1080" dirty="0"/>
-          </a:p>
-          <a:p>
-            <a:pPr marL="0" indent="0">
+          </a:p>
+          <a:p>
+            <a:pPr>
               <a:spcAft>
                 <a:spcPts val="100"/>
               </a:spcAft>
-              <a:buNone/>
             </a:pPr>
             <a:r>
               <a:rPr lang="en-US" sz="1080" dirty="0">
                 <a:solidFill>
-                  <a:srgbClr val="FFA552"/>
+                  <a:srgbClr val="79C0FF"/>
                 </a:solidFill>
                 <a:latin typeface="Consolas" pitchFamily="34" charset="0"/>
                 <a:ea typeface="Consolas" pitchFamily="34" charset="-122"/>
                 <a:cs typeface="Consolas" pitchFamily="34" charset="-120"/>
               </a:rPr>
-              <a:t>     pthread_create(worker, args[i])</a:t>
-            </a:r>
-            <a:endParaRPr lang="en-US" sz="1080" dirty="0"/>
-          </a:p>
-          <a:p>
-            <a:pPr marL="0" indent="0">
+              <a:t>     </a:t>
+            </a:r>
+            <a:r>
+              <a:rPr lang="en-US" sz="1080" dirty="0" err="1">
+                <a:solidFill>
+                  <a:srgbClr val="79C0FF"/>
+                </a:solidFill>
+                <a:latin typeface="Consolas" pitchFamily="34" charset="0"/>
+                <a:ea typeface="Consolas" pitchFamily="34" charset="-122"/>
+                <a:cs typeface="Consolas" pitchFamily="34" charset="-120"/>
+              </a:rPr>
+              <a:t>args</a:t>
+            </a:r>
+            <a:r>
+              <a:rPr lang="en-US" sz="1080" dirty="0">
+                <a:solidFill>
+                  <a:srgbClr val="79C0FF"/>
+                </a:solidFill>
+                <a:latin typeface="Consolas" pitchFamily="34" charset="0"/>
+                <a:ea typeface="Consolas" pitchFamily="34" charset="-122"/>
+                <a:cs typeface="Consolas" pitchFamily="34" charset="-120"/>
+              </a:rPr>
+              <a:t>[</a:t>
+            </a:r>
+            <a:r>
+              <a:rPr lang="en-US" sz="1080" dirty="0" err="1">
+                <a:solidFill>
+                  <a:srgbClr val="79C0FF"/>
+                </a:solidFill>
+                <a:latin typeface="Consolas" pitchFamily="34" charset="0"/>
+                <a:ea typeface="Consolas" pitchFamily="34" charset="-122"/>
+                <a:cs typeface="Consolas" pitchFamily="34" charset="-120"/>
+              </a:rPr>
+              <a:t>i</a:t>
+            </a:r>
+            <a:r>
+              <a:rPr lang="en-US" sz="1080" dirty="0">
+                <a:solidFill>
+                  <a:srgbClr val="79C0FF"/>
+                </a:solidFill>
+                <a:latin typeface="Consolas" pitchFamily="34" charset="0"/>
+                <a:ea typeface="Consolas" pitchFamily="34" charset="-122"/>
+                <a:cs typeface="Consolas" pitchFamily="34" charset="-120"/>
+              </a:rPr>
+              <a:t>] = { </a:t>
+            </a:r>
+            <a:r>
+              <a:rPr lang="en-US" sz="1080" dirty="0" err="1">
+                <a:solidFill>
+                  <a:srgbClr val="79C0FF"/>
+                </a:solidFill>
+                <a:latin typeface="Consolas" pitchFamily="34" charset="0"/>
+                <a:ea typeface="Consolas" pitchFamily="34" charset="-122"/>
+                <a:cs typeface="Consolas" pitchFamily="34" charset="-120"/>
+              </a:rPr>
+              <a:t>nums</a:t>
+            </a:r>
+            <a:r>
+              <a:rPr lang="en-US" sz="1080" dirty="0">
+                <a:solidFill>
+                  <a:srgbClr val="79C0FF"/>
+                </a:solidFill>
+                <a:latin typeface="Consolas" pitchFamily="34" charset="0"/>
+                <a:ea typeface="Consolas" pitchFamily="34" charset="-122"/>
+                <a:cs typeface="Consolas" pitchFamily="34" charset="-120"/>
+              </a:rPr>
+              <a:t>, start, end, f, &amp;partials[</a:t>
+            </a:r>
+            <a:r>
+              <a:rPr lang="en-US" sz="1080" dirty="0" err="1">
+                <a:solidFill>
+                  <a:srgbClr val="79C0FF"/>
+                </a:solidFill>
+                <a:latin typeface="Consolas" pitchFamily="34" charset="0"/>
+                <a:ea typeface="Consolas" pitchFamily="34" charset="-122"/>
+                <a:cs typeface="Consolas" pitchFamily="34" charset="-120"/>
+              </a:rPr>
+              <a:t>i</a:t>
+            </a:r>
+            <a:r>
+              <a:rPr lang="en-US" sz="1080" dirty="0">
+                <a:solidFill>
+                  <a:srgbClr val="79C0FF"/>
+                </a:solidFill>
+                <a:latin typeface="Consolas" pitchFamily="34" charset="0"/>
+                <a:ea typeface="Consolas" pitchFamily="34" charset="-122"/>
+                <a:cs typeface="Consolas" pitchFamily="34" charset="-120"/>
+              </a:rPr>
+              <a:t>] }</a:t>
+            </a:r>
+          </a:p>
+          <a:p>
+            <a:pPr>
               <a:spcAft>
                 <a:spcPts val="100"/>
               </a:spcAft>
-              <a:buNone/>
             </a:pPr>
             <a:r>
               <a:rPr lang="en-US" sz="1080" dirty="0">
@@ -18715,16 +18904,80 @@
                 <a:ea typeface="Consolas" pitchFamily="34" charset="-122"/>
                 <a:cs typeface="Consolas" pitchFamily="34" charset="-120"/>
               </a:rPr>
-              <a:t>5. pthread_join all threads</a:t>
-            </a:r>
-            <a:endParaRPr lang="en-US" sz="1080" dirty="0"/>
-          </a:p>
-          <a:p>
-            <a:pPr marL="0" indent="0">
+              <a:t>     </a:t>
+            </a:r>
+            <a:r>
+              <a:rPr lang="en-US" sz="1080" dirty="0" err="1">
+                <a:solidFill>
+                  <a:srgbClr val="79C0FF"/>
+                </a:solidFill>
+                <a:latin typeface="Consolas" pitchFamily="34" charset="0"/>
+                <a:ea typeface="Consolas" pitchFamily="34" charset="-122"/>
+                <a:cs typeface="Consolas" pitchFamily="34" charset="-120"/>
+              </a:rPr>
+              <a:t>pthread_create</a:t>
+            </a:r>
+            <a:r>
+              <a:rPr lang="en-US" sz="1080" dirty="0">
+                <a:solidFill>
+                  <a:srgbClr val="79C0FF"/>
+                </a:solidFill>
+                <a:latin typeface="Consolas" pitchFamily="34" charset="0"/>
+                <a:ea typeface="Consolas" pitchFamily="34" charset="-122"/>
+                <a:cs typeface="Consolas" pitchFamily="34" charset="-120"/>
+              </a:rPr>
+              <a:t>(worker, </a:t>
+            </a:r>
+            <a:r>
+              <a:rPr lang="en-US" sz="1080" dirty="0" err="1">
+                <a:solidFill>
+                  <a:srgbClr val="79C0FF"/>
+                </a:solidFill>
+                <a:latin typeface="Consolas" pitchFamily="34" charset="0"/>
+                <a:ea typeface="Consolas" pitchFamily="34" charset="-122"/>
+                <a:cs typeface="Consolas" pitchFamily="34" charset="-120"/>
+              </a:rPr>
+              <a:t>args</a:t>
+            </a:r>
+            <a:r>
+              <a:rPr lang="en-US" sz="1080" dirty="0">
+                <a:solidFill>
+                  <a:srgbClr val="79C0FF"/>
+                </a:solidFill>
+                <a:latin typeface="Consolas" pitchFamily="34" charset="0"/>
+                <a:ea typeface="Consolas" pitchFamily="34" charset="-122"/>
+                <a:cs typeface="Consolas" pitchFamily="34" charset="-120"/>
+              </a:rPr>
+              <a:t>[</a:t>
+            </a:r>
+            <a:r>
+              <a:rPr lang="en-US" sz="1080" dirty="0" err="1">
+                <a:solidFill>
+                  <a:srgbClr val="79C0FF"/>
+                </a:solidFill>
+                <a:latin typeface="Consolas" pitchFamily="34" charset="0"/>
+                <a:ea typeface="Consolas" pitchFamily="34" charset="-122"/>
+                <a:cs typeface="Consolas" pitchFamily="34" charset="-120"/>
+              </a:rPr>
+              <a:t>i</a:t>
+            </a:r>
+            <a:r>
+              <a:rPr lang="en-US" sz="1080" dirty="0">
+                <a:solidFill>
+                  <a:srgbClr val="79C0FF"/>
+                </a:solidFill>
+                <a:latin typeface="Consolas" pitchFamily="34" charset="0"/>
+                <a:ea typeface="Consolas" pitchFamily="34" charset="-122"/>
+                <a:cs typeface="Consolas" pitchFamily="34" charset="-120"/>
+              </a:rPr>
+              <a:t>])</a:t>
+            </a:r>
+          </a:p>
+          <a:p>
+            <a:pPr>
               <a:spcAft>
                 <a:spcPts val="100"/>
               </a:spcAft>
-              <a:buNone/>
             </a:pPr>
             <a:r>
               <a:rPr lang="en-US" sz="1080" dirty="0">
@@ -18735,16 +18988,215 @@
                 <a:ea typeface="Consolas" pitchFamily="34" charset="-122"/>
                 <a:cs typeface="Consolas" pitchFamily="34" charset="-120"/>
               </a:rPr>
-              <a:t>6. result = f(partials[0..n-1])</a:t>
+              <a:t>5. </a:t>
+            </a:r>
+            <a:r>
+              <a:rPr lang="en-US" sz="1080" dirty="0" err="1">
+                <a:solidFill>
+                  <a:srgbClr val="79C0FF"/>
+                </a:solidFill>
+                <a:latin typeface="Consolas" pitchFamily="34" charset="0"/>
+                <a:ea typeface="Consolas" pitchFamily="34" charset="-122"/>
+                <a:cs typeface="Consolas" pitchFamily="34" charset="-120"/>
+              </a:rPr>
+              <a:t>pthread_join</a:t>
+            </a:r>
+            <a:r>
+              <a:rPr lang="en-US" sz="1080" dirty="0">
+                <a:solidFill>
+                  <a:srgbClr val="79C0FF"/>
+                </a:solidFill>
+                <a:latin typeface="Consolas" pitchFamily="34" charset="0"/>
+                <a:ea typeface="Consolas" pitchFamily="34" charset="-122"/>
+                <a:cs typeface="Consolas" pitchFamily="34" charset="-120"/>
+              </a:rPr>
+              <a:t> all threads</a:t>
             </a:r>
             <a:endParaRPr lang="en-US" sz="1080" dirty="0"/>
           </a:p>
           <a:p>
-            <a:pPr marL="0" indent="0">
+            <a:pPr>
               <a:spcAft>
                 <a:spcPts val="100"/>
               </a:spcAft>
-              <a:buNone/>
+            </a:pPr>
+            <a:r>
+              <a:rPr lang="en-US" sz="1080" dirty="0">
+                <a:solidFill>
+                  <a:srgbClr val="79C0FF"/>
+                </a:solidFill>
+                <a:latin typeface="Consolas" pitchFamily="34" charset="0"/>
+                <a:ea typeface="Consolas" pitchFamily="34" charset="-122"/>
+                <a:cs typeface="Consolas" pitchFamily="34" charset="-120"/>
+              </a:rPr>
+              <a:t>6. result = </a:t>
+            </a:r>
+            <a:r>
+              <a:rPr lang="en-US" sz="1080" dirty="0" err="1">
+                <a:solidFill>
+                  <a:srgbClr val="79C0FF"/>
+                </a:solidFill>
+                <a:latin typeface="Consolas" pitchFamily="34" charset="0"/>
+                <a:ea typeface="Consolas" pitchFamily="34" charset="-122"/>
+                <a:cs typeface="Consolas" pitchFamily="34" charset="-120"/>
+              </a:rPr>
+              <a:t>thread_worker</a:t>
+            </a:r>
+            <a:r>
+              <a:rPr lang="en-US" sz="1080" dirty="0">
+                <a:solidFill>
+                  <a:srgbClr val="79C0FF"/>
+                </a:solidFill>
+                <a:latin typeface="Consolas" pitchFamily="34" charset="0"/>
+                <a:ea typeface="Consolas" pitchFamily="34" charset="-122"/>
+                <a:cs typeface="Consolas" pitchFamily="34" charset="-120"/>
+              </a:rPr>
+              <a:t>(</a:t>
+            </a:r>
+            <a:r>
+              <a:rPr lang="en-US" sz="1080" dirty="0" err="1">
+                <a:solidFill>
+                  <a:srgbClr val="79C0FF"/>
+                </a:solidFill>
+                <a:latin typeface="Consolas" pitchFamily="34" charset="0"/>
+                <a:ea typeface="Consolas" pitchFamily="34" charset="-122"/>
+                <a:cs typeface="Consolas" pitchFamily="34" charset="-120"/>
+              </a:rPr>
+              <a:t>arg</a:t>
+            </a:r>
+            <a:r>
+              <a:rPr lang="en-US" sz="1080" dirty="0">
+                <a:solidFill>
+                  <a:srgbClr val="79C0FF"/>
+                </a:solidFill>
+                <a:latin typeface="Consolas" pitchFamily="34" charset="0"/>
+                <a:ea typeface="Consolas" pitchFamily="34" charset="-122"/>
+                <a:cs typeface="Consolas" pitchFamily="34" charset="-120"/>
+              </a:rPr>
+              <a:t>):</a:t>
+            </a:r>
+          </a:p>
+          <a:p>
+            <a:pPr>
+              <a:spcAft>
+                <a:spcPts val="100"/>
+              </a:spcAft>
+            </a:pPr>
+            <a:r>
+              <a:rPr lang="en-US" sz="1080" dirty="0">
+                <a:solidFill>
+                  <a:srgbClr val="79C0FF"/>
+                </a:solidFill>
+                <a:latin typeface="Consolas" pitchFamily="34" charset="0"/>
+                <a:ea typeface="Consolas" pitchFamily="34" charset="-122"/>
+                <a:cs typeface="Consolas" pitchFamily="34" charset="-120"/>
+              </a:rPr>
+              <a:t>  partial = </a:t>
+            </a:r>
+            <a:r>
+              <a:rPr lang="en-US" sz="1080" dirty="0" err="1">
+                <a:solidFill>
+                  <a:srgbClr val="79C0FF"/>
+                </a:solidFill>
+                <a:latin typeface="Consolas" pitchFamily="34" charset="0"/>
+                <a:ea typeface="Consolas" pitchFamily="34" charset="-122"/>
+                <a:cs typeface="Consolas" pitchFamily="34" charset="-120"/>
+              </a:rPr>
+              <a:t>nums</a:t>
+            </a:r>
+            <a:r>
+              <a:rPr lang="en-US" sz="1080" dirty="0">
+                <a:solidFill>
+                  <a:srgbClr val="79C0FF"/>
+                </a:solidFill>
+                <a:latin typeface="Consolas" pitchFamily="34" charset="0"/>
+                <a:ea typeface="Consolas" pitchFamily="34" charset="-122"/>
+                <a:cs typeface="Consolas" pitchFamily="34" charset="-120"/>
+              </a:rPr>
+              <a:t>[start]</a:t>
+            </a:r>
+          </a:p>
+          <a:p>
+            <a:pPr>
+              <a:spcAft>
+                <a:spcPts val="100"/>
+              </a:spcAft>
+            </a:pPr>
+            <a:r>
+              <a:rPr lang="en-US" sz="1080" dirty="0">
+                <a:solidFill>
+                  <a:srgbClr val="79C0FF"/>
+                </a:solidFill>
+                <a:latin typeface="Consolas" pitchFamily="34" charset="0"/>
+                <a:ea typeface="Consolas" pitchFamily="34" charset="-122"/>
+                <a:cs typeface="Consolas" pitchFamily="34" charset="-120"/>
+              </a:rPr>
+              <a:t>  FOR k = start+1 to end:</a:t>
+            </a:r>
+          </a:p>
+          <a:p>
+            <a:pPr>
+              <a:spcAft>
+                <a:spcPts val="100"/>
+              </a:spcAft>
+            </a:pPr>
+            <a:r>
+              <a:rPr lang="en-US" sz="1080" dirty="0">
+                <a:solidFill>
+                  <a:srgbClr val="79C0FF"/>
+                </a:solidFill>
+                <a:latin typeface="Consolas" pitchFamily="34" charset="0"/>
+                <a:ea typeface="Consolas" pitchFamily="34" charset="-122"/>
+                <a:cs typeface="Consolas" pitchFamily="34" charset="-120"/>
+              </a:rPr>
+              <a:t>    partial = f((int)partial, </a:t>
+            </a:r>
+            <a:r>
+              <a:rPr lang="en-US" sz="1080" dirty="0" err="1">
+                <a:solidFill>
+                  <a:srgbClr val="79C0FF"/>
+                </a:solidFill>
+                <a:latin typeface="Consolas" pitchFamily="34" charset="0"/>
+                <a:ea typeface="Consolas" pitchFamily="34" charset="-122"/>
+                <a:cs typeface="Consolas" pitchFamily="34" charset="-120"/>
+              </a:rPr>
+              <a:t>nums</a:t>
+            </a:r>
+            <a:r>
+              <a:rPr lang="en-US" sz="1080" dirty="0">
+                <a:solidFill>
+                  <a:srgbClr val="79C0FF"/>
+                </a:solidFill>
+                <a:latin typeface="Consolas" pitchFamily="34" charset="0"/>
+                <a:ea typeface="Consolas" pitchFamily="34" charset="-122"/>
+                <a:cs typeface="Consolas" pitchFamily="34" charset="-120"/>
+              </a:rPr>
+              <a:t>[k])</a:t>
+            </a:r>
+          </a:p>
+          <a:p>
+            <a:pPr>
+              <a:spcAft>
+                <a:spcPts val="100"/>
+              </a:spcAft>
+            </a:pPr>
+            <a:r>
+              <a:rPr lang="en-US" sz="1080" dirty="0">
+                <a:solidFill>
+                  <a:srgbClr val="79C0FF"/>
+                </a:solidFill>
+                <a:latin typeface="Consolas" pitchFamily="34" charset="0"/>
+                <a:ea typeface="Consolas" pitchFamily="34" charset="-122"/>
+                <a:cs typeface="Consolas" pitchFamily="34" charset="-120"/>
+              </a:rPr>
+              <a:t>  *result = partial</a:t>
+            </a:r>
+          </a:p>
+          <a:p>
+            <a:pPr>
+              <a:spcAft>
+                <a:spcPts val="100"/>
+              </a:spcAft>
             </a:pPr>
             <a:r>
               <a:rPr lang="en-US" sz="1080" dirty="0">

</xml_diff>

<commit_message>
adding mmap_compute – side note
</commit_message>
<xml_diff>
--- a/project_slides.pptx
+++ b/project_slides.pptx
@@ -5,33 +5,34 @@
     <p:sldMasterId id="2147483648" r:id="rId1"/>
   </p:sldMasterIdLst>
   <p:notesMasterIdLst>
-    <p:notesMasterId r:id="rId26"/>
+    <p:notesMasterId r:id="rId27"/>
   </p:notesMasterIdLst>
   <p:sldIdLst>
     <p:sldId id="256" r:id="rId2"/>
     <p:sldId id="257" r:id="rId3"/>
     <p:sldId id="258" r:id="rId4"/>
     <p:sldId id="259" r:id="rId5"/>
-    <p:sldId id="260" r:id="rId6"/>
-    <p:sldId id="268" r:id="rId7"/>
-    <p:sldId id="269" r:id="rId8"/>
-    <p:sldId id="273" r:id="rId9"/>
-    <p:sldId id="274" r:id="rId10"/>
-    <p:sldId id="261" r:id="rId11"/>
-    <p:sldId id="263" r:id="rId12"/>
-    <p:sldId id="264" r:id="rId13"/>
-    <p:sldId id="265" r:id="rId14"/>
-    <p:sldId id="266" r:id="rId15"/>
-    <p:sldId id="267" r:id="rId16"/>
-    <p:sldId id="262" r:id="rId17"/>
-    <p:sldId id="277" r:id="rId18"/>
-    <p:sldId id="276" r:id="rId19"/>
-    <p:sldId id="275" r:id="rId20"/>
-    <p:sldId id="270" r:id="rId21"/>
-    <p:sldId id="271" r:id="rId22"/>
-    <p:sldId id="278" r:id="rId23"/>
-    <p:sldId id="279" r:id="rId24"/>
-    <p:sldId id="280" r:id="rId25"/>
+    <p:sldId id="281" r:id="rId6"/>
+    <p:sldId id="260" r:id="rId7"/>
+    <p:sldId id="268" r:id="rId8"/>
+    <p:sldId id="269" r:id="rId9"/>
+    <p:sldId id="273" r:id="rId10"/>
+    <p:sldId id="274" r:id="rId11"/>
+    <p:sldId id="261" r:id="rId12"/>
+    <p:sldId id="263" r:id="rId13"/>
+    <p:sldId id="264" r:id="rId14"/>
+    <p:sldId id="265" r:id="rId15"/>
+    <p:sldId id="266" r:id="rId16"/>
+    <p:sldId id="267" r:id="rId17"/>
+    <p:sldId id="262" r:id="rId18"/>
+    <p:sldId id="277" r:id="rId19"/>
+    <p:sldId id="276" r:id="rId20"/>
+    <p:sldId id="275" r:id="rId21"/>
+    <p:sldId id="270" r:id="rId22"/>
+    <p:sldId id="271" r:id="rId23"/>
+    <p:sldId id="278" r:id="rId24"/>
+    <p:sldId id="279" r:id="rId25"/>
+    <p:sldId id="280" r:id="rId26"/>
   </p:sldIdLst>
   <p:sldSz cx="9144000" cy="5143500" type="screen16x9"/>
   <p:notesSz cx="5143500" cy="9144000"/>
@@ -6029,6 +6030,90 @@
   <p:cSld>
     <p:spTree>
       <p:nvGrpSpPr>
+        <p:cNvPr id="1" name=""/>
+        <p:cNvGrpSpPr/>
+        <p:nvPr/>
+      </p:nvGrpSpPr>
+      <p:grpSpPr>
+        <a:xfrm>
+          <a:off x="0" y="0"/>
+          <a:ext cx="0" cy="0"/>
+          <a:chOff x="0" y="0"/>
+          <a:chExt cx="0" cy="0"/>
+        </a:xfrm>
+      </p:grpSpPr>
+      <p:sp>
+        <p:nvSpPr>
+          <p:cNvPr id="2" name="Slide Image Placeholder 1"/>
+          <p:cNvSpPr>
+            <a:spLocks noGrp="1" noRot="1" noChangeAspect="1"/>
+          </p:cNvSpPr>
+          <p:nvPr>
+            <p:ph type="sldImg"/>
+          </p:nvPr>
+        </p:nvSpPr>
+        <p:spPr/>
+      </p:sp>
+      <p:sp>
+        <p:nvSpPr>
+          <p:cNvPr id="3" name="Notes Placeholder 2"/>
+          <p:cNvSpPr>
+            <a:spLocks noGrp="1"/>
+          </p:cNvSpPr>
+          <p:nvPr>
+            <p:ph type="body" idx="1"/>
+          </p:nvPr>
+        </p:nvSpPr>
+        <p:spPr/>
+        <p:txBody>
+          <a:bodyPr/>
+          <a:lstStyle/>
+          <a:p>
+            <a:endParaRPr lang="en-US" dirty="0"/>
+          </a:p>
+        </p:txBody>
+      </p:sp>
+      <p:sp>
+        <p:nvSpPr>
+          <p:cNvPr id="4" name="Slide Number Placeholder 3"/>
+          <p:cNvSpPr>
+            <a:spLocks noGrp="1"/>
+          </p:cNvSpPr>
+          <p:nvPr>
+            <p:ph type="sldNum" sz="quarter" idx="10"/>
+          </p:nvPr>
+        </p:nvSpPr>
+        <p:spPr/>
+        <p:txBody>
+          <a:bodyPr/>
+          <a:lstStyle/>
+          <a:p>
+            <a:fld id="{F7021451-1387-4CA6-816F-3879F97B5CBC}" type="slidenum">
+              <a:rPr lang="en-US"/>
+              <a:t>11</a:t>
+            </a:fld>
+            <a:endParaRPr lang="en-US"/>
+          </a:p>
+        </p:txBody>
+      </p:sp>
+    </p:spTree>
+    <p:extLst>
+      <p:ext uri="{BB962C8B-B14F-4D97-AF65-F5344CB8AC3E}">
+        <p14:creationId xmlns:p14="http://schemas.microsoft.com/office/powerpoint/2010/main" val="1024086991"/>
+      </p:ext>
+    </p:extLst>
+  </p:cSld>
+  <p:clrMapOvr>
+    <a:masterClrMapping/>
+  </p:clrMapOvr>
+</p:notes>
+</file>
+
+<file path=ppt/notesSlides/notesSlide12.xml><?xml version="1.0" encoding="utf-8"?>
+<p:notes xmlns:a="http://schemas.openxmlformats.org/drawingml/2006/main" xmlns:r="http://schemas.openxmlformats.org/officeDocument/2006/relationships" xmlns:p="http://schemas.openxmlformats.org/presentationml/2006/main">
+  <p:cSld>
+    <p:spTree>
+      <p:nvGrpSpPr>
         <p:cNvPr id="1" name="">
           <a:extLst>
             <a:ext uri="{FF2B5EF4-FFF2-40B4-BE49-F238E27FC236}">
@@ -6113,7 +6198,7 @@
           <a:p>
             <a:fld id="{F7021451-1387-4CA6-816F-3879F97B5CBC}" type="slidenum">
               <a:rPr lang="en-US"/>
-              <a:t>11</a:t>
+              <a:t>12</a:t>
             </a:fld>
             <a:endParaRPr lang="en-US"/>
           </a:p>
@@ -6132,7 +6217,7 @@
 </p:notes>
 </file>
 
-<file path=ppt/notesSlides/notesSlide12.xml><?xml version="1.0" encoding="utf-8"?>
+<file path=ppt/notesSlides/notesSlide13.xml><?xml version="1.0" encoding="utf-8"?>
 <p:notes xmlns:a="http://schemas.openxmlformats.org/drawingml/2006/main" xmlns:r="http://schemas.openxmlformats.org/officeDocument/2006/relationships" xmlns:p="http://schemas.openxmlformats.org/presentationml/2006/main">
   <p:cSld>
     <p:spTree>
@@ -6221,7 +6306,7 @@
           <a:p>
             <a:fld id="{F7021451-1387-4CA6-816F-3879F97B5CBC}" type="slidenum">
               <a:rPr lang="en-US"/>
-              <a:t>12</a:t>
+              <a:t>13</a:t>
             </a:fld>
             <a:endParaRPr lang="en-US"/>
           </a:p>
@@ -6240,7 +6325,7 @@
 </p:notes>
 </file>
 
-<file path=ppt/notesSlides/notesSlide13.xml><?xml version="1.0" encoding="utf-8"?>
+<file path=ppt/notesSlides/notesSlide14.xml><?xml version="1.0" encoding="utf-8"?>
 <p:notes xmlns:a="http://schemas.openxmlformats.org/drawingml/2006/main" xmlns:r="http://schemas.openxmlformats.org/officeDocument/2006/relationships" xmlns:p="http://schemas.openxmlformats.org/presentationml/2006/main">
   <p:cSld>
     <p:spTree>
@@ -6329,7 +6414,7 @@
           <a:p>
             <a:fld id="{F7021451-1387-4CA6-816F-3879F97B5CBC}" type="slidenum">
               <a:rPr lang="en-US"/>
-              <a:t>13</a:t>
+              <a:t>14</a:t>
             </a:fld>
             <a:endParaRPr lang="en-US"/>
           </a:p>
@@ -6348,7 +6433,7 @@
 </p:notes>
 </file>
 
-<file path=ppt/notesSlides/notesSlide14.xml><?xml version="1.0" encoding="utf-8"?>
+<file path=ppt/notesSlides/notesSlide15.xml><?xml version="1.0" encoding="utf-8"?>
 <p:notes xmlns:a="http://schemas.openxmlformats.org/drawingml/2006/main" xmlns:r="http://schemas.openxmlformats.org/officeDocument/2006/relationships" xmlns:p="http://schemas.openxmlformats.org/presentationml/2006/main">
   <p:cSld>
     <p:spTree>
@@ -6437,7 +6522,7 @@
           <a:p>
             <a:fld id="{F7021451-1387-4CA6-816F-3879F97B5CBC}" type="slidenum">
               <a:rPr lang="en-US"/>
-              <a:t>14</a:t>
+              <a:t>15</a:t>
             </a:fld>
             <a:endParaRPr lang="en-US"/>
           </a:p>
@@ -6456,7 +6541,7 @@
 </p:notes>
 </file>
 
-<file path=ppt/notesSlides/notesSlide15.xml><?xml version="1.0" encoding="utf-8"?>
+<file path=ppt/notesSlides/notesSlide16.xml><?xml version="1.0" encoding="utf-8"?>
 <p:notes xmlns:a="http://schemas.openxmlformats.org/drawingml/2006/main" xmlns:r="http://schemas.openxmlformats.org/officeDocument/2006/relationships" xmlns:p="http://schemas.openxmlformats.org/presentationml/2006/main">
   <p:cSld>
     <p:spTree>
@@ -6545,7 +6630,7 @@
           <a:p>
             <a:fld id="{F7021451-1387-4CA6-816F-3879F97B5CBC}" type="slidenum">
               <a:rPr lang="en-US"/>
-              <a:t>15</a:t>
+              <a:t>16</a:t>
             </a:fld>
             <a:endParaRPr lang="en-US"/>
           </a:p>
@@ -6564,7 +6649,7 @@
 </p:notes>
 </file>
 
-<file path=ppt/notesSlides/notesSlide16.xml><?xml version="1.0" encoding="utf-8"?>
+<file path=ppt/notesSlides/notesSlide17.xml><?xml version="1.0" encoding="utf-8"?>
 <p:notes xmlns:a="http://schemas.openxmlformats.org/drawingml/2006/main" xmlns:r="http://schemas.openxmlformats.org/officeDocument/2006/relationships" xmlns:p="http://schemas.openxmlformats.org/presentationml/2006/main">
   <p:cSld>
     <p:spTree>
@@ -6629,7 +6714,7 @@
           <a:p>
             <a:fld id="{F7021451-1387-4CA6-816F-3879F97B5CBC}" type="slidenum">
               <a:rPr lang="en-US"/>
-              <a:t>16</a:t>
+              <a:t>17</a:t>
             </a:fld>
             <a:endParaRPr lang="en-US"/>
           </a:p>
@@ -6648,7 +6733,7 @@
 </p:notes>
 </file>
 
-<file path=ppt/notesSlides/notesSlide17.xml><?xml version="1.0" encoding="utf-8"?>
+<file path=ppt/notesSlides/notesSlide18.xml><?xml version="1.0" encoding="utf-8"?>
 <p:notes xmlns:a="http://schemas.openxmlformats.org/drawingml/2006/main" xmlns:r="http://schemas.openxmlformats.org/officeDocument/2006/relationships" xmlns:p="http://schemas.openxmlformats.org/presentationml/2006/main">
   <p:cSld>
     <p:spTree>
@@ -6737,7 +6822,7 @@
           <a:p>
             <a:fld id="{F7021451-1387-4CA6-816F-3879F97B5CBC}" type="slidenum">
               <a:rPr lang="en-US"/>
-              <a:t>17</a:t>
+              <a:t>18</a:t>
             </a:fld>
             <a:endParaRPr lang="en-US"/>
           </a:p>
@@ -6756,7 +6841,7 @@
 </p:notes>
 </file>
 
-<file path=ppt/notesSlides/notesSlide18.xml><?xml version="1.0" encoding="utf-8"?>
+<file path=ppt/notesSlides/notesSlide19.xml><?xml version="1.0" encoding="utf-8"?>
 <p:notes xmlns:a="http://schemas.openxmlformats.org/drawingml/2006/main" xmlns:r="http://schemas.openxmlformats.org/officeDocument/2006/relationships" xmlns:p="http://schemas.openxmlformats.org/presentationml/2006/main">
   <p:cSld>
     <p:spTree>
@@ -6845,7 +6930,7 @@
           <a:p>
             <a:fld id="{F7021451-1387-4CA6-816F-3879F97B5CBC}" type="slidenum">
               <a:rPr lang="en-US"/>
-              <a:t>18</a:t>
+              <a:t>19</a:t>
             </a:fld>
             <a:endParaRPr lang="en-US"/>
           </a:p>
@@ -6855,90 +6940,6 @@
     <p:extLst>
       <p:ext uri="{BB962C8B-B14F-4D97-AF65-F5344CB8AC3E}">
         <p14:creationId xmlns:p14="http://schemas.microsoft.com/office/powerpoint/2010/main" val="1212680079"/>
-      </p:ext>
-    </p:extLst>
-  </p:cSld>
-  <p:clrMapOvr>
-    <a:masterClrMapping/>
-  </p:clrMapOvr>
-</p:notes>
-</file>
-
-<file path=ppt/notesSlides/notesSlide19.xml><?xml version="1.0" encoding="utf-8"?>
-<p:notes xmlns:a="http://schemas.openxmlformats.org/drawingml/2006/main" xmlns:r="http://schemas.openxmlformats.org/officeDocument/2006/relationships" xmlns:p="http://schemas.openxmlformats.org/presentationml/2006/main">
-  <p:cSld>
-    <p:spTree>
-      <p:nvGrpSpPr>
-        <p:cNvPr id="1" name=""/>
-        <p:cNvGrpSpPr/>
-        <p:nvPr/>
-      </p:nvGrpSpPr>
-      <p:grpSpPr>
-        <a:xfrm>
-          <a:off x="0" y="0"/>
-          <a:ext cx="0" cy="0"/>
-          <a:chOff x="0" y="0"/>
-          <a:chExt cx="0" cy="0"/>
-        </a:xfrm>
-      </p:grpSpPr>
-      <p:sp>
-        <p:nvSpPr>
-          <p:cNvPr id="2" name="Slide Image Placeholder 1"/>
-          <p:cNvSpPr>
-            <a:spLocks noGrp="1" noRot="1" noChangeAspect="1"/>
-          </p:cNvSpPr>
-          <p:nvPr>
-            <p:ph type="sldImg"/>
-          </p:nvPr>
-        </p:nvSpPr>
-        <p:spPr/>
-      </p:sp>
-      <p:sp>
-        <p:nvSpPr>
-          <p:cNvPr id="3" name="Notes Placeholder 2"/>
-          <p:cNvSpPr>
-            <a:spLocks noGrp="1"/>
-          </p:cNvSpPr>
-          <p:nvPr>
-            <p:ph type="body" idx="1"/>
-          </p:nvPr>
-        </p:nvSpPr>
-        <p:spPr/>
-        <p:txBody>
-          <a:bodyPr/>
-          <a:lstStyle/>
-          <a:p>
-            <a:endParaRPr lang="en-US" dirty="0"/>
-          </a:p>
-        </p:txBody>
-      </p:sp>
-      <p:sp>
-        <p:nvSpPr>
-          <p:cNvPr id="4" name="Slide Number Placeholder 3"/>
-          <p:cNvSpPr>
-            <a:spLocks noGrp="1"/>
-          </p:cNvSpPr>
-          <p:nvPr>
-            <p:ph type="sldNum" sz="quarter" idx="10"/>
-          </p:nvPr>
-        </p:nvSpPr>
-        <p:spPr/>
-        <p:txBody>
-          <a:bodyPr/>
-          <a:lstStyle/>
-          <a:p>
-            <a:fld id="{F7021451-1387-4CA6-816F-3879F97B5CBC}" type="slidenum">
-              <a:rPr lang="en-US"/>
-              <a:t>19</a:t>
-            </a:fld>
-            <a:endParaRPr lang="en-US"/>
-          </a:p>
-        </p:txBody>
-      </p:sp>
-    </p:spTree>
-    <p:extLst>
-      <p:ext uri="{BB962C8B-B14F-4D97-AF65-F5344CB8AC3E}">
-        <p14:creationId xmlns:p14="http://schemas.microsoft.com/office/powerpoint/2010/main" val="1024086991"/>
       </p:ext>
     </p:extLst>
   </p:cSld>
@@ -7037,6 +7038,90 @@
   <p:cSld>
     <p:spTree>
       <p:nvGrpSpPr>
+        <p:cNvPr id="1" name=""/>
+        <p:cNvGrpSpPr/>
+        <p:nvPr/>
+      </p:nvGrpSpPr>
+      <p:grpSpPr>
+        <a:xfrm>
+          <a:off x="0" y="0"/>
+          <a:ext cx="0" cy="0"/>
+          <a:chOff x="0" y="0"/>
+          <a:chExt cx="0" cy="0"/>
+        </a:xfrm>
+      </p:grpSpPr>
+      <p:sp>
+        <p:nvSpPr>
+          <p:cNvPr id="2" name="Slide Image Placeholder 1"/>
+          <p:cNvSpPr>
+            <a:spLocks noGrp="1" noRot="1" noChangeAspect="1"/>
+          </p:cNvSpPr>
+          <p:nvPr>
+            <p:ph type="sldImg"/>
+          </p:nvPr>
+        </p:nvSpPr>
+        <p:spPr/>
+      </p:sp>
+      <p:sp>
+        <p:nvSpPr>
+          <p:cNvPr id="3" name="Notes Placeholder 2"/>
+          <p:cNvSpPr>
+            <a:spLocks noGrp="1"/>
+          </p:cNvSpPr>
+          <p:nvPr>
+            <p:ph type="body" idx="1"/>
+          </p:nvPr>
+        </p:nvSpPr>
+        <p:spPr/>
+        <p:txBody>
+          <a:bodyPr/>
+          <a:lstStyle/>
+          <a:p>
+            <a:endParaRPr lang="en-US" dirty="0"/>
+          </a:p>
+        </p:txBody>
+      </p:sp>
+      <p:sp>
+        <p:nvSpPr>
+          <p:cNvPr id="4" name="Slide Number Placeholder 3"/>
+          <p:cNvSpPr>
+            <a:spLocks noGrp="1"/>
+          </p:cNvSpPr>
+          <p:nvPr>
+            <p:ph type="sldNum" sz="quarter" idx="10"/>
+          </p:nvPr>
+        </p:nvSpPr>
+        <p:spPr/>
+        <p:txBody>
+          <a:bodyPr/>
+          <a:lstStyle/>
+          <a:p>
+            <a:fld id="{F7021451-1387-4CA6-816F-3879F97B5CBC}" type="slidenum">
+              <a:rPr lang="en-US"/>
+              <a:t>20</a:t>
+            </a:fld>
+            <a:endParaRPr lang="en-US"/>
+          </a:p>
+        </p:txBody>
+      </p:sp>
+    </p:spTree>
+    <p:extLst>
+      <p:ext uri="{BB962C8B-B14F-4D97-AF65-F5344CB8AC3E}">
+        <p14:creationId xmlns:p14="http://schemas.microsoft.com/office/powerpoint/2010/main" val="1024086991"/>
+      </p:ext>
+    </p:extLst>
+  </p:cSld>
+  <p:clrMapOvr>
+    <a:masterClrMapping/>
+  </p:clrMapOvr>
+</p:notes>
+</file>
+
+<file path=ppt/notesSlides/notesSlide21.xml><?xml version="1.0" encoding="utf-8"?>
+<p:notes xmlns:a="http://schemas.openxmlformats.org/drawingml/2006/main" xmlns:r="http://schemas.openxmlformats.org/officeDocument/2006/relationships" xmlns:p="http://schemas.openxmlformats.org/presentationml/2006/main">
+  <p:cSld>
+    <p:spTree>
+      <p:nvGrpSpPr>
         <p:cNvPr id="1" name="">
           <a:extLst>
             <a:ext uri="{FF2B5EF4-FFF2-40B4-BE49-F238E27FC236}">
@@ -7168,7 +7253,7 @@
                 <a:tabLst/>
                 <a:defRPr/>
               </a:pPr>
-              <a:t>20</a:t>
+              <a:t>21</a:t>
             </a:fld>
             <a:endParaRPr kumimoji="0" lang="en-US" sz="1800" b="0" i="0" u="none" strike="noStrike" kern="1200" cap="none" spc="0" normalizeH="0" baseline="0" noProof="0">
               <a:ln>
@@ -7200,7 +7285,7 @@
 </p:notes>
 </file>
 
-<file path=ppt/notesSlides/notesSlide21.xml><?xml version="1.0" encoding="utf-8"?>
+<file path=ppt/notesSlides/notesSlide22.xml><?xml version="1.0" encoding="utf-8"?>
 <p:notes xmlns:a="http://schemas.openxmlformats.org/drawingml/2006/main" xmlns:r="http://schemas.openxmlformats.org/officeDocument/2006/relationships" xmlns:p="http://schemas.openxmlformats.org/presentationml/2006/main">
   <p:cSld>
     <p:spTree>
@@ -7289,7 +7374,7 @@
           <a:p>
             <a:fld id="{F7021451-1387-4CA6-816F-3879F97B5CBC}" type="slidenum">
               <a:rPr lang="en-US"/>
-              <a:t>21</a:t>
+              <a:t>22</a:t>
             </a:fld>
             <a:endParaRPr lang="en-US"/>
           </a:p>
@@ -7308,7 +7393,7 @@
 </p:notes>
 </file>
 
-<file path=ppt/notesSlides/notesSlide22.xml><?xml version="1.0" encoding="utf-8"?>
+<file path=ppt/notesSlides/notesSlide23.xml><?xml version="1.0" encoding="utf-8"?>
 <p:notes xmlns:a="http://schemas.openxmlformats.org/drawingml/2006/main" xmlns:r="http://schemas.openxmlformats.org/officeDocument/2006/relationships" xmlns:p="http://schemas.openxmlformats.org/presentationml/2006/main">
   <p:cSld>
     <p:spTree>
@@ -7397,7 +7482,7 @@
           <a:p>
             <a:fld id="{F7021451-1387-4CA6-816F-3879F97B5CBC}" type="slidenum">
               <a:rPr lang="en-US"/>
-              <a:t>22</a:t>
+              <a:t>23</a:t>
             </a:fld>
             <a:endParaRPr lang="en-US"/>
           </a:p>
@@ -7416,7 +7501,7 @@
 </p:notes>
 </file>
 
-<file path=ppt/notesSlides/notesSlide23.xml><?xml version="1.0" encoding="utf-8"?>
+<file path=ppt/notesSlides/notesSlide24.xml><?xml version="1.0" encoding="utf-8"?>
 <p:notes xmlns:a="http://schemas.openxmlformats.org/drawingml/2006/main" xmlns:r="http://schemas.openxmlformats.org/officeDocument/2006/relationships" xmlns:p="http://schemas.openxmlformats.org/presentationml/2006/main">
   <p:cSld>
     <p:spTree>
@@ -7505,7 +7590,7 @@
           <a:p>
             <a:fld id="{F7021451-1387-4CA6-816F-3879F97B5CBC}" type="slidenum">
               <a:rPr lang="en-US"/>
-              <a:t>23</a:t>
+              <a:t>24</a:t>
             </a:fld>
             <a:endParaRPr lang="en-US"/>
           </a:p>
@@ -7524,7 +7609,7 @@
 </p:notes>
 </file>
 
-<file path=ppt/notesSlides/notesSlide24.xml><?xml version="1.0" encoding="utf-8"?>
+<file path=ppt/notesSlides/notesSlide25.xml><?xml version="1.0" encoding="utf-8"?>
 <p:notes xmlns:a="http://schemas.openxmlformats.org/drawingml/2006/main" xmlns:r="http://schemas.openxmlformats.org/officeDocument/2006/relationships" xmlns:p="http://schemas.openxmlformats.org/presentationml/2006/main">
   <p:cSld>
     <p:spTree>
@@ -7613,7 +7698,7 @@
           <a:p>
             <a:fld id="{F7021451-1387-4CA6-816F-3879F97B5CBC}" type="slidenum">
               <a:rPr lang="en-US"/>
-              <a:t>24</a:t>
+              <a:t>25</a:t>
             </a:fld>
             <a:endParaRPr lang="en-US"/>
           </a:p>
@@ -7805,6 +7890,114 @@
   <p:cSld>
     <p:spTree>
       <p:nvGrpSpPr>
+        <p:cNvPr id="1" name="">
+          <a:extLst>
+            <a:ext uri="{FF2B5EF4-FFF2-40B4-BE49-F238E27FC236}">
+              <a16:creationId xmlns:a16="http://schemas.microsoft.com/office/drawing/2014/main" id="{61A0505C-66A2-4B2C-B123-617913FC3E62}"/>
+            </a:ext>
+          </a:extLst>
+        </p:cNvPr>
+        <p:cNvGrpSpPr/>
+        <p:nvPr/>
+      </p:nvGrpSpPr>
+      <p:grpSpPr>
+        <a:xfrm>
+          <a:off x="0" y="0"/>
+          <a:ext cx="0" cy="0"/>
+          <a:chOff x="0" y="0"/>
+          <a:chExt cx="0" cy="0"/>
+        </a:xfrm>
+      </p:grpSpPr>
+      <p:sp>
+        <p:nvSpPr>
+          <p:cNvPr id="2" name="Slide Image Placeholder 1">
+            <a:extLst>
+              <a:ext uri="{FF2B5EF4-FFF2-40B4-BE49-F238E27FC236}">
+                <a16:creationId xmlns:a16="http://schemas.microsoft.com/office/drawing/2014/main" id="{6A3F7420-4633-113D-23B8-B239C3687EB6}"/>
+              </a:ext>
+            </a:extLst>
+          </p:cNvPr>
+          <p:cNvSpPr>
+            <a:spLocks noGrp="1" noRot="1" noChangeAspect="1"/>
+          </p:cNvSpPr>
+          <p:nvPr>
+            <p:ph type="sldImg"/>
+          </p:nvPr>
+        </p:nvSpPr>
+        <p:spPr/>
+      </p:sp>
+      <p:sp>
+        <p:nvSpPr>
+          <p:cNvPr id="3" name="Notes Placeholder 2">
+            <a:extLst>
+              <a:ext uri="{FF2B5EF4-FFF2-40B4-BE49-F238E27FC236}">
+                <a16:creationId xmlns:a16="http://schemas.microsoft.com/office/drawing/2014/main" id="{4450EC84-4735-1CD7-494F-0EB4CDEF614B}"/>
+              </a:ext>
+            </a:extLst>
+          </p:cNvPr>
+          <p:cNvSpPr>
+            <a:spLocks noGrp="1"/>
+          </p:cNvSpPr>
+          <p:nvPr>
+            <p:ph type="body" idx="1"/>
+          </p:nvPr>
+        </p:nvSpPr>
+        <p:spPr/>
+        <p:txBody>
+          <a:bodyPr/>
+          <a:lstStyle/>
+          <a:p>
+            <a:endParaRPr lang="en-US" dirty="0"/>
+          </a:p>
+        </p:txBody>
+      </p:sp>
+      <p:sp>
+        <p:nvSpPr>
+          <p:cNvPr id="4" name="Slide Number Placeholder 3">
+            <a:extLst>
+              <a:ext uri="{FF2B5EF4-FFF2-40B4-BE49-F238E27FC236}">
+                <a16:creationId xmlns:a16="http://schemas.microsoft.com/office/drawing/2014/main" id="{37D63884-63FE-582C-1716-F2F5C19B989E}"/>
+              </a:ext>
+            </a:extLst>
+          </p:cNvPr>
+          <p:cNvSpPr>
+            <a:spLocks noGrp="1"/>
+          </p:cNvSpPr>
+          <p:nvPr>
+            <p:ph type="sldNum" sz="quarter" idx="10"/>
+          </p:nvPr>
+        </p:nvSpPr>
+        <p:spPr/>
+        <p:txBody>
+          <a:bodyPr/>
+          <a:lstStyle/>
+          <a:p>
+            <a:fld id="{F7021451-1387-4CA6-816F-3879F97B5CBC}" type="slidenum">
+              <a:rPr lang="en-US"/>
+              <a:t>5</a:t>
+            </a:fld>
+            <a:endParaRPr lang="en-US"/>
+          </a:p>
+        </p:txBody>
+      </p:sp>
+    </p:spTree>
+    <p:extLst>
+      <p:ext uri="{BB962C8B-B14F-4D97-AF65-F5344CB8AC3E}">
+        <p14:creationId xmlns:p14="http://schemas.microsoft.com/office/powerpoint/2010/main" val="681922992"/>
+      </p:ext>
+    </p:extLst>
+  </p:cSld>
+  <p:clrMapOvr>
+    <a:masterClrMapping/>
+  </p:clrMapOvr>
+</p:notes>
+</file>
+
+<file path=ppt/notesSlides/notesSlide6.xml><?xml version="1.0" encoding="utf-8"?>
+<p:notes xmlns:a="http://schemas.openxmlformats.org/drawingml/2006/main" xmlns:r="http://schemas.openxmlformats.org/officeDocument/2006/relationships" xmlns:p="http://schemas.openxmlformats.org/presentationml/2006/main">
+  <p:cSld>
+    <p:spTree>
+      <p:nvGrpSpPr>
         <p:cNvPr id="1" name=""/>
         <p:cNvGrpSpPr/>
         <p:nvPr/>
@@ -7865,7 +8058,7 @@
           <a:p>
             <a:fld id="{F7021451-1387-4CA6-816F-3879F97B5CBC}" type="slidenum">
               <a:rPr lang="en-US"/>
-              <a:t>5</a:t>
+              <a:t>6</a:t>
             </a:fld>
             <a:endParaRPr lang="en-US"/>
           </a:p>
@@ -7884,7 +8077,7 @@
 </p:notes>
 </file>
 
-<file path=ppt/notesSlides/notesSlide6.xml><?xml version="1.0" encoding="utf-8"?>
+<file path=ppt/notesSlides/notesSlide7.xml><?xml version="1.0" encoding="utf-8"?>
 <p:notes xmlns:a="http://schemas.openxmlformats.org/drawingml/2006/main" xmlns:r="http://schemas.openxmlformats.org/officeDocument/2006/relationships" xmlns:p="http://schemas.openxmlformats.org/presentationml/2006/main">
   <p:cSld>
     <p:spTree>
@@ -7973,7 +8166,7 @@
           <a:p>
             <a:fld id="{F7021451-1387-4CA6-816F-3879F97B5CBC}" type="slidenum">
               <a:rPr lang="en-US"/>
-              <a:t>6</a:t>
+              <a:t>7</a:t>
             </a:fld>
             <a:endParaRPr lang="en-US"/>
           </a:p>
@@ -7992,7 +8185,7 @@
 </p:notes>
 </file>
 
-<file path=ppt/notesSlides/notesSlide7.xml><?xml version="1.0" encoding="utf-8"?>
+<file path=ppt/notesSlides/notesSlide8.xml><?xml version="1.0" encoding="utf-8"?>
 <p:notes xmlns:a="http://schemas.openxmlformats.org/drawingml/2006/main" xmlns:r="http://schemas.openxmlformats.org/officeDocument/2006/relationships" xmlns:p="http://schemas.openxmlformats.org/presentationml/2006/main">
   <p:cSld>
     <p:spTree>
@@ -8057,7 +8250,7 @@
           <a:p>
             <a:fld id="{F7021451-1387-4CA6-816F-3879F97B5CBC}" type="slidenum">
               <a:rPr lang="en-US"/>
-              <a:t>7</a:t>
+              <a:t>8</a:t>
             </a:fld>
             <a:endParaRPr lang="en-US"/>
           </a:p>
@@ -8076,7 +8269,7 @@
 </p:notes>
 </file>
 
-<file path=ppt/notesSlides/notesSlide8.xml><?xml version="1.0" encoding="utf-8"?>
+<file path=ppt/notesSlides/notesSlide9.xml><?xml version="1.0" encoding="utf-8"?>
 <p:notes xmlns:a="http://schemas.openxmlformats.org/drawingml/2006/main" xmlns:r="http://schemas.openxmlformats.org/officeDocument/2006/relationships" xmlns:p="http://schemas.openxmlformats.org/presentationml/2006/main">
   <p:cSld>
     <p:spTree>
@@ -8165,7 +8358,7 @@
           <a:p>
             <a:fld id="{F7021451-1387-4CA6-816F-3879F97B5CBC}" type="slidenum">
               <a:rPr lang="en-US"/>
-              <a:t>8</a:t>
+              <a:t>9</a:t>
             </a:fld>
             <a:endParaRPr lang="en-US"/>
           </a:p>
@@ -8175,90 +8368,6 @@
     <p:extLst>
       <p:ext uri="{BB962C8B-B14F-4D97-AF65-F5344CB8AC3E}">
         <p14:creationId xmlns:p14="http://schemas.microsoft.com/office/powerpoint/2010/main" val="3630224614"/>
-      </p:ext>
-    </p:extLst>
-  </p:cSld>
-  <p:clrMapOvr>
-    <a:masterClrMapping/>
-  </p:clrMapOvr>
-</p:notes>
-</file>
-
-<file path=ppt/notesSlides/notesSlide9.xml><?xml version="1.0" encoding="utf-8"?>
-<p:notes xmlns:a="http://schemas.openxmlformats.org/drawingml/2006/main" xmlns:r="http://schemas.openxmlformats.org/officeDocument/2006/relationships" xmlns:p="http://schemas.openxmlformats.org/presentationml/2006/main">
-  <p:cSld>
-    <p:spTree>
-      <p:nvGrpSpPr>
-        <p:cNvPr id="1" name=""/>
-        <p:cNvGrpSpPr/>
-        <p:nvPr/>
-      </p:nvGrpSpPr>
-      <p:grpSpPr>
-        <a:xfrm>
-          <a:off x="0" y="0"/>
-          <a:ext cx="0" cy="0"/>
-          <a:chOff x="0" y="0"/>
-          <a:chExt cx="0" cy="0"/>
-        </a:xfrm>
-      </p:grpSpPr>
-      <p:sp>
-        <p:nvSpPr>
-          <p:cNvPr id="2" name="Slide Image Placeholder 1"/>
-          <p:cNvSpPr>
-            <a:spLocks noGrp="1" noRot="1" noChangeAspect="1"/>
-          </p:cNvSpPr>
-          <p:nvPr>
-            <p:ph type="sldImg"/>
-          </p:nvPr>
-        </p:nvSpPr>
-        <p:spPr/>
-      </p:sp>
-      <p:sp>
-        <p:nvSpPr>
-          <p:cNvPr id="3" name="Notes Placeholder 2"/>
-          <p:cNvSpPr>
-            <a:spLocks noGrp="1"/>
-          </p:cNvSpPr>
-          <p:nvPr>
-            <p:ph type="body" idx="1"/>
-          </p:nvPr>
-        </p:nvSpPr>
-        <p:spPr/>
-        <p:txBody>
-          <a:bodyPr/>
-          <a:lstStyle/>
-          <a:p>
-            <a:endParaRPr lang="en-US" dirty="0"/>
-          </a:p>
-        </p:txBody>
-      </p:sp>
-      <p:sp>
-        <p:nvSpPr>
-          <p:cNvPr id="4" name="Slide Number Placeholder 3"/>
-          <p:cNvSpPr>
-            <a:spLocks noGrp="1"/>
-          </p:cNvSpPr>
-          <p:nvPr>
-            <p:ph type="sldNum" sz="quarter" idx="10"/>
-          </p:nvPr>
-        </p:nvSpPr>
-        <p:spPr/>
-        <p:txBody>
-          <a:bodyPr/>
-          <a:lstStyle/>
-          <a:p>
-            <a:fld id="{F7021451-1387-4CA6-816F-3879F97B5CBC}" type="slidenum">
-              <a:rPr lang="en-US"/>
-              <a:t>9</a:t>
-            </a:fld>
-            <a:endParaRPr lang="en-US"/>
-          </a:p>
-        </p:txBody>
-      </p:sp>
-    </p:spTree>
-    <p:extLst>
-      <p:ext uri="{BB962C8B-B14F-4D97-AF65-F5344CB8AC3E}">
-        <p14:creationId xmlns:p14="http://schemas.microsoft.com/office/powerpoint/2010/main" val="1024086991"/>
       </p:ext>
     </p:extLst>
   </p:cSld>
@@ -8913,6 +9022,525 @@
 
 <file path=ppt/slides/slide10.xml><?xml version="1.0" encoding="utf-8"?>
 <p:sld xmlns:a="http://schemas.openxmlformats.org/drawingml/2006/main" xmlns:r="http://schemas.openxmlformats.org/officeDocument/2006/relationships" xmlns:p="http://schemas.openxmlformats.org/presentationml/2006/main">
+  <p:cSld>
+    <p:spTree>
+      <p:nvGrpSpPr>
+        <p:cNvPr id="1" name=""/>
+        <p:cNvGrpSpPr/>
+        <p:nvPr/>
+      </p:nvGrpSpPr>
+      <p:grpSpPr>
+        <a:xfrm>
+          <a:off x="0" y="0"/>
+          <a:ext cx="0" cy="0"/>
+          <a:chOff x="0" y="0"/>
+          <a:chExt cx="0" cy="0"/>
+        </a:xfrm>
+      </p:grpSpPr>
+      <p:sp>
+        <p:nvSpPr>
+          <p:cNvPr id="2" name="Shape 0"/>
+          <p:cNvSpPr/>
+          <p:nvPr/>
+        </p:nvSpPr>
+        <p:spPr>
+          <a:xfrm>
+            <a:off x="0" y="0"/>
+            <a:ext cx="9144000" cy="777240"/>
+          </a:xfrm>
+          <a:prstGeom prst="rect">
+            <a:avLst/>
+          </a:prstGeom>
+          <a:solidFill>
+            <a:srgbClr val="00A896"/>
+          </a:solidFill>
+          <a:ln w="12700">
+            <a:solidFill>
+              <a:srgbClr val="00A896"/>
+            </a:solidFill>
+            <a:prstDash val="solid"/>
+          </a:ln>
+        </p:spPr>
+        <p:txBody>
+          <a:bodyPr/>
+          <a:lstStyle/>
+          <a:p>
+            <a:endParaRPr lang="en-US"/>
+          </a:p>
+        </p:txBody>
+      </p:sp>
+      <p:sp>
+        <p:nvSpPr>
+          <p:cNvPr id="3" name="Text 1"/>
+          <p:cNvSpPr/>
+          <p:nvPr/>
+        </p:nvSpPr>
+        <p:spPr>
+          <a:xfrm>
+            <a:off x="365760" y="0"/>
+            <a:ext cx="8412480" cy="777240"/>
+          </a:xfrm>
+          <a:prstGeom prst="rect">
+            <a:avLst/>
+          </a:prstGeom>
+          <a:noFill/>
+          <a:ln/>
+        </p:spPr>
+        <p:txBody>
+          <a:bodyPr wrap="square" lIns="0" tIns="0" rIns="0" bIns="0" rtlCol="0" anchor="ctr"/>
+          <a:lstStyle/>
+          <a:p>
+            <a:pPr marL="0" indent="0">
+              <a:buNone/>
+            </a:pPr>
+            <a:r>
+              <a:rPr lang="en-US" sz="2400" b="1" dirty="0">
+                <a:solidFill>
+                  <a:srgbClr val="FFFFFF"/>
+                </a:solidFill>
+                <a:latin typeface="Calibri" pitchFamily="34" charset="0"/>
+                <a:ea typeface="Calibri" pitchFamily="34" charset="-122"/>
+                <a:cs typeface="Calibri" pitchFamily="34" charset="-120"/>
+              </a:rPr>
+              <a:t>02  parallel_compute — Pseudo-code</a:t>
+            </a:r>
+            <a:endParaRPr lang="en-US" sz="2400" dirty="0"/>
+          </a:p>
+        </p:txBody>
+      </p:sp>
+      <p:sp>
+        <p:nvSpPr>
+          <p:cNvPr id="4" name="Shape 2"/>
+          <p:cNvSpPr/>
+          <p:nvPr/>
+        </p:nvSpPr>
+        <p:spPr>
+          <a:xfrm>
+            <a:off x="320040" y="914400"/>
+            <a:ext cx="8503920" cy="3977640"/>
+          </a:xfrm>
+          <a:prstGeom prst="rect">
+            <a:avLst/>
+          </a:prstGeom>
+          <a:solidFill>
+            <a:srgbClr val="111D2A"/>
+          </a:solidFill>
+          <a:ln w="12700">
+            <a:solidFill>
+              <a:srgbClr val="3D5166"/>
+            </a:solidFill>
+            <a:prstDash val="solid"/>
+          </a:ln>
+          <a:effectLst>
+            <a:outerShdw blurRad="101600" dist="38100" dir="8100000" algn="bl" rotWithShape="0">
+              <a:srgbClr val="000000">
+                <a:alpha val="30000"/>
+              </a:srgbClr>
+            </a:outerShdw>
+          </a:effectLst>
+        </p:spPr>
+        <p:txBody>
+          <a:bodyPr/>
+          <a:lstStyle/>
+          <a:p>
+            <a:endParaRPr lang="en-US"/>
+          </a:p>
+        </p:txBody>
+      </p:sp>
+      <p:sp>
+        <p:nvSpPr>
+          <p:cNvPr id="5" name="Text 3"/>
+          <p:cNvSpPr/>
+          <p:nvPr/>
+        </p:nvSpPr>
+        <p:spPr>
+          <a:xfrm>
+            <a:off x="502920" y="1005840"/>
+            <a:ext cx="8229600" cy="3749040"/>
+          </a:xfrm>
+          <a:prstGeom prst="rect">
+            <a:avLst/>
+          </a:prstGeom>
+          <a:noFill/>
+          <a:ln/>
+        </p:spPr>
+        <p:txBody>
+          <a:bodyPr wrap="square" rtlCol="0" anchor="ctr"/>
+          <a:lstStyle/>
+          <a:p>
+            <a:pPr marL="0" indent="0" algn="l">
+              <a:buNone/>
+            </a:pPr>
+            <a:r>
+              <a:rPr lang="en-US" sz="1150" b="1" dirty="0">
+                <a:solidFill>
+                  <a:srgbClr val="FFB347"/>
+                </a:solidFill>
+                <a:latin typeface="Consolas" pitchFamily="34" charset="0"/>
+                <a:ea typeface="Consolas" pitchFamily="34" charset="-122"/>
+                <a:cs typeface="Consolas" pitchFamily="34" charset="-120"/>
+              </a:rPr>
+              <a:t>FUNCTION </a:t>
+            </a:r>
+            <a:r>
+              <a:rPr lang="en-US" sz="1150" b="1" dirty="0">
+                <a:solidFill>
+                  <a:srgbClr val="00C9A7"/>
+                </a:solidFill>
+                <a:latin typeface="Consolas" pitchFamily="34" charset="0"/>
+                <a:ea typeface="Consolas" pitchFamily="34" charset="-122"/>
+                <a:cs typeface="Consolas" pitchFamily="34" charset="-120"/>
+              </a:rPr>
+              <a:t>parallel_compute</a:t>
+            </a:r>
+            <a:r>
+              <a:rPr lang="en-US" sz="1150" dirty="0">
+                <a:solidFill>
+                  <a:srgbClr val="FFFFFF"/>
+                </a:solidFill>
+                <a:latin typeface="Consolas" pitchFamily="34" charset="0"/>
+                <a:ea typeface="Consolas" pitchFamily="34" charset="-122"/>
+                <a:cs typeface="Consolas" pitchFamily="34" charset="-120"/>
+              </a:rPr>
+              <a:t>(filepath, n_proc, f):
+    nums  ← </a:t>
+            </a:r>
+            <a:r>
+              <a:rPr lang="en-US" sz="1150" dirty="0">
+                <a:solidFill>
+                  <a:srgbClr val="00C9A7"/>
+                </a:solidFill>
+                <a:latin typeface="Consolas" pitchFamily="34" charset="0"/>
+                <a:ea typeface="Consolas" pitchFamily="34" charset="-122"/>
+                <a:cs typeface="Consolas" pitchFamily="34" charset="-120"/>
+              </a:rPr>
+              <a:t>read_numbers</a:t>
+            </a:r>
+            <a:r>
+              <a:rPr lang="en-US" sz="1150" dirty="0">
+                <a:solidFill>
+                  <a:srgbClr val="FFFFFF"/>
+                </a:solidFill>
+                <a:latin typeface="Consolas" pitchFamily="34" charset="0"/>
+                <a:ea typeface="Consolas" pitchFamily="34" charset="-122"/>
+                <a:cs typeface="Consolas" pitchFamily="34" charset="-120"/>
+              </a:rPr>
+              <a:t>(filepath)
+    chunk ← len(nums) / n_proc
+    remainder ← len(nums) % n_proc
+</a:t>
+            </a:r>
+            <a:r>
+              <a:rPr lang="en-US" sz="1150" dirty="0">
+                <a:solidFill>
+                  <a:srgbClr val="FFB347"/>
+                </a:solidFill>
+                <a:latin typeface="Consolas" pitchFamily="34" charset="0"/>
+                <a:ea typeface="Consolas" pitchFamily="34" charset="-122"/>
+                <a:cs typeface="Consolas" pitchFamily="34" charset="-120"/>
+              </a:rPr>
+              <a:t>    FOR </a:t>
+            </a:r>
+            <a:r>
+              <a:rPr lang="en-US" sz="1150" dirty="0">
+                <a:solidFill>
+                  <a:srgbClr val="FFFFFF"/>
+                </a:solidFill>
+                <a:latin typeface="Consolas" pitchFamily="34" charset="0"/>
+                <a:ea typeface="Consolas" pitchFamily="34" charset="-122"/>
+                <a:cs typeface="Consolas" pitchFamily="34" charset="-120"/>
+              </a:rPr>
+              <a:t>i = 0 </a:t>
+            </a:r>
+            <a:r>
+              <a:rPr lang="en-US" sz="1150" dirty="0">
+                <a:solidFill>
+                  <a:srgbClr val="FFB347"/>
+                </a:solidFill>
+                <a:latin typeface="Consolas" pitchFamily="34" charset="0"/>
+                <a:ea typeface="Consolas" pitchFamily="34" charset="-122"/>
+                <a:cs typeface="Consolas" pitchFamily="34" charset="-120"/>
+              </a:rPr>
+              <a:t>TO </a:t>
+            </a:r>
+            <a:r>
+              <a:rPr lang="en-US" sz="1150" dirty="0">
+                <a:solidFill>
+                  <a:srgbClr val="FFFFFF"/>
+                </a:solidFill>
+                <a:latin typeface="Consolas" pitchFamily="34" charset="0"/>
+                <a:ea typeface="Consolas" pitchFamily="34" charset="-122"/>
+                <a:cs typeface="Consolas" pitchFamily="34" charset="-120"/>
+              </a:rPr>
+              <a:t>n_proc - 1 :
+</a:t>
+            </a:r>
+            <a:r>
+              <a:rPr lang="en-US" sz="1150" dirty="0">
+                <a:solidFill>
+                  <a:srgbClr val="8BA3B8"/>
+                </a:solidFill>
+                <a:latin typeface="Consolas" pitchFamily="34" charset="0"/>
+                <a:ea typeface="Consolas" pitchFamily="34" charset="-122"/>
+                <a:cs typeface="Consolas" pitchFamily="34" charset="-120"/>
+              </a:rPr>
+              <a:t>        create ctrl_pipe[i], res_pipe[i]
+        fork child i
+</a:t>
+            </a:r>
+            <a:r>
+              <a:rPr lang="en-US" sz="1150" dirty="0">
+                <a:solidFill>
+                  <a:srgbClr val="FFB347"/>
+                </a:solidFill>
+                <a:latin typeface="Consolas" pitchFamily="34" charset="0"/>
+                <a:ea typeface="Consolas" pitchFamily="34" charset="-122"/>
+                <a:cs typeface="Consolas" pitchFamily="34" charset="-120"/>
+              </a:rPr>
+              <a:t>        IF </a:t>
+            </a:r>
+            <a:r>
+              <a:rPr lang="en-US" sz="1150" dirty="0">
+                <a:solidFill>
+                  <a:srgbClr val="FFFFFF"/>
+                </a:solidFill>
+                <a:latin typeface="Consolas" pitchFamily="34" charset="0"/>
+                <a:ea typeface="Consolas" pitchFamily="34" charset="-122"/>
+                <a:cs typeface="Consolas" pitchFamily="34" charset="-120"/>
+              </a:rPr>
+              <a:t>child :
+            start, end ← </a:t>
+            </a:r>
+            <a:r>
+              <a:rPr lang="en-US" sz="1150" dirty="0">
+                <a:solidFill>
+                  <a:srgbClr val="00C9A7"/>
+                </a:solidFill>
+                <a:latin typeface="Consolas" pitchFamily="34" charset="0"/>
+                <a:ea typeface="Consolas" pitchFamily="34" charset="-122"/>
+                <a:cs typeface="Consolas" pitchFamily="34" charset="-120"/>
+              </a:rPr>
+              <a:t>read</a:t>
+            </a:r>
+            <a:r>
+              <a:rPr lang="en-US" sz="1150" dirty="0">
+                <a:solidFill>
+                  <a:srgbClr val="8BA3B8"/>
+                </a:solidFill>
+                <a:latin typeface="Consolas" pitchFamily="34" charset="0"/>
+                <a:ea typeface="Consolas" pitchFamily="34" charset="-122"/>
+                <a:cs typeface="Consolas" pitchFamily="34" charset="-120"/>
+              </a:rPr>
+              <a:t>(ctrl_pipe[i])      // receive slice bounds
+</a:t>
+            </a:r>
+            <a:r>
+              <a:rPr lang="en-US" sz="1150" dirty="0">
+                <a:solidFill>
+                  <a:srgbClr val="FFFFFF"/>
+                </a:solidFill>
+                <a:latin typeface="Consolas" pitchFamily="34" charset="0"/>
+                <a:ea typeface="Consolas" pitchFamily="34" charset="-122"/>
+                <a:cs typeface="Consolas" pitchFamily="34" charset="-120"/>
+              </a:rPr>
+              <a:t>            partial ← sequential_compute(nums[start..end], f)
+            </a:t>
+            </a:r>
+            <a:r>
+              <a:rPr lang="en-US" sz="1150" dirty="0">
+                <a:solidFill>
+                  <a:srgbClr val="00C9A7"/>
+                </a:solidFill>
+                <a:latin typeface="Consolas" pitchFamily="34" charset="0"/>
+                <a:ea typeface="Consolas" pitchFamily="34" charset="-122"/>
+                <a:cs typeface="Consolas" pitchFamily="34" charset="-120"/>
+              </a:rPr>
+              <a:t>write</a:t>
+            </a:r>
+            <a:r>
+              <a:rPr lang="en-US" sz="1150" dirty="0">
+                <a:solidFill>
+                  <a:srgbClr val="FFFFFF"/>
+                </a:solidFill>
+                <a:latin typeface="Consolas" pitchFamily="34" charset="0"/>
+                <a:ea typeface="Consolas" pitchFamily="34" charset="-122"/>
+                <a:cs typeface="Consolas" pitchFamily="34" charset="-120"/>
+              </a:rPr>
+              <a:t>(res_pipe[i], partial) ; exit()
+</a:t>
+            </a:r>
+            <a:r>
+              <a:rPr lang="en-US" sz="1150" dirty="0">
+                <a:solidFill>
+                  <a:srgbClr val="FFB347"/>
+                </a:solidFill>
+                <a:latin typeface="Consolas" pitchFamily="34" charset="0"/>
+                <a:ea typeface="Consolas" pitchFamily="34" charset="-122"/>
+                <a:cs typeface="Consolas" pitchFamily="34" charset="-120"/>
+              </a:rPr>
+              <a:t>        ELSE </a:t>
+            </a:r>
+            <a:r>
+              <a:rPr lang="en-US" sz="1150" dirty="0">
+                <a:solidFill>
+                  <a:srgbClr val="FFFFFF"/>
+                </a:solidFill>
+                <a:latin typeface="Consolas" pitchFamily="34" charset="0"/>
+                <a:ea typeface="Consolas" pitchFamily="34" charset="-122"/>
+                <a:cs typeface="Consolas" pitchFamily="34" charset="-120"/>
+              </a:rPr>
+              <a:t>(parent) : </a:t>
+            </a:r>
+            <a:r>
+              <a:rPr lang="en-US" sz="1150" dirty="0">
+                <a:solidFill>
+                  <a:srgbClr val="00C9A7"/>
+                </a:solidFill>
+                <a:latin typeface="Consolas" pitchFamily="34" charset="0"/>
+                <a:ea typeface="Consolas" pitchFamily="34" charset="-122"/>
+                <a:cs typeface="Consolas" pitchFamily="34" charset="-120"/>
+              </a:rPr>
+              <a:t>write</a:t>
+            </a:r>
+            <a:r>
+              <a:rPr lang="en-US" sz="1150" dirty="0">
+                <a:solidFill>
+                  <a:srgbClr val="FFFFFF"/>
+                </a:solidFill>
+                <a:latin typeface="Consolas" pitchFamily="34" charset="0"/>
+                <a:ea typeface="Consolas" pitchFamily="34" charset="-122"/>
+                <a:cs typeface="Consolas" pitchFamily="34" charset="-120"/>
+              </a:rPr>
+              <a:t>(ctrl_pipe[i], start, end)
+</a:t>
+            </a:r>
+            <a:r>
+              <a:rPr lang="en-US" sz="1150" dirty="0">
+                <a:solidFill>
+                  <a:srgbClr val="00C9A7"/>
+                </a:solidFill>
+                <a:latin typeface="Consolas" pitchFamily="34" charset="0"/>
+                <a:ea typeface="Consolas" pitchFamily="34" charset="-122"/>
+                <a:cs typeface="Consolas" pitchFamily="34" charset="-120"/>
+              </a:rPr>
+              <a:t>    wait</a:t>
+            </a:r>
+            <a:r>
+              <a:rPr lang="en-US" sz="1150" dirty="0">
+                <a:solidFill>
+                  <a:srgbClr val="FFFFFF"/>
+                </a:solidFill>
+                <a:latin typeface="Consolas" pitchFamily="34" charset="0"/>
+                <a:ea typeface="Consolas" pitchFamily="34" charset="-122"/>
+                <a:cs typeface="Consolas" pitchFamily="34" charset="-120"/>
+              </a:rPr>
+              <a:t>() for all children
+    result ← </a:t>
+            </a:r>
+            <a:r>
+              <a:rPr lang="en-US" sz="1150" dirty="0">
+                <a:solidFill>
+                  <a:srgbClr val="00C9A7"/>
+                </a:solidFill>
+                <a:latin typeface="Consolas" pitchFamily="34" charset="0"/>
+                <a:ea typeface="Consolas" pitchFamily="34" charset="-122"/>
+                <a:cs typeface="Consolas" pitchFamily="34" charset="-120"/>
+              </a:rPr>
+              <a:t>read</a:t>
+            </a:r>
+            <a:r>
+              <a:rPr lang="en-US" sz="1150" dirty="0">
+                <a:solidFill>
+                  <a:srgbClr val="FFFFFF"/>
+                </a:solidFill>
+                <a:latin typeface="Consolas" pitchFamily="34" charset="0"/>
+                <a:ea typeface="Consolas" pitchFamily="34" charset="-122"/>
+                <a:cs typeface="Consolas" pitchFamily="34" charset="-120"/>
+              </a:rPr>
+              <a:t>(res_pipe[0])
+</a:t>
+            </a:r>
+            <a:r>
+              <a:rPr lang="en-US" sz="1150" dirty="0">
+                <a:solidFill>
+                  <a:srgbClr val="FFB347"/>
+                </a:solidFill>
+                <a:latin typeface="Consolas" pitchFamily="34" charset="0"/>
+                <a:ea typeface="Consolas" pitchFamily="34" charset="-122"/>
+                <a:cs typeface="Consolas" pitchFamily="34" charset="-120"/>
+              </a:rPr>
+              <a:t>    FOR </a:t>
+            </a:r>
+            <a:r>
+              <a:rPr lang="en-US" sz="1150" dirty="0">
+                <a:solidFill>
+                  <a:srgbClr val="FFFFFF"/>
+                </a:solidFill>
+                <a:latin typeface="Consolas" pitchFamily="34" charset="0"/>
+                <a:ea typeface="Consolas" pitchFamily="34" charset="-122"/>
+                <a:cs typeface="Consolas" pitchFamily="34" charset="-120"/>
+              </a:rPr>
+              <a:t>i = 1 TO n_proc-1 : result ← f(result, </a:t>
+            </a:r>
+            <a:r>
+              <a:rPr lang="en-US" sz="1150" dirty="0">
+                <a:solidFill>
+                  <a:srgbClr val="00C9A7"/>
+                </a:solidFill>
+                <a:latin typeface="Consolas" pitchFamily="34" charset="0"/>
+                <a:ea typeface="Consolas" pitchFamily="34" charset="-122"/>
+                <a:cs typeface="Consolas" pitchFamily="34" charset="-120"/>
+              </a:rPr>
+              <a:t>read</a:t>
+            </a:r>
+            <a:r>
+              <a:rPr lang="en-US" sz="1150" dirty="0">
+                <a:solidFill>
+                  <a:srgbClr val="FFFFFF"/>
+                </a:solidFill>
+                <a:latin typeface="Consolas" pitchFamily="34" charset="0"/>
+                <a:ea typeface="Consolas" pitchFamily="34" charset="-122"/>
+                <a:cs typeface="Consolas" pitchFamily="34" charset="-120"/>
+              </a:rPr>
+              <a:t>(res_pipe[i]))
+</a:t>
+            </a:r>
+            <a:r>
+              <a:rPr lang="en-US" sz="1150" dirty="0">
+                <a:solidFill>
+                  <a:srgbClr val="FFB347"/>
+                </a:solidFill>
+                <a:latin typeface="Consolas" pitchFamily="34" charset="0"/>
+                <a:ea typeface="Consolas" pitchFamily="34" charset="-122"/>
+                <a:cs typeface="Consolas" pitchFamily="34" charset="-120"/>
+              </a:rPr>
+              <a:t>    RETURN </a:t>
+            </a:r>
+            <a:r>
+              <a:rPr lang="en-US" sz="1150" dirty="0">
+                <a:solidFill>
+                  <a:srgbClr val="4CAF86"/>
+                </a:solidFill>
+                <a:latin typeface="Consolas" pitchFamily="34" charset="0"/>
+                <a:ea typeface="Consolas" pitchFamily="34" charset="-122"/>
+                <a:cs typeface="Consolas" pitchFamily="34" charset="-120"/>
+              </a:rPr>
+              <a:t>result</a:t>
+            </a:r>
+            <a:endParaRPr lang="en-US" sz="1150" dirty="0"/>
+          </a:p>
+        </p:txBody>
+      </p:sp>
+    </p:spTree>
+  </p:cSld>
+  <p:clrMapOvr>
+    <a:masterClrMapping/>
+  </p:clrMapOvr>
+</p:sld>
+</file>
+
+<file path=ppt/slides/slide11.xml><?xml version="1.0" encoding="utf-8"?>
+<p:sld xmlns:a="http://schemas.openxmlformats.org/drawingml/2006/main" xmlns:r="http://schemas.openxmlformats.org/officeDocument/2006/relationships" xmlns:p="http://schemas.openxmlformats.org/presentationml/2006/main">
   <p:cSld name="Slide 6">
     <p:bg>
       <p:bgPr>
@@ -10090,7 +10718,7 @@
 </p:sld>
 </file>
 
-<file path=ppt/slides/slide11.xml><?xml version="1.0" encoding="utf-8"?>
+<file path=ppt/slides/slide12.xml><?xml version="1.0" encoding="utf-8"?>
 <p:sld xmlns:a="http://schemas.openxmlformats.org/drawingml/2006/main" xmlns:r="http://schemas.openxmlformats.org/officeDocument/2006/relationships" xmlns:p="http://schemas.openxmlformats.org/presentationml/2006/main">
   <p:cSld>
     <p:bg>
@@ -10277,7 +10905,7 @@
 </p:sld>
 </file>
 
-<file path=ppt/slides/slide12.xml><?xml version="1.0" encoding="utf-8"?>
+<file path=ppt/slides/slide13.xml><?xml version="1.0" encoding="utf-8"?>
 <p:sld xmlns:a="http://schemas.openxmlformats.org/drawingml/2006/main" xmlns:r="http://schemas.openxmlformats.org/officeDocument/2006/relationships" xmlns:p="http://schemas.openxmlformats.org/presentationml/2006/main">
   <p:cSld>
     <p:bg>
@@ -10434,7 +11062,7 @@
 </p:sld>
 </file>
 
-<file path=ppt/slides/slide13.xml><?xml version="1.0" encoding="utf-8"?>
+<file path=ppt/slides/slide14.xml><?xml version="1.0" encoding="utf-8"?>
 <p:sld xmlns:a="http://schemas.openxmlformats.org/drawingml/2006/main" xmlns:r="http://schemas.openxmlformats.org/officeDocument/2006/relationships" xmlns:p="http://schemas.openxmlformats.org/presentationml/2006/main">
   <p:cSld>
     <p:bg>
@@ -10591,7 +11219,7 @@
 </p:sld>
 </file>
 
-<file path=ppt/slides/slide14.xml><?xml version="1.0" encoding="utf-8"?>
+<file path=ppt/slides/slide15.xml><?xml version="1.0" encoding="utf-8"?>
 <p:sld xmlns:a="http://schemas.openxmlformats.org/drawingml/2006/main" xmlns:r="http://schemas.openxmlformats.org/officeDocument/2006/relationships" xmlns:p="http://schemas.openxmlformats.org/presentationml/2006/main">
   <p:cSld>
     <p:bg>
@@ -10748,7 +11376,7 @@
 </p:sld>
 </file>
 
-<file path=ppt/slides/slide15.xml><?xml version="1.0" encoding="utf-8"?>
+<file path=ppt/slides/slide16.xml><?xml version="1.0" encoding="utf-8"?>
 <p:sld xmlns:a="http://schemas.openxmlformats.org/drawingml/2006/main" xmlns:r="http://schemas.openxmlformats.org/officeDocument/2006/relationships" xmlns:p="http://schemas.openxmlformats.org/presentationml/2006/main">
   <p:cSld>
     <p:bg>
@@ -10905,7 +11533,7 @@
 </p:sld>
 </file>
 
-<file path=ppt/slides/slide16.xml><?xml version="1.0" encoding="utf-8"?>
+<file path=ppt/slides/slide17.xml><?xml version="1.0" encoding="utf-8"?>
 <p:sld xmlns:a="http://schemas.openxmlformats.org/drawingml/2006/main" xmlns:r="http://schemas.openxmlformats.org/officeDocument/2006/relationships" xmlns:p="http://schemas.openxmlformats.org/presentationml/2006/main">
   <p:cSld name="Slide 7">
     <p:bg>
@@ -12345,7 +12973,7 @@
 </p:sld>
 </file>
 
-<file path=ppt/slides/slide17.xml><?xml version="1.0" encoding="utf-8"?>
+<file path=ppt/slides/slide18.xml><?xml version="1.0" encoding="utf-8"?>
 <p:sld xmlns:a="http://schemas.openxmlformats.org/drawingml/2006/main" xmlns:r="http://schemas.openxmlformats.org/officeDocument/2006/relationships" xmlns:p="http://schemas.openxmlformats.org/presentationml/2006/main">
   <p:cSld>
     <p:bg>
@@ -12502,7 +13130,7 @@
 </p:sld>
 </file>
 
-<file path=ppt/slides/slide18.xml><?xml version="1.0" encoding="utf-8"?>
+<file path=ppt/slides/slide19.xml><?xml version="1.0" encoding="utf-8"?>
 <p:sld xmlns:a="http://schemas.openxmlformats.org/drawingml/2006/main" xmlns:r="http://schemas.openxmlformats.org/officeDocument/2006/relationships" xmlns:p="http://schemas.openxmlformats.org/presentationml/2006/main">
   <p:cSld>
     <p:spTree>
@@ -12621,7 +13249,760 @@
 </p:sld>
 </file>
 
-<file path=ppt/slides/slide19.xml><?xml version="1.0" encoding="utf-8"?>
+<file path=ppt/slides/slide2.xml><?xml version="1.0" encoding="utf-8"?>
+<p:sld xmlns:a="http://schemas.openxmlformats.org/drawingml/2006/main" xmlns:r="http://schemas.openxmlformats.org/officeDocument/2006/relationships" xmlns:p="http://schemas.openxmlformats.org/presentationml/2006/main">
+  <p:cSld name="Slide 2">
+    <p:bg>
+      <p:bgPr>
+        <a:solidFill>
+          <a:srgbClr val="F0F4FF"/>
+        </a:solidFill>
+        <a:effectLst/>
+      </p:bgPr>
+    </p:bg>
+    <p:spTree>
+      <p:nvGrpSpPr>
+        <p:cNvPr id="1" name=""/>
+        <p:cNvGrpSpPr/>
+        <p:nvPr/>
+      </p:nvGrpSpPr>
+      <p:grpSpPr>
+        <a:xfrm>
+          <a:off x="0" y="0"/>
+          <a:ext cx="0" cy="0"/>
+          <a:chOff x="0" y="0"/>
+          <a:chExt cx="0" cy="0"/>
+        </a:xfrm>
+      </p:grpSpPr>
+      <p:sp>
+        <p:nvSpPr>
+          <p:cNvPr id="2" name="Shape 0"/>
+          <p:cNvSpPr/>
+          <p:nvPr/>
+        </p:nvSpPr>
+        <p:spPr>
+          <a:xfrm>
+            <a:off x="0" y="0"/>
+            <a:ext cx="9144000" cy="868680"/>
+          </a:xfrm>
+          <a:prstGeom prst="rect">
+            <a:avLst/>
+          </a:prstGeom>
+          <a:solidFill>
+            <a:srgbClr val="1A1F36"/>
+          </a:solidFill>
+          <a:ln w="12700">
+            <a:solidFill>
+              <a:srgbClr val="1A1F36"/>
+            </a:solidFill>
+            <a:prstDash val="solid"/>
+          </a:ln>
+        </p:spPr>
+        <p:txBody>
+          <a:bodyPr/>
+          <a:lstStyle/>
+          <a:p>
+            <a:endParaRPr lang="en-US"/>
+          </a:p>
+        </p:txBody>
+      </p:sp>
+      <p:sp>
+        <p:nvSpPr>
+          <p:cNvPr id="3" name="Text 1"/>
+          <p:cNvSpPr/>
+          <p:nvPr/>
+        </p:nvSpPr>
+        <p:spPr>
+          <a:xfrm>
+            <a:off x="365760" y="109728"/>
+            <a:ext cx="8229600" cy="640080"/>
+          </a:xfrm>
+          <a:prstGeom prst="rect">
+            <a:avLst/>
+          </a:prstGeom>
+          <a:noFill/>
+          <a:ln/>
+        </p:spPr>
+        <p:txBody>
+          <a:bodyPr wrap="square" lIns="0" tIns="0" rIns="0" bIns="0" rtlCol="0" anchor="ctr"/>
+          <a:lstStyle/>
+          <a:p>
+            <a:pPr marL="0" indent="0">
+              <a:buNone/>
+            </a:pPr>
+            <a:r>
+              <a:rPr lang="en-US" sz="2600" b="1" dirty="0">
+                <a:solidFill>
+                  <a:srgbClr val="FFFFFF"/>
+                </a:solidFill>
+                <a:latin typeface="Calibri" pitchFamily="34" charset="0"/>
+                <a:ea typeface="Calibri" pitchFamily="34" charset="-122"/>
+                <a:cs typeface="Calibri" pitchFamily="34" charset="-120"/>
+              </a:rPr>
+              <a:t>Team Roles</a:t>
+            </a:r>
+            <a:endParaRPr lang="en-US" sz="2600" dirty="0"/>
+          </a:p>
+        </p:txBody>
+      </p:sp>
+      <p:sp>
+        <p:nvSpPr>
+          <p:cNvPr id="4" name="Shape 2"/>
+          <p:cNvSpPr/>
+          <p:nvPr/>
+        </p:nvSpPr>
+        <p:spPr>
+          <a:xfrm>
+            <a:off x="274320" y="1005840"/>
+            <a:ext cx="4023360" cy="3749040"/>
+          </a:xfrm>
+          <a:prstGeom prst="rect">
+            <a:avLst/>
+          </a:prstGeom>
+          <a:solidFill>
+            <a:srgbClr val="FFFFFF"/>
+          </a:solidFill>
+          <a:ln w="12700">
+            <a:solidFill>
+              <a:srgbClr val="E0E6F8"/>
+            </a:solidFill>
+            <a:prstDash val="solid"/>
+          </a:ln>
+          <a:effectLst>
+            <a:outerShdw blurRad="101600" dist="38100" dir="8100000" algn="bl" rotWithShape="0">
+              <a:srgbClr val="000000">
+                <a:alpha val="18000"/>
+              </a:srgbClr>
+            </a:outerShdw>
+          </a:effectLst>
+        </p:spPr>
+        <p:txBody>
+          <a:bodyPr/>
+          <a:lstStyle/>
+          <a:p>
+            <a:endParaRPr lang="en-US"/>
+          </a:p>
+        </p:txBody>
+      </p:sp>
+      <p:sp>
+        <p:nvSpPr>
+          <p:cNvPr id="5" name="Shape 3"/>
+          <p:cNvSpPr/>
+          <p:nvPr/>
+        </p:nvSpPr>
+        <p:spPr>
+          <a:xfrm>
+            <a:off x="274320" y="1005840"/>
+            <a:ext cx="4023360" cy="109728"/>
+          </a:xfrm>
+          <a:prstGeom prst="rect">
+            <a:avLst/>
+          </a:prstGeom>
+          <a:solidFill>
+            <a:srgbClr val="4F8EF7"/>
+          </a:solidFill>
+          <a:ln w="12700">
+            <a:solidFill>
+              <a:srgbClr val="4F8EF7"/>
+            </a:solidFill>
+            <a:prstDash val="solid"/>
+          </a:ln>
+        </p:spPr>
+        <p:txBody>
+          <a:bodyPr/>
+          <a:lstStyle/>
+          <a:p>
+            <a:endParaRPr lang="en-US"/>
+          </a:p>
+        </p:txBody>
+      </p:sp>
+      <p:sp>
+        <p:nvSpPr>
+          <p:cNvPr id="6" name="Text 4"/>
+          <p:cNvSpPr/>
+          <p:nvPr/>
+        </p:nvSpPr>
+        <p:spPr>
+          <a:xfrm>
+            <a:off x="438912" y="1097280"/>
+            <a:ext cx="3657600" cy="320040"/>
+          </a:xfrm>
+          <a:prstGeom prst="rect">
+            <a:avLst/>
+          </a:prstGeom>
+          <a:noFill/>
+          <a:ln/>
+        </p:spPr>
+        <p:txBody>
+          <a:bodyPr wrap="square" lIns="0" tIns="0" rIns="0" bIns="0" rtlCol="0" anchor="ctr"/>
+          <a:lstStyle/>
+          <a:p>
+            <a:pPr marL="0" indent="0">
+              <a:buNone/>
+            </a:pPr>
+            <a:r>
+              <a:rPr lang="en-US" sz="1000" b="1" dirty="0">
+                <a:solidFill>
+                  <a:srgbClr val="4F8EF7"/>
+                </a:solidFill>
+                <a:latin typeface="Calibri" pitchFamily="34" charset="0"/>
+                <a:ea typeface="Calibri" pitchFamily="34" charset="-122"/>
+                <a:cs typeface="Calibri" pitchFamily="34" charset="-120"/>
+              </a:rPr>
+              <a:t>MEMBER 1 </a:t>
+            </a:r>
+            <a:endParaRPr lang="en-US" sz="1000" dirty="0"/>
+          </a:p>
+        </p:txBody>
+      </p:sp>
+      <p:sp>
+        <p:nvSpPr>
+          <p:cNvPr id="7" name="Text 5"/>
+          <p:cNvSpPr/>
+          <p:nvPr/>
+        </p:nvSpPr>
+        <p:spPr>
+          <a:xfrm>
+            <a:off x="438912" y="1417320"/>
+            <a:ext cx="3657600" cy="411480"/>
+          </a:xfrm>
+          <a:prstGeom prst="rect">
+            <a:avLst/>
+          </a:prstGeom>
+          <a:noFill/>
+          <a:ln/>
+        </p:spPr>
+        <p:txBody>
+          <a:bodyPr wrap="square" lIns="0" tIns="0" rIns="0" bIns="0" rtlCol="0" anchor="ctr"/>
+          <a:lstStyle/>
+          <a:p>
+            <a:pPr marL="0" indent="0">
+              <a:buNone/>
+            </a:pPr>
+            <a:r>
+              <a:rPr lang="en-US" sz="1800" b="1" dirty="0">
+                <a:solidFill>
+                  <a:srgbClr val="1A1F36"/>
+                </a:solidFill>
+                <a:latin typeface="Calibri" pitchFamily="34" charset="0"/>
+                <a:ea typeface="Calibri" pitchFamily="34" charset="-122"/>
+                <a:cs typeface="Calibri" pitchFamily="34" charset="-120"/>
+              </a:rPr>
+              <a:t>Sama Emad Abu Zahra</a:t>
+            </a:r>
+            <a:endParaRPr lang="en-US" sz="1800" dirty="0"/>
+          </a:p>
+        </p:txBody>
+      </p:sp>
+      <p:sp>
+        <p:nvSpPr>
+          <p:cNvPr id="8" name="Shape 6"/>
+          <p:cNvSpPr/>
+          <p:nvPr/>
+        </p:nvSpPr>
+        <p:spPr>
+          <a:xfrm>
+            <a:off x="438912" y="1874520"/>
+            <a:ext cx="3657600" cy="0"/>
+          </a:xfrm>
+          <a:prstGeom prst="line">
+            <a:avLst/>
+          </a:prstGeom>
+          <a:noFill/>
+          <a:ln w="12700">
+            <a:solidFill>
+              <a:srgbClr val="E0E6F8"/>
+            </a:solidFill>
+            <a:prstDash val="solid"/>
+          </a:ln>
+        </p:spPr>
+        <p:txBody>
+          <a:bodyPr/>
+          <a:lstStyle/>
+          <a:p>
+            <a:endParaRPr lang="en-US"/>
+          </a:p>
+        </p:txBody>
+      </p:sp>
+      <p:sp>
+        <p:nvSpPr>
+          <p:cNvPr id="9" name="Text 7"/>
+          <p:cNvSpPr/>
+          <p:nvPr/>
+        </p:nvSpPr>
+        <p:spPr>
+          <a:xfrm>
+            <a:off x="438912" y="1993392"/>
+            <a:ext cx="3657600" cy="2651760"/>
+          </a:xfrm>
+          <a:prstGeom prst="rect">
+            <a:avLst/>
+          </a:prstGeom>
+          <a:noFill/>
+          <a:ln/>
+        </p:spPr>
+        <p:txBody>
+          <a:bodyPr wrap="square" lIns="0" tIns="0" rIns="0" bIns="0" rtlCol="0" anchor="ctr"/>
+          <a:lstStyle/>
+          <a:p>
+            <a:pPr marL="342900" indent="-342900">
+              <a:spcAft>
+                <a:spcPts val="400"/>
+              </a:spcAft>
+              <a:buSzPct val="100000"/>
+              <a:buChar char="•"/>
+            </a:pPr>
+            <a:r>
+              <a:rPr lang="en-US" sz="1250" dirty="0">
+                <a:solidFill>
+                  <a:srgbClr val="1A1F36"/>
+                </a:solidFill>
+                <a:latin typeface="Calibri" pitchFamily="34" charset="0"/>
+                <a:ea typeface="Calibri" pitchFamily="34" charset="-122"/>
+                <a:cs typeface="Calibri" pitchFamily="34" charset="-120"/>
+              </a:rPr>
+              <a:t>Implemented mmap_compute</a:t>
+            </a:r>
+            <a:endParaRPr lang="en-US" sz="1250" dirty="0"/>
+          </a:p>
+          <a:p>
+            <a:pPr marL="342900" indent="-342900">
+              <a:spcAft>
+                <a:spcPts val="400"/>
+              </a:spcAft>
+              <a:buSzPct val="100000"/>
+              <a:buChar char="•"/>
+            </a:pPr>
+            <a:r>
+              <a:rPr lang="en-US" sz="1250" dirty="0">
+                <a:solidFill>
+                  <a:srgbClr val="1A1F36"/>
+                </a:solidFill>
+                <a:latin typeface="Calibri" pitchFamily="34" charset="0"/>
+                <a:ea typeface="Calibri" pitchFamily="34" charset="-122"/>
+                <a:cs typeface="Calibri" pitchFamily="34" charset="-120"/>
+              </a:rPr>
+              <a:t>Implemented threads_compute</a:t>
+            </a:r>
+            <a:endParaRPr lang="en-US" sz="1250" dirty="0"/>
+          </a:p>
+          <a:p>
+            <a:pPr marL="342900" indent="-342900">
+              <a:spcAft>
+                <a:spcPts val="400"/>
+              </a:spcAft>
+              <a:buSzPct val="100000"/>
+              <a:buChar char="•"/>
+            </a:pPr>
+            <a:r>
+              <a:rPr lang="en-US" sz="1250" dirty="0">
+                <a:solidFill>
+                  <a:srgbClr val="1A1F36"/>
+                </a:solidFill>
+                <a:latin typeface="Calibri" pitchFamily="34" charset="0"/>
+                <a:ea typeface="Calibri" pitchFamily="34" charset="-122"/>
+                <a:cs typeface="Calibri" pitchFamily="34" charset="-120"/>
+              </a:rPr>
+              <a:t>Updated parse.h (read_numbers_ul)</a:t>
+            </a:r>
+            <a:endParaRPr lang="en-US" sz="1250" dirty="0"/>
+          </a:p>
+          <a:p>
+            <a:pPr marL="342900" indent="-342900">
+              <a:spcAft>
+                <a:spcPts val="400"/>
+              </a:spcAft>
+              <a:buSzPct val="100000"/>
+              <a:buChar char="•"/>
+            </a:pPr>
+            <a:r>
+              <a:rPr lang="en-US" sz="1250" dirty="0">
+                <a:solidFill>
+                  <a:srgbClr val="1A1F36"/>
+                </a:solidFill>
+                <a:latin typeface="Calibri" pitchFamily="34" charset="0"/>
+                <a:ea typeface="Calibri" pitchFamily="34" charset="-122"/>
+                <a:cs typeface="Calibri" pitchFamily="34" charset="-120"/>
+              </a:rPr>
+              <a:t>Updated compute.h (ulfunc_t type)</a:t>
+            </a:r>
+            <a:endParaRPr lang="en-US" sz="1250" dirty="0"/>
+          </a:p>
+          <a:p>
+            <a:pPr marL="342900" indent="-342900">
+              <a:spcAft>
+                <a:spcPts val="400"/>
+              </a:spcAft>
+              <a:buSzPct val="100000"/>
+              <a:buChar char="•"/>
+            </a:pPr>
+            <a:r>
+              <a:rPr lang="en-US" sz="1250" dirty="0">
+                <a:solidFill>
+                  <a:srgbClr val="1A1F36"/>
+                </a:solidFill>
+                <a:latin typeface="Calibri" pitchFamily="34" charset="0"/>
+                <a:ea typeface="Calibri" pitchFamily="34" charset="-122"/>
+                <a:cs typeface="Calibri" pitchFamily="34" charset="-120"/>
+              </a:rPr>
+              <a:t>Wrote test_correctness.c for all 4 functions</a:t>
+            </a:r>
+            <a:endParaRPr lang="en-US" sz="1250" dirty="0"/>
+          </a:p>
+          <a:p>
+            <a:pPr marL="342900" indent="-342900">
+              <a:spcAft>
+                <a:spcPts val="400"/>
+              </a:spcAft>
+              <a:buSzPct val="100000"/>
+              <a:buChar char="•"/>
+            </a:pPr>
+            <a:r>
+              <a:rPr lang="en-US" sz="1250" dirty="0">
+                <a:solidFill>
+                  <a:srgbClr val="1A1F36"/>
+                </a:solidFill>
+                <a:latin typeface="Calibri" pitchFamily="34" charset="0"/>
+                <a:ea typeface="Calibri" pitchFamily="34" charset="-122"/>
+                <a:cs typeface="Calibri" pitchFamily="34" charset="-120"/>
+              </a:rPr>
+              <a:t>Verified correctness</a:t>
+            </a:r>
+            <a:endParaRPr lang="en-US" sz="1250" dirty="0"/>
+          </a:p>
+        </p:txBody>
+      </p:sp>
+      <p:sp>
+        <p:nvSpPr>
+          <p:cNvPr id="10" name="Shape 8"/>
+          <p:cNvSpPr/>
+          <p:nvPr/>
+        </p:nvSpPr>
+        <p:spPr>
+          <a:xfrm>
+            <a:off x="4846320" y="1005840"/>
+            <a:ext cx="4023360" cy="3749040"/>
+          </a:xfrm>
+          <a:prstGeom prst="rect">
+            <a:avLst/>
+          </a:prstGeom>
+          <a:solidFill>
+            <a:srgbClr val="FFFFFF"/>
+          </a:solidFill>
+          <a:ln w="12700">
+            <a:solidFill>
+              <a:srgbClr val="E0E6F8"/>
+            </a:solidFill>
+            <a:prstDash val="solid"/>
+          </a:ln>
+          <a:effectLst>
+            <a:outerShdw blurRad="101600" dist="38100" dir="8100000" algn="bl" rotWithShape="0">
+              <a:srgbClr val="000000">
+                <a:alpha val="18000"/>
+              </a:srgbClr>
+            </a:outerShdw>
+          </a:effectLst>
+        </p:spPr>
+        <p:txBody>
+          <a:bodyPr/>
+          <a:lstStyle/>
+          <a:p>
+            <a:endParaRPr lang="en-US" dirty="0"/>
+          </a:p>
+        </p:txBody>
+      </p:sp>
+      <p:sp>
+        <p:nvSpPr>
+          <p:cNvPr id="11" name="Shape 9"/>
+          <p:cNvSpPr/>
+          <p:nvPr/>
+        </p:nvSpPr>
+        <p:spPr>
+          <a:xfrm>
+            <a:off x="4846320" y="1005840"/>
+            <a:ext cx="4023360" cy="109728"/>
+          </a:xfrm>
+          <a:prstGeom prst="rect">
+            <a:avLst/>
+          </a:prstGeom>
+          <a:solidFill>
+            <a:srgbClr val="00B4D8"/>
+          </a:solidFill>
+          <a:ln w="12700">
+            <a:solidFill>
+              <a:srgbClr val="00B4D8"/>
+            </a:solidFill>
+            <a:prstDash val="solid"/>
+          </a:ln>
+        </p:spPr>
+        <p:txBody>
+          <a:bodyPr/>
+          <a:lstStyle/>
+          <a:p>
+            <a:endParaRPr lang="en-US"/>
+          </a:p>
+        </p:txBody>
+      </p:sp>
+      <p:sp>
+        <p:nvSpPr>
+          <p:cNvPr id="12" name="Text 10"/>
+          <p:cNvSpPr/>
+          <p:nvPr/>
+        </p:nvSpPr>
+        <p:spPr>
+          <a:xfrm>
+            <a:off x="5010912" y="1097280"/>
+            <a:ext cx="3657600" cy="320040"/>
+          </a:xfrm>
+          <a:prstGeom prst="rect">
+            <a:avLst/>
+          </a:prstGeom>
+          <a:noFill/>
+          <a:ln/>
+        </p:spPr>
+        <p:txBody>
+          <a:bodyPr wrap="square" lIns="0" tIns="0" rIns="0" bIns="0" rtlCol="0" anchor="ctr"/>
+          <a:lstStyle/>
+          <a:p>
+            <a:pPr marL="0" indent="0">
+              <a:buNone/>
+            </a:pPr>
+            <a:r>
+              <a:rPr lang="en-US" sz="1000" b="1" dirty="0">
+                <a:solidFill>
+                  <a:srgbClr val="00B4D8"/>
+                </a:solidFill>
+                <a:latin typeface="Calibri" pitchFamily="34" charset="0"/>
+                <a:ea typeface="Calibri" pitchFamily="34" charset="-122"/>
+                <a:cs typeface="Calibri" pitchFamily="34" charset="-120"/>
+              </a:rPr>
+              <a:t>MEMBER 2</a:t>
+            </a:r>
+            <a:endParaRPr lang="en-US" sz="1000" dirty="0"/>
+          </a:p>
+        </p:txBody>
+      </p:sp>
+      <p:sp>
+        <p:nvSpPr>
+          <p:cNvPr id="13" name="Text 11"/>
+          <p:cNvSpPr/>
+          <p:nvPr/>
+        </p:nvSpPr>
+        <p:spPr>
+          <a:xfrm>
+            <a:off x="5010912" y="1417320"/>
+            <a:ext cx="3657600" cy="411480"/>
+          </a:xfrm>
+          <a:prstGeom prst="rect">
+            <a:avLst/>
+          </a:prstGeom>
+          <a:noFill/>
+          <a:ln/>
+        </p:spPr>
+        <p:txBody>
+          <a:bodyPr wrap="square" lIns="0" tIns="0" rIns="0" bIns="0" rtlCol="0" anchor="ctr"/>
+          <a:lstStyle/>
+          <a:p>
+            <a:pPr marL="0" indent="0">
+              <a:buNone/>
+            </a:pPr>
+            <a:r>
+              <a:rPr lang="en-US" sz="1800" b="1" dirty="0">
+                <a:solidFill>
+                  <a:srgbClr val="1A1F36"/>
+                </a:solidFill>
+                <a:latin typeface="Calibri" pitchFamily="34" charset="0"/>
+                <a:ea typeface="Calibri" pitchFamily="34" charset="-122"/>
+                <a:cs typeface="Calibri" pitchFamily="34" charset="-120"/>
+              </a:rPr>
+              <a:t>Yara</a:t>
+            </a:r>
+            <a:endParaRPr lang="en-US" sz="1800" dirty="0"/>
+          </a:p>
+        </p:txBody>
+      </p:sp>
+      <p:sp>
+        <p:nvSpPr>
+          <p:cNvPr id="14" name="Shape 12"/>
+          <p:cNvSpPr/>
+          <p:nvPr/>
+        </p:nvSpPr>
+        <p:spPr>
+          <a:xfrm>
+            <a:off x="5010912" y="1874520"/>
+            <a:ext cx="3657600" cy="0"/>
+          </a:xfrm>
+          <a:prstGeom prst="line">
+            <a:avLst/>
+          </a:prstGeom>
+          <a:noFill/>
+          <a:ln w="12700">
+            <a:solidFill>
+              <a:srgbClr val="E0E6F8"/>
+            </a:solidFill>
+            <a:prstDash val="solid"/>
+          </a:ln>
+        </p:spPr>
+        <p:txBody>
+          <a:bodyPr/>
+          <a:lstStyle/>
+          <a:p>
+            <a:endParaRPr lang="en-US"/>
+          </a:p>
+        </p:txBody>
+      </p:sp>
+      <p:sp>
+        <p:nvSpPr>
+          <p:cNvPr id="15" name="Text 13"/>
+          <p:cNvSpPr/>
+          <p:nvPr/>
+        </p:nvSpPr>
+        <p:spPr>
+          <a:xfrm>
+            <a:off x="5010912" y="1993392"/>
+            <a:ext cx="3657600" cy="2651760"/>
+          </a:xfrm>
+          <a:prstGeom prst="rect">
+            <a:avLst/>
+          </a:prstGeom>
+          <a:noFill/>
+          <a:ln/>
+        </p:spPr>
+        <p:txBody>
+          <a:bodyPr wrap="square" lIns="0" tIns="0" rIns="0" bIns="0" rtlCol="0" anchor="ctr"/>
+          <a:lstStyle/>
+          <a:p>
+            <a:pPr marL="342900" indent="-342900">
+              <a:spcAft>
+                <a:spcPts val="400"/>
+              </a:spcAft>
+              <a:buSzPct val="100000"/>
+              <a:buChar char="•"/>
+            </a:pPr>
+            <a:endParaRPr lang="en-US" sz="1250" dirty="0"/>
+          </a:p>
+        </p:txBody>
+      </p:sp>
+      <p:sp>
+        <p:nvSpPr>
+          <p:cNvPr id="16" name="Text 7">
+            <a:extLst>
+              <a:ext uri="{FF2B5EF4-FFF2-40B4-BE49-F238E27FC236}">
+                <a16:creationId xmlns:a16="http://schemas.microsoft.com/office/drawing/2014/main" id="{87550E9F-D30B-F08A-054A-E036FBD0C477}"/>
+              </a:ext>
+            </a:extLst>
+          </p:cNvPr>
+          <p:cNvSpPr/>
+          <p:nvPr/>
+        </p:nvSpPr>
+        <p:spPr>
+          <a:xfrm>
+            <a:off x="5047488" y="1828800"/>
+            <a:ext cx="3657600" cy="2651760"/>
+          </a:xfrm>
+          <a:prstGeom prst="rect">
+            <a:avLst/>
+          </a:prstGeom>
+          <a:noFill/>
+          <a:ln/>
+        </p:spPr>
+        <p:txBody>
+          <a:bodyPr wrap="square" lIns="0" tIns="0" rIns="0" bIns="0" rtlCol="0" anchor="ctr"/>
+          <a:lstStyle/>
+          <a:p>
+            <a:pPr marL="342900" indent="-342900">
+              <a:spcAft>
+                <a:spcPts val="400"/>
+              </a:spcAft>
+              <a:buSzPct val="100000"/>
+              <a:buChar char="•"/>
+            </a:pPr>
+            <a:r>
+              <a:rPr lang="en-US" sz="1250" dirty="0">
+                <a:solidFill>
+                  <a:srgbClr val="1A1F36"/>
+                </a:solidFill>
+                <a:latin typeface="Calibri" pitchFamily="34" charset="0"/>
+                <a:ea typeface="Calibri" pitchFamily="34" charset="-122"/>
+                <a:cs typeface="Calibri" pitchFamily="34" charset="-120"/>
+              </a:rPr>
+              <a:t>Implemented Experiment_1</a:t>
+            </a:r>
+            <a:endParaRPr lang="en-US" sz="1250" dirty="0"/>
+          </a:p>
+          <a:p>
+            <a:pPr marL="342900" indent="-342900">
+              <a:spcAft>
+                <a:spcPts val="400"/>
+              </a:spcAft>
+              <a:buSzPct val="100000"/>
+              <a:buChar char="•"/>
+            </a:pPr>
+            <a:r>
+              <a:rPr lang="en-US" sz="1250" dirty="0">
+                <a:solidFill>
+                  <a:srgbClr val="1A1F36"/>
+                </a:solidFill>
+                <a:latin typeface="Calibri" pitchFamily="34" charset="0"/>
+                <a:ea typeface="Calibri" pitchFamily="34" charset="-122"/>
+                <a:cs typeface="Calibri" pitchFamily="34" charset="-120"/>
+              </a:rPr>
+              <a:t>Implemented Experiment_2</a:t>
+            </a:r>
+          </a:p>
+          <a:p>
+            <a:pPr marL="342900" indent="-342900">
+              <a:spcAft>
+                <a:spcPts val="400"/>
+              </a:spcAft>
+              <a:buSzPct val="100000"/>
+              <a:buChar char="•"/>
+            </a:pPr>
+            <a:r>
+              <a:rPr lang="en-US" sz="1250" dirty="0">
+                <a:solidFill>
+                  <a:srgbClr val="1A1F36"/>
+                </a:solidFill>
+                <a:latin typeface="Calibri" pitchFamily="34" charset="0"/>
+                <a:ea typeface="Calibri" pitchFamily="34" charset="-122"/>
+                <a:cs typeface="Calibri" pitchFamily="34" charset="-120"/>
+              </a:rPr>
+              <a:t>Ran both experiments and extracted results</a:t>
+            </a:r>
+            <a:endParaRPr lang="en-US" sz="1250" dirty="0"/>
+          </a:p>
+          <a:p>
+            <a:pPr marL="342900" indent="-342900">
+              <a:spcAft>
+                <a:spcPts val="400"/>
+              </a:spcAft>
+              <a:buSzPct val="100000"/>
+              <a:buChar char="•"/>
+            </a:pPr>
+            <a:r>
+              <a:rPr lang="en-US" sz="1250" dirty="0">
+                <a:solidFill>
+                  <a:srgbClr val="1A1F36"/>
+                </a:solidFill>
+                <a:latin typeface="Calibri" pitchFamily="34" charset="0"/>
+                <a:ea typeface="Calibri" pitchFamily="34" charset="-122"/>
+                <a:cs typeface="Calibri" pitchFamily="34" charset="-120"/>
+              </a:rPr>
+              <a:t>Updated sequential and parallel compute to match the new input function requirements</a:t>
+            </a:r>
+            <a:endParaRPr lang="en-US" sz="1250" dirty="0"/>
+          </a:p>
+        </p:txBody>
+      </p:sp>
+    </p:spTree>
+  </p:cSld>
+  <p:clrMapOvr>
+    <a:masterClrMapping/>
+  </p:clrMapOvr>
+</p:sld>
+</file>
+
+<file path=ppt/slides/slide20.xml><?xml version="1.0" encoding="utf-8"?>
 <p:sld xmlns:a="http://schemas.openxmlformats.org/drawingml/2006/main" xmlns:r="http://schemas.openxmlformats.org/officeDocument/2006/relationships" xmlns:p="http://schemas.openxmlformats.org/presentationml/2006/main">
   <p:cSld>
     <p:spTree>
@@ -12747,760 +14128,7 @@
 </p:sld>
 </file>
 
-<file path=ppt/slides/slide2.xml><?xml version="1.0" encoding="utf-8"?>
-<p:sld xmlns:a="http://schemas.openxmlformats.org/drawingml/2006/main" xmlns:r="http://schemas.openxmlformats.org/officeDocument/2006/relationships" xmlns:p="http://schemas.openxmlformats.org/presentationml/2006/main">
-  <p:cSld name="Slide 2">
-    <p:bg>
-      <p:bgPr>
-        <a:solidFill>
-          <a:srgbClr val="F0F4FF"/>
-        </a:solidFill>
-        <a:effectLst/>
-      </p:bgPr>
-    </p:bg>
-    <p:spTree>
-      <p:nvGrpSpPr>
-        <p:cNvPr id="1" name=""/>
-        <p:cNvGrpSpPr/>
-        <p:nvPr/>
-      </p:nvGrpSpPr>
-      <p:grpSpPr>
-        <a:xfrm>
-          <a:off x="0" y="0"/>
-          <a:ext cx="0" cy="0"/>
-          <a:chOff x="0" y="0"/>
-          <a:chExt cx="0" cy="0"/>
-        </a:xfrm>
-      </p:grpSpPr>
-      <p:sp>
-        <p:nvSpPr>
-          <p:cNvPr id="2" name="Shape 0"/>
-          <p:cNvSpPr/>
-          <p:nvPr/>
-        </p:nvSpPr>
-        <p:spPr>
-          <a:xfrm>
-            <a:off x="0" y="0"/>
-            <a:ext cx="9144000" cy="868680"/>
-          </a:xfrm>
-          <a:prstGeom prst="rect">
-            <a:avLst/>
-          </a:prstGeom>
-          <a:solidFill>
-            <a:srgbClr val="1A1F36"/>
-          </a:solidFill>
-          <a:ln w="12700">
-            <a:solidFill>
-              <a:srgbClr val="1A1F36"/>
-            </a:solidFill>
-            <a:prstDash val="solid"/>
-          </a:ln>
-        </p:spPr>
-        <p:txBody>
-          <a:bodyPr/>
-          <a:lstStyle/>
-          <a:p>
-            <a:endParaRPr lang="en-US"/>
-          </a:p>
-        </p:txBody>
-      </p:sp>
-      <p:sp>
-        <p:nvSpPr>
-          <p:cNvPr id="3" name="Text 1"/>
-          <p:cNvSpPr/>
-          <p:nvPr/>
-        </p:nvSpPr>
-        <p:spPr>
-          <a:xfrm>
-            <a:off x="365760" y="109728"/>
-            <a:ext cx="8229600" cy="640080"/>
-          </a:xfrm>
-          <a:prstGeom prst="rect">
-            <a:avLst/>
-          </a:prstGeom>
-          <a:noFill/>
-          <a:ln/>
-        </p:spPr>
-        <p:txBody>
-          <a:bodyPr wrap="square" lIns="0" tIns="0" rIns="0" bIns="0" rtlCol="0" anchor="ctr"/>
-          <a:lstStyle/>
-          <a:p>
-            <a:pPr marL="0" indent="0">
-              <a:buNone/>
-            </a:pPr>
-            <a:r>
-              <a:rPr lang="en-US" sz="2600" b="1" dirty="0">
-                <a:solidFill>
-                  <a:srgbClr val="FFFFFF"/>
-                </a:solidFill>
-                <a:latin typeface="Calibri" pitchFamily="34" charset="0"/>
-                <a:ea typeface="Calibri" pitchFamily="34" charset="-122"/>
-                <a:cs typeface="Calibri" pitchFamily="34" charset="-120"/>
-              </a:rPr>
-              <a:t>Team Roles</a:t>
-            </a:r>
-            <a:endParaRPr lang="en-US" sz="2600" dirty="0"/>
-          </a:p>
-        </p:txBody>
-      </p:sp>
-      <p:sp>
-        <p:nvSpPr>
-          <p:cNvPr id="4" name="Shape 2"/>
-          <p:cNvSpPr/>
-          <p:nvPr/>
-        </p:nvSpPr>
-        <p:spPr>
-          <a:xfrm>
-            <a:off x="274320" y="1005840"/>
-            <a:ext cx="4023360" cy="3749040"/>
-          </a:xfrm>
-          <a:prstGeom prst="rect">
-            <a:avLst/>
-          </a:prstGeom>
-          <a:solidFill>
-            <a:srgbClr val="FFFFFF"/>
-          </a:solidFill>
-          <a:ln w="12700">
-            <a:solidFill>
-              <a:srgbClr val="E0E6F8"/>
-            </a:solidFill>
-            <a:prstDash val="solid"/>
-          </a:ln>
-          <a:effectLst>
-            <a:outerShdw blurRad="101600" dist="38100" dir="8100000" algn="bl" rotWithShape="0">
-              <a:srgbClr val="000000">
-                <a:alpha val="18000"/>
-              </a:srgbClr>
-            </a:outerShdw>
-          </a:effectLst>
-        </p:spPr>
-        <p:txBody>
-          <a:bodyPr/>
-          <a:lstStyle/>
-          <a:p>
-            <a:endParaRPr lang="en-US"/>
-          </a:p>
-        </p:txBody>
-      </p:sp>
-      <p:sp>
-        <p:nvSpPr>
-          <p:cNvPr id="5" name="Shape 3"/>
-          <p:cNvSpPr/>
-          <p:nvPr/>
-        </p:nvSpPr>
-        <p:spPr>
-          <a:xfrm>
-            <a:off x="274320" y="1005840"/>
-            <a:ext cx="4023360" cy="109728"/>
-          </a:xfrm>
-          <a:prstGeom prst="rect">
-            <a:avLst/>
-          </a:prstGeom>
-          <a:solidFill>
-            <a:srgbClr val="4F8EF7"/>
-          </a:solidFill>
-          <a:ln w="12700">
-            <a:solidFill>
-              <a:srgbClr val="4F8EF7"/>
-            </a:solidFill>
-            <a:prstDash val="solid"/>
-          </a:ln>
-        </p:spPr>
-        <p:txBody>
-          <a:bodyPr/>
-          <a:lstStyle/>
-          <a:p>
-            <a:endParaRPr lang="en-US"/>
-          </a:p>
-        </p:txBody>
-      </p:sp>
-      <p:sp>
-        <p:nvSpPr>
-          <p:cNvPr id="6" name="Text 4"/>
-          <p:cNvSpPr/>
-          <p:nvPr/>
-        </p:nvSpPr>
-        <p:spPr>
-          <a:xfrm>
-            <a:off x="438912" y="1097280"/>
-            <a:ext cx="3657600" cy="320040"/>
-          </a:xfrm>
-          <a:prstGeom prst="rect">
-            <a:avLst/>
-          </a:prstGeom>
-          <a:noFill/>
-          <a:ln/>
-        </p:spPr>
-        <p:txBody>
-          <a:bodyPr wrap="square" lIns="0" tIns="0" rIns="0" bIns="0" rtlCol="0" anchor="ctr"/>
-          <a:lstStyle/>
-          <a:p>
-            <a:pPr marL="0" indent="0">
-              <a:buNone/>
-            </a:pPr>
-            <a:r>
-              <a:rPr lang="en-US" sz="1000" b="1" dirty="0">
-                <a:solidFill>
-                  <a:srgbClr val="4F8EF7"/>
-                </a:solidFill>
-                <a:latin typeface="Calibri" pitchFamily="34" charset="0"/>
-                <a:ea typeface="Calibri" pitchFamily="34" charset="-122"/>
-                <a:cs typeface="Calibri" pitchFamily="34" charset="-120"/>
-              </a:rPr>
-              <a:t>MEMBER 1 </a:t>
-            </a:r>
-            <a:endParaRPr lang="en-US" sz="1000" dirty="0"/>
-          </a:p>
-        </p:txBody>
-      </p:sp>
-      <p:sp>
-        <p:nvSpPr>
-          <p:cNvPr id="7" name="Text 5"/>
-          <p:cNvSpPr/>
-          <p:nvPr/>
-        </p:nvSpPr>
-        <p:spPr>
-          <a:xfrm>
-            <a:off x="438912" y="1417320"/>
-            <a:ext cx="3657600" cy="411480"/>
-          </a:xfrm>
-          <a:prstGeom prst="rect">
-            <a:avLst/>
-          </a:prstGeom>
-          <a:noFill/>
-          <a:ln/>
-        </p:spPr>
-        <p:txBody>
-          <a:bodyPr wrap="square" lIns="0" tIns="0" rIns="0" bIns="0" rtlCol="0" anchor="ctr"/>
-          <a:lstStyle/>
-          <a:p>
-            <a:pPr marL="0" indent="0">
-              <a:buNone/>
-            </a:pPr>
-            <a:r>
-              <a:rPr lang="en-US" sz="1800" b="1" dirty="0">
-                <a:solidFill>
-                  <a:srgbClr val="1A1F36"/>
-                </a:solidFill>
-                <a:latin typeface="Calibri" pitchFamily="34" charset="0"/>
-                <a:ea typeface="Calibri" pitchFamily="34" charset="-122"/>
-                <a:cs typeface="Calibri" pitchFamily="34" charset="-120"/>
-              </a:rPr>
-              <a:t>Sama Emad Abu Zahra</a:t>
-            </a:r>
-            <a:endParaRPr lang="en-US" sz="1800" dirty="0"/>
-          </a:p>
-        </p:txBody>
-      </p:sp>
-      <p:sp>
-        <p:nvSpPr>
-          <p:cNvPr id="8" name="Shape 6"/>
-          <p:cNvSpPr/>
-          <p:nvPr/>
-        </p:nvSpPr>
-        <p:spPr>
-          <a:xfrm>
-            <a:off x="438912" y="1874520"/>
-            <a:ext cx="3657600" cy="0"/>
-          </a:xfrm>
-          <a:prstGeom prst="line">
-            <a:avLst/>
-          </a:prstGeom>
-          <a:noFill/>
-          <a:ln w="12700">
-            <a:solidFill>
-              <a:srgbClr val="E0E6F8"/>
-            </a:solidFill>
-            <a:prstDash val="solid"/>
-          </a:ln>
-        </p:spPr>
-        <p:txBody>
-          <a:bodyPr/>
-          <a:lstStyle/>
-          <a:p>
-            <a:endParaRPr lang="en-US"/>
-          </a:p>
-        </p:txBody>
-      </p:sp>
-      <p:sp>
-        <p:nvSpPr>
-          <p:cNvPr id="9" name="Text 7"/>
-          <p:cNvSpPr/>
-          <p:nvPr/>
-        </p:nvSpPr>
-        <p:spPr>
-          <a:xfrm>
-            <a:off x="438912" y="1993392"/>
-            <a:ext cx="3657600" cy="2651760"/>
-          </a:xfrm>
-          <a:prstGeom prst="rect">
-            <a:avLst/>
-          </a:prstGeom>
-          <a:noFill/>
-          <a:ln/>
-        </p:spPr>
-        <p:txBody>
-          <a:bodyPr wrap="square" lIns="0" tIns="0" rIns="0" bIns="0" rtlCol="0" anchor="ctr"/>
-          <a:lstStyle/>
-          <a:p>
-            <a:pPr marL="342900" indent="-342900">
-              <a:spcAft>
-                <a:spcPts val="400"/>
-              </a:spcAft>
-              <a:buSzPct val="100000"/>
-              <a:buChar char="•"/>
-            </a:pPr>
-            <a:r>
-              <a:rPr lang="en-US" sz="1250" dirty="0">
-                <a:solidFill>
-                  <a:srgbClr val="1A1F36"/>
-                </a:solidFill>
-                <a:latin typeface="Calibri" pitchFamily="34" charset="0"/>
-                <a:ea typeface="Calibri" pitchFamily="34" charset="-122"/>
-                <a:cs typeface="Calibri" pitchFamily="34" charset="-120"/>
-              </a:rPr>
-              <a:t>Implemented mmap_compute</a:t>
-            </a:r>
-            <a:endParaRPr lang="en-US" sz="1250" dirty="0"/>
-          </a:p>
-          <a:p>
-            <a:pPr marL="342900" indent="-342900">
-              <a:spcAft>
-                <a:spcPts val="400"/>
-              </a:spcAft>
-              <a:buSzPct val="100000"/>
-              <a:buChar char="•"/>
-            </a:pPr>
-            <a:r>
-              <a:rPr lang="en-US" sz="1250" dirty="0">
-                <a:solidFill>
-                  <a:srgbClr val="1A1F36"/>
-                </a:solidFill>
-                <a:latin typeface="Calibri" pitchFamily="34" charset="0"/>
-                <a:ea typeface="Calibri" pitchFamily="34" charset="-122"/>
-                <a:cs typeface="Calibri" pitchFamily="34" charset="-120"/>
-              </a:rPr>
-              <a:t>Implemented threads_compute</a:t>
-            </a:r>
-            <a:endParaRPr lang="en-US" sz="1250" dirty="0"/>
-          </a:p>
-          <a:p>
-            <a:pPr marL="342900" indent="-342900">
-              <a:spcAft>
-                <a:spcPts val="400"/>
-              </a:spcAft>
-              <a:buSzPct val="100000"/>
-              <a:buChar char="•"/>
-            </a:pPr>
-            <a:r>
-              <a:rPr lang="en-US" sz="1250" dirty="0">
-                <a:solidFill>
-                  <a:srgbClr val="1A1F36"/>
-                </a:solidFill>
-                <a:latin typeface="Calibri" pitchFamily="34" charset="0"/>
-                <a:ea typeface="Calibri" pitchFamily="34" charset="-122"/>
-                <a:cs typeface="Calibri" pitchFamily="34" charset="-120"/>
-              </a:rPr>
-              <a:t>Updated parse.h (read_numbers_ul)</a:t>
-            </a:r>
-            <a:endParaRPr lang="en-US" sz="1250" dirty="0"/>
-          </a:p>
-          <a:p>
-            <a:pPr marL="342900" indent="-342900">
-              <a:spcAft>
-                <a:spcPts val="400"/>
-              </a:spcAft>
-              <a:buSzPct val="100000"/>
-              <a:buChar char="•"/>
-            </a:pPr>
-            <a:r>
-              <a:rPr lang="en-US" sz="1250" dirty="0">
-                <a:solidFill>
-                  <a:srgbClr val="1A1F36"/>
-                </a:solidFill>
-                <a:latin typeface="Calibri" pitchFamily="34" charset="0"/>
-                <a:ea typeface="Calibri" pitchFamily="34" charset="-122"/>
-                <a:cs typeface="Calibri" pitchFamily="34" charset="-120"/>
-              </a:rPr>
-              <a:t>Updated compute.h (ulfunc_t type)</a:t>
-            </a:r>
-            <a:endParaRPr lang="en-US" sz="1250" dirty="0"/>
-          </a:p>
-          <a:p>
-            <a:pPr marL="342900" indent="-342900">
-              <a:spcAft>
-                <a:spcPts val="400"/>
-              </a:spcAft>
-              <a:buSzPct val="100000"/>
-              <a:buChar char="•"/>
-            </a:pPr>
-            <a:r>
-              <a:rPr lang="en-US" sz="1250" dirty="0">
-                <a:solidFill>
-                  <a:srgbClr val="1A1F36"/>
-                </a:solidFill>
-                <a:latin typeface="Calibri" pitchFamily="34" charset="0"/>
-                <a:ea typeface="Calibri" pitchFamily="34" charset="-122"/>
-                <a:cs typeface="Calibri" pitchFamily="34" charset="-120"/>
-              </a:rPr>
-              <a:t>Wrote test_correctness.c for all 4 functions</a:t>
-            </a:r>
-            <a:endParaRPr lang="en-US" sz="1250" dirty="0"/>
-          </a:p>
-          <a:p>
-            <a:pPr marL="342900" indent="-342900">
-              <a:spcAft>
-                <a:spcPts val="400"/>
-              </a:spcAft>
-              <a:buSzPct val="100000"/>
-              <a:buChar char="•"/>
-            </a:pPr>
-            <a:r>
-              <a:rPr lang="en-US" sz="1250" dirty="0">
-                <a:solidFill>
-                  <a:srgbClr val="1A1F36"/>
-                </a:solidFill>
-                <a:latin typeface="Calibri" pitchFamily="34" charset="0"/>
-                <a:ea typeface="Calibri" pitchFamily="34" charset="-122"/>
-                <a:cs typeface="Calibri" pitchFamily="34" charset="-120"/>
-              </a:rPr>
-              <a:t>Verified correctness</a:t>
-            </a:r>
-            <a:endParaRPr lang="en-US" sz="1250" dirty="0"/>
-          </a:p>
-        </p:txBody>
-      </p:sp>
-      <p:sp>
-        <p:nvSpPr>
-          <p:cNvPr id="10" name="Shape 8"/>
-          <p:cNvSpPr/>
-          <p:nvPr/>
-        </p:nvSpPr>
-        <p:spPr>
-          <a:xfrm>
-            <a:off x="4846320" y="1005840"/>
-            <a:ext cx="4023360" cy="3749040"/>
-          </a:xfrm>
-          <a:prstGeom prst="rect">
-            <a:avLst/>
-          </a:prstGeom>
-          <a:solidFill>
-            <a:srgbClr val="FFFFFF"/>
-          </a:solidFill>
-          <a:ln w="12700">
-            <a:solidFill>
-              <a:srgbClr val="E0E6F8"/>
-            </a:solidFill>
-            <a:prstDash val="solid"/>
-          </a:ln>
-          <a:effectLst>
-            <a:outerShdw blurRad="101600" dist="38100" dir="8100000" algn="bl" rotWithShape="0">
-              <a:srgbClr val="000000">
-                <a:alpha val="18000"/>
-              </a:srgbClr>
-            </a:outerShdw>
-          </a:effectLst>
-        </p:spPr>
-        <p:txBody>
-          <a:bodyPr/>
-          <a:lstStyle/>
-          <a:p>
-            <a:endParaRPr lang="en-US" dirty="0"/>
-          </a:p>
-        </p:txBody>
-      </p:sp>
-      <p:sp>
-        <p:nvSpPr>
-          <p:cNvPr id="11" name="Shape 9"/>
-          <p:cNvSpPr/>
-          <p:nvPr/>
-        </p:nvSpPr>
-        <p:spPr>
-          <a:xfrm>
-            <a:off x="4846320" y="1005840"/>
-            <a:ext cx="4023360" cy="109728"/>
-          </a:xfrm>
-          <a:prstGeom prst="rect">
-            <a:avLst/>
-          </a:prstGeom>
-          <a:solidFill>
-            <a:srgbClr val="00B4D8"/>
-          </a:solidFill>
-          <a:ln w="12700">
-            <a:solidFill>
-              <a:srgbClr val="00B4D8"/>
-            </a:solidFill>
-            <a:prstDash val="solid"/>
-          </a:ln>
-        </p:spPr>
-        <p:txBody>
-          <a:bodyPr/>
-          <a:lstStyle/>
-          <a:p>
-            <a:endParaRPr lang="en-US"/>
-          </a:p>
-        </p:txBody>
-      </p:sp>
-      <p:sp>
-        <p:nvSpPr>
-          <p:cNvPr id="12" name="Text 10"/>
-          <p:cNvSpPr/>
-          <p:nvPr/>
-        </p:nvSpPr>
-        <p:spPr>
-          <a:xfrm>
-            <a:off x="5010912" y="1097280"/>
-            <a:ext cx="3657600" cy="320040"/>
-          </a:xfrm>
-          <a:prstGeom prst="rect">
-            <a:avLst/>
-          </a:prstGeom>
-          <a:noFill/>
-          <a:ln/>
-        </p:spPr>
-        <p:txBody>
-          <a:bodyPr wrap="square" lIns="0" tIns="0" rIns="0" bIns="0" rtlCol="0" anchor="ctr"/>
-          <a:lstStyle/>
-          <a:p>
-            <a:pPr marL="0" indent="0">
-              <a:buNone/>
-            </a:pPr>
-            <a:r>
-              <a:rPr lang="en-US" sz="1000" b="1" dirty="0">
-                <a:solidFill>
-                  <a:srgbClr val="00B4D8"/>
-                </a:solidFill>
-                <a:latin typeface="Calibri" pitchFamily="34" charset="0"/>
-                <a:ea typeface="Calibri" pitchFamily="34" charset="-122"/>
-                <a:cs typeface="Calibri" pitchFamily="34" charset="-120"/>
-              </a:rPr>
-              <a:t>MEMBER 2</a:t>
-            </a:r>
-            <a:endParaRPr lang="en-US" sz="1000" dirty="0"/>
-          </a:p>
-        </p:txBody>
-      </p:sp>
-      <p:sp>
-        <p:nvSpPr>
-          <p:cNvPr id="13" name="Text 11"/>
-          <p:cNvSpPr/>
-          <p:nvPr/>
-        </p:nvSpPr>
-        <p:spPr>
-          <a:xfrm>
-            <a:off x="5010912" y="1417320"/>
-            <a:ext cx="3657600" cy="411480"/>
-          </a:xfrm>
-          <a:prstGeom prst="rect">
-            <a:avLst/>
-          </a:prstGeom>
-          <a:noFill/>
-          <a:ln/>
-        </p:spPr>
-        <p:txBody>
-          <a:bodyPr wrap="square" lIns="0" tIns="0" rIns="0" bIns="0" rtlCol="0" anchor="ctr"/>
-          <a:lstStyle/>
-          <a:p>
-            <a:pPr marL="0" indent="0">
-              <a:buNone/>
-            </a:pPr>
-            <a:r>
-              <a:rPr lang="en-US" sz="1800" b="1" dirty="0">
-                <a:solidFill>
-                  <a:srgbClr val="1A1F36"/>
-                </a:solidFill>
-                <a:latin typeface="Calibri" pitchFamily="34" charset="0"/>
-                <a:ea typeface="Calibri" pitchFamily="34" charset="-122"/>
-                <a:cs typeface="Calibri" pitchFamily="34" charset="-120"/>
-              </a:rPr>
-              <a:t>Yara</a:t>
-            </a:r>
-            <a:endParaRPr lang="en-US" sz="1800" dirty="0"/>
-          </a:p>
-        </p:txBody>
-      </p:sp>
-      <p:sp>
-        <p:nvSpPr>
-          <p:cNvPr id="14" name="Shape 12"/>
-          <p:cNvSpPr/>
-          <p:nvPr/>
-        </p:nvSpPr>
-        <p:spPr>
-          <a:xfrm>
-            <a:off x="5010912" y="1874520"/>
-            <a:ext cx="3657600" cy="0"/>
-          </a:xfrm>
-          <a:prstGeom prst="line">
-            <a:avLst/>
-          </a:prstGeom>
-          <a:noFill/>
-          <a:ln w="12700">
-            <a:solidFill>
-              <a:srgbClr val="E0E6F8"/>
-            </a:solidFill>
-            <a:prstDash val="solid"/>
-          </a:ln>
-        </p:spPr>
-        <p:txBody>
-          <a:bodyPr/>
-          <a:lstStyle/>
-          <a:p>
-            <a:endParaRPr lang="en-US"/>
-          </a:p>
-        </p:txBody>
-      </p:sp>
-      <p:sp>
-        <p:nvSpPr>
-          <p:cNvPr id="15" name="Text 13"/>
-          <p:cNvSpPr/>
-          <p:nvPr/>
-        </p:nvSpPr>
-        <p:spPr>
-          <a:xfrm>
-            <a:off x="5010912" y="1993392"/>
-            <a:ext cx="3657600" cy="2651760"/>
-          </a:xfrm>
-          <a:prstGeom prst="rect">
-            <a:avLst/>
-          </a:prstGeom>
-          <a:noFill/>
-          <a:ln/>
-        </p:spPr>
-        <p:txBody>
-          <a:bodyPr wrap="square" lIns="0" tIns="0" rIns="0" bIns="0" rtlCol="0" anchor="ctr"/>
-          <a:lstStyle/>
-          <a:p>
-            <a:pPr marL="342900" indent="-342900">
-              <a:spcAft>
-                <a:spcPts val="400"/>
-              </a:spcAft>
-              <a:buSzPct val="100000"/>
-              <a:buChar char="•"/>
-            </a:pPr>
-            <a:endParaRPr lang="en-US" sz="1250" dirty="0"/>
-          </a:p>
-        </p:txBody>
-      </p:sp>
-      <p:sp>
-        <p:nvSpPr>
-          <p:cNvPr id="16" name="Text 7">
-            <a:extLst>
-              <a:ext uri="{FF2B5EF4-FFF2-40B4-BE49-F238E27FC236}">
-                <a16:creationId xmlns:a16="http://schemas.microsoft.com/office/drawing/2014/main" id="{87550E9F-D30B-F08A-054A-E036FBD0C477}"/>
-              </a:ext>
-            </a:extLst>
-          </p:cNvPr>
-          <p:cNvSpPr/>
-          <p:nvPr/>
-        </p:nvSpPr>
-        <p:spPr>
-          <a:xfrm>
-            <a:off x="5047488" y="1828800"/>
-            <a:ext cx="3657600" cy="2651760"/>
-          </a:xfrm>
-          <a:prstGeom prst="rect">
-            <a:avLst/>
-          </a:prstGeom>
-          <a:noFill/>
-          <a:ln/>
-        </p:spPr>
-        <p:txBody>
-          <a:bodyPr wrap="square" lIns="0" tIns="0" rIns="0" bIns="0" rtlCol="0" anchor="ctr"/>
-          <a:lstStyle/>
-          <a:p>
-            <a:pPr marL="342900" indent="-342900">
-              <a:spcAft>
-                <a:spcPts val="400"/>
-              </a:spcAft>
-              <a:buSzPct val="100000"/>
-              <a:buChar char="•"/>
-            </a:pPr>
-            <a:r>
-              <a:rPr lang="en-US" sz="1250" dirty="0">
-                <a:solidFill>
-                  <a:srgbClr val="1A1F36"/>
-                </a:solidFill>
-                <a:latin typeface="Calibri" pitchFamily="34" charset="0"/>
-                <a:ea typeface="Calibri" pitchFamily="34" charset="-122"/>
-                <a:cs typeface="Calibri" pitchFamily="34" charset="-120"/>
-              </a:rPr>
-              <a:t>Implemented Experiment_1</a:t>
-            </a:r>
-            <a:endParaRPr lang="en-US" sz="1250" dirty="0"/>
-          </a:p>
-          <a:p>
-            <a:pPr marL="342900" indent="-342900">
-              <a:spcAft>
-                <a:spcPts val="400"/>
-              </a:spcAft>
-              <a:buSzPct val="100000"/>
-              <a:buChar char="•"/>
-            </a:pPr>
-            <a:r>
-              <a:rPr lang="en-US" sz="1250" dirty="0">
-                <a:solidFill>
-                  <a:srgbClr val="1A1F36"/>
-                </a:solidFill>
-                <a:latin typeface="Calibri" pitchFamily="34" charset="0"/>
-                <a:ea typeface="Calibri" pitchFamily="34" charset="-122"/>
-                <a:cs typeface="Calibri" pitchFamily="34" charset="-120"/>
-              </a:rPr>
-              <a:t>Implemented Experiment_2</a:t>
-            </a:r>
-          </a:p>
-          <a:p>
-            <a:pPr marL="342900" indent="-342900">
-              <a:spcAft>
-                <a:spcPts val="400"/>
-              </a:spcAft>
-              <a:buSzPct val="100000"/>
-              <a:buChar char="•"/>
-            </a:pPr>
-            <a:r>
-              <a:rPr lang="en-US" sz="1250" dirty="0">
-                <a:solidFill>
-                  <a:srgbClr val="1A1F36"/>
-                </a:solidFill>
-                <a:latin typeface="Calibri" pitchFamily="34" charset="0"/>
-                <a:ea typeface="Calibri" pitchFamily="34" charset="-122"/>
-                <a:cs typeface="Calibri" pitchFamily="34" charset="-120"/>
-              </a:rPr>
-              <a:t>Ran both experiments and extracted results</a:t>
-            </a:r>
-            <a:endParaRPr lang="en-US" sz="1250" dirty="0"/>
-          </a:p>
-          <a:p>
-            <a:pPr marL="342900" indent="-342900">
-              <a:spcAft>
-                <a:spcPts val="400"/>
-              </a:spcAft>
-              <a:buSzPct val="100000"/>
-              <a:buChar char="•"/>
-            </a:pPr>
-            <a:r>
-              <a:rPr lang="en-US" sz="1250" dirty="0">
-                <a:solidFill>
-                  <a:srgbClr val="1A1F36"/>
-                </a:solidFill>
-                <a:latin typeface="Calibri" pitchFamily="34" charset="0"/>
-                <a:ea typeface="Calibri" pitchFamily="34" charset="-122"/>
-                <a:cs typeface="Calibri" pitchFamily="34" charset="-120"/>
-              </a:rPr>
-              <a:t>Updated sequential and parallel compute to match the new input function requirements</a:t>
-            </a:r>
-            <a:endParaRPr lang="en-US" sz="1250" dirty="0"/>
-          </a:p>
-        </p:txBody>
-      </p:sp>
-    </p:spTree>
-  </p:cSld>
-  <p:clrMapOvr>
-    <a:masterClrMapping/>
-  </p:clrMapOvr>
-</p:sld>
-</file>
-
-<file path=ppt/slides/slide20.xml><?xml version="1.0" encoding="utf-8"?>
+<file path=ppt/slides/slide21.xml><?xml version="1.0" encoding="utf-8"?>
 <p:sld xmlns:a="http://schemas.openxmlformats.org/drawingml/2006/main" xmlns:r="http://schemas.openxmlformats.org/officeDocument/2006/relationships" xmlns:p="http://schemas.openxmlformats.org/presentationml/2006/main">
   <p:cSld>
     <p:spTree>
@@ -13682,7 +14310,7 @@
 </p:sld>
 </file>
 
-<file path=ppt/slides/slide21.xml><?xml version="1.0" encoding="utf-8"?>
+<file path=ppt/slides/slide22.xml><?xml version="1.0" encoding="utf-8"?>
 <p:sld xmlns:a="http://schemas.openxmlformats.org/drawingml/2006/main" xmlns:r="http://schemas.openxmlformats.org/officeDocument/2006/relationships" xmlns:p="http://schemas.openxmlformats.org/presentationml/2006/main">
   <p:cSld>
     <p:spTree>
@@ -14094,7 +14722,7 @@
 </p:sld>
 </file>
 
-<file path=ppt/slides/slide22.xml><?xml version="1.0" encoding="utf-8"?>
+<file path=ppt/slides/slide23.xml><?xml version="1.0" encoding="utf-8"?>
 <p:sld xmlns:a="http://schemas.openxmlformats.org/drawingml/2006/main" xmlns:r="http://schemas.openxmlformats.org/officeDocument/2006/relationships" xmlns:p="http://schemas.openxmlformats.org/presentationml/2006/main">
   <p:cSld>
     <p:spTree>
@@ -14495,7 +15123,7 @@
 </p:sld>
 </file>
 
-<file path=ppt/slides/slide23.xml><?xml version="1.0" encoding="utf-8"?>
+<file path=ppt/slides/slide24.xml><?xml version="1.0" encoding="utf-8"?>
 <p:sld xmlns:a="http://schemas.openxmlformats.org/drawingml/2006/main" xmlns:r="http://schemas.openxmlformats.org/officeDocument/2006/relationships" xmlns:p="http://schemas.openxmlformats.org/presentationml/2006/main">
   <p:cSld>
     <p:spTree>
@@ -14960,7 +15588,7 @@
 </p:sld>
 </file>
 
-<file path=ppt/slides/slide24.xml><?xml version="1.0" encoding="utf-8"?>
+<file path=ppt/slides/slide25.xml><?xml version="1.0" encoding="utf-8"?>
 <p:sld xmlns:a="http://schemas.openxmlformats.org/drawingml/2006/main" xmlns:r="http://schemas.openxmlformats.org/officeDocument/2006/relationships" xmlns:p="http://schemas.openxmlformats.org/presentationml/2006/main">
   <p:cSld>
     <p:spTree>
@@ -18123,6 +18751,481 @@
 
 <file path=ppt/slides/slide5.xml><?xml version="1.0" encoding="utf-8"?>
 <p:sld xmlns:a="http://schemas.openxmlformats.org/drawingml/2006/main" xmlns:r="http://schemas.openxmlformats.org/officeDocument/2006/relationships" xmlns:p="http://schemas.openxmlformats.org/presentationml/2006/main">
+  <p:cSld>
+    <p:bg>
+      <p:bgPr>
+        <a:solidFill>
+          <a:srgbClr val="F0F4FF"/>
+        </a:solidFill>
+        <a:effectLst/>
+      </p:bgPr>
+    </p:bg>
+    <p:spTree>
+      <p:nvGrpSpPr>
+        <p:cNvPr id="1" name="">
+          <a:extLst>
+            <a:ext uri="{FF2B5EF4-FFF2-40B4-BE49-F238E27FC236}">
+              <a16:creationId xmlns:a16="http://schemas.microsoft.com/office/drawing/2014/main" id="{145F44F3-079A-9D47-92DA-4D571C8B85CD}"/>
+            </a:ext>
+          </a:extLst>
+        </p:cNvPr>
+        <p:cNvGrpSpPr/>
+        <p:nvPr/>
+      </p:nvGrpSpPr>
+      <p:grpSpPr>
+        <a:xfrm>
+          <a:off x="0" y="0"/>
+          <a:ext cx="0" cy="0"/>
+          <a:chOff x="0" y="0"/>
+          <a:chExt cx="0" cy="0"/>
+        </a:xfrm>
+      </p:grpSpPr>
+      <p:sp>
+        <p:nvSpPr>
+          <p:cNvPr id="2" name="Shape 0">
+            <a:extLst>
+              <a:ext uri="{FF2B5EF4-FFF2-40B4-BE49-F238E27FC236}">
+                <a16:creationId xmlns:a16="http://schemas.microsoft.com/office/drawing/2014/main" id="{F7271A21-82BD-7456-7DEA-33E9635A478E}"/>
+              </a:ext>
+            </a:extLst>
+          </p:cNvPr>
+          <p:cNvSpPr/>
+          <p:nvPr/>
+        </p:nvSpPr>
+        <p:spPr>
+          <a:xfrm>
+            <a:off x="0" y="0"/>
+            <a:ext cx="9144000" cy="868680"/>
+          </a:xfrm>
+          <a:prstGeom prst="rect">
+            <a:avLst/>
+          </a:prstGeom>
+          <a:solidFill>
+            <a:srgbClr val="1A1F36"/>
+          </a:solidFill>
+          <a:ln w="12700">
+            <a:solidFill>
+              <a:srgbClr val="1A1F36"/>
+            </a:solidFill>
+            <a:prstDash val="solid"/>
+          </a:ln>
+        </p:spPr>
+        <p:txBody>
+          <a:bodyPr/>
+          <a:lstStyle/>
+          <a:p>
+            <a:endParaRPr lang="en-US"/>
+          </a:p>
+        </p:txBody>
+      </p:sp>
+      <p:sp>
+        <p:nvSpPr>
+          <p:cNvPr id="3" name="Text 1">
+            <a:extLst>
+              <a:ext uri="{FF2B5EF4-FFF2-40B4-BE49-F238E27FC236}">
+                <a16:creationId xmlns:a16="http://schemas.microsoft.com/office/drawing/2014/main" id="{80C10F88-4DB5-F2E0-586F-5440AE72CBCD}"/>
+              </a:ext>
+            </a:extLst>
+          </p:cNvPr>
+          <p:cNvSpPr/>
+          <p:nvPr/>
+        </p:nvSpPr>
+        <p:spPr>
+          <a:xfrm>
+            <a:off x="365760" y="109728"/>
+            <a:ext cx="8412480" cy="640080"/>
+          </a:xfrm>
+          <a:prstGeom prst="rect">
+            <a:avLst/>
+          </a:prstGeom>
+          <a:noFill/>
+          <a:ln/>
+        </p:spPr>
+        <p:txBody>
+          <a:bodyPr wrap="square" lIns="0" tIns="0" rIns="0" bIns="0" rtlCol="0" anchor="ctr"/>
+          <a:lstStyle/>
+          <a:p>
+            <a:pPr marL="0" indent="0">
+              <a:buNone/>
+            </a:pPr>
+            <a:r>
+              <a:rPr lang="en-US" sz="2200" b="1" dirty="0">
+                <a:solidFill>
+                  <a:srgbClr val="FFFFFF"/>
+                </a:solidFill>
+                <a:latin typeface="Calibri" pitchFamily="34" charset="0"/>
+                <a:ea typeface="Calibri" pitchFamily="34" charset="-122"/>
+                <a:cs typeface="Calibri" pitchFamily="34" charset="-120"/>
+              </a:rPr>
+              <a:t>mmap_compute – side note</a:t>
+            </a:r>
+            <a:endParaRPr lang="en-US" sz="2200" dirty="0"/>
+          </a:p>
+        </p:txBody>
+      </p:sp>
+      <p:sp>
+        <p:nvSpPr>
+          <p:cNvPr id="4" name="Shape 2">
+            <a:extLst>
+              <a:ext uri="{FF2B5EF4-FFF2-40B4-BE49-F238E27FC236}">
+                <a16:creationId xmlns:a16="http://schemas.microsoft.com/office/drawing/2014/main" id="{235E5AD7-D6AF-304A-95F1-0150B2891D04}"/>
+              </a:ext>
+            </a:extLst>
+          </p:cNvPr>
+          <p:cNvSpPr/>
+          <p:nvPr/>
+        </p:nvSpPr>
+        <p:spPr>
+          <a:xfrm>
+            <a:off x="274320" y="960120"/>
+            <a:ext cx="8236634" cy="3886200"/>
+          </a:xfrm>
+          <a:prstGeom prst="rect">
+            <a:avLst/>
+          </a:prstGeom>
+          <a:solidFill>
+            <a:srgbClr val="FFFFFF"/>
+          </a:solidFill>
+          <a:ln w="12700">
+            <a:solidFill>
+              <a:srgbClr val="E0E6F8"/>
+            </a:solidFill>
+            <a:prstDash val="solid"/>
+          </a:ln>
+          <a:effectLst>
+            <a:outerShdw blurRad="101600" dist="38100" dir="8100000" algn="bl" rotWithShape="0">
+              <a:srgbClr val="000000">
+                <a:alpha val="18000"/>
+              </a:srgbClr>
+            </a:outerShdw>
+          </a:effectLst>
+        </p:spPr>
+        <p:txBody>
+          <a:bodyPr/>
+          <a:lstStyle/>
+          <a:p>
+            <a:endParaRPr lang="en-US"/>
+          </a:p>
+        </p:txBody>
+      </p:sp>
+      <p:sp>
+        <p:nvSpPr>
+          <p:cNvPr id="5" name="Shape 3">
+            <a:extLst>
+              <a:ext uri="{FF2B5EF4-FFF2-40B4-BE49-F238E27FC236}">
+                <a16:creationId xmlns:a16="http://schemas.microsoft.com/office/drawing/2014/main" id="{0D2E126B-3396-B78F-DD16-00618F2ECFCC}"/>
+              </a:ext>
+            </a:extLst>
+          </p:cNvPr>
+          <p:cNvSpPr/>
+          <p:nvPr/>
+        </p:nvSpPr>
+        <p:spPr>
+          <a:xfrm>
+            <a:off x="274320" y="960120"/>
+            <a:ext cx="3749040" cy="109728"/>
+          </a:xfrm>
+          <a:prstGeom prst="rect">
+            <a:avLst/>
+          </a:prstGeom>
+          <a:solidFill>
+            <a:srgbClr val="4F8EF7"/>
+          </a:solidFill>
+          <a:ln w="12700">
+            <a:solidFill>
+              <a:srgbClr val="4F8EF7"/>
+            </a:solidFill>
+            <a:prstDash val="solid"/>
+          </a:ln>
+        </p:spPr>
+        <p:txBody>
+          <a:bodyPr/>
+          <a:lstStyle/>
+          <a:p>
+            <a:endParaRPr lang="en-US"/>
+          </a:p>
+        </p:txBody>
+      </p:sp>
+      <p:sp>
+        <p:nvSpPr>
+          <p:cNvPr id="6" name="Text 4">
+            <a:extLst>
+              <a:ext uri="{FF2B5EF4-FFF2-40B4-BE49-F238E27FC236}">
+                <a16:creationId xmlns:a16="http://schemas.microsoft.com/office/drawing/2014/main" id="{5478A357-C34A-B008-7220-0C7182E54766}"/>
+              </a:ext>
+            </a:extLst>
+          </p:cNvPr>
+          <p:cNvSpPr/>
+          <p:nvPr/>
+        </p:nvSpPr>
+        <p:spPr>
+          <a:xfrm>
+            <a:off x="411480" y="1229867"/>
+            <a:ext cx="8008034" cy="3440607"/>
+          </a:xfrm>
+          <a:prstGeom prst="rect">
+            <a:avLst/>
+          </a:prstGeom>
+          <a:noFill/>
+          <a:ln/>
+        </p:spPr>
+        <p:txBody>
+          <a:bodyPr wrap="square" lIns="0" tIns="0" rIns="0" bIns="0" rtlCol="0" anchor="ctr"/>
+          <a:lstStyle/>
+          <a:p>
+            <a:r>
+              <a:rPr lang="en-US" b="1" dirty="0">
+                <a:solidFill>
+                  <a:srgbClr val="1A1F36"/>
+                </a:solidFill>
+                <a:latin typeface="Calibri" pitchFamily="34" charset="0"/>
+                <a:ea typeface="Calibri" pitchFamily="34" charset="-122"/>
+                <a:cs typeface="Calibri" pitchFamily="34" charset="-120"/>
+              </a:rPr>
+              <a:t>In this implementation, the partials array is declared as:</a:t>
+            </a:r>
+          </a:p>
+          <a:p>
+            <a:r>
+              <a:rPr lang="en-US" sz="1400" dirty="0">
+                <a:solidFill>
+                  <a:srgbClr val="4F8EF7"/>
+                </a:solidFill>
+                <a:latin typeface="Consolas" pitchFamily="34" charset="0"/>
+              </a:rPr>
+              <a:t>unsigned long *partials</a:t>
+            </a:r>
+          </a:p>
+          <a:p>
+            <a:endParaRPr lang="en-US" sz="1400" dirty="0">
+              <a:solidFill>
+                <a:srgbClr val="4F8EF7"/>
+              </a:solidFill>
+              <a:latin typeface="Consolas" pitchFamily="34" charset="0"/>
+            </a:endParaRPr>
+          </a:p>
+          <a:p>
+            <a:r>
+              <a:rPr lang="en-US" b="1" dirty="0">
+                <a:solidFill>
+                  <a:srgbClr val="1A1F36"/>
+                </a:solidFill>
+                <a:latin typeface="Calibri" pitchFamily="34" charset="0"/>
+                <a:ea typeface="Calibri" pitchFamily="34" charset="-122"/>
+                <a:cs typeface="Calibri" pitchFamily="34" charset="-120"/>
+              </a:rPr>
+              <a:t>However, when combining results, we cast values to int:</a:t>
+            </a:r>
+          </a:p>
+          <a:p>
+            <a:r>
+              <a:rPr lang="en-US" sz="1400" dirty="0">
+                <a:solidFill>
+                  <a:srgbClr val="4F8EF7"/>
+                </a:solidFill>
+                <a:latin typeface="Consolas" pitchFamily="34" charset="0"/>
+              </a:rPr>
+              <a:t>result = f((int)result, (int)partials[</a:t>
+            </a:r>
+            <a:r>
+              <a:rPr lang="en-US" sz="1400" dirty="0" err="1">
+                <a:solidFill>
+                  <a:srgbClr val="4F8EF7"/>
+                </a:solidFill>
+                <a:latin typeface="Consolas" pitchFamily="34" charset="0"/>
+              </a:rPr>
+              <a:t>i</a:t>
+            </a:r>
+            <a:r>
+              <a:rPr lang="en-US" sz="1400" dirty="0">
+                <a:solidFill>
+                  <a:srgbClr val="4F8EF7"/>
+                </a:solidFill>
+                <a:latin typeface="Consolas" pitchFamily="34" charset="0"/>
+              </a:rPr>
+              <a:t>]);</a:t>
+            </a:r>
+          </a:p>
+          <a:p>
+            <a:endParaRPr lang="en-US" sz="1400" dirty="0">
+              <a:solidFill>
+                <a:srgbClr val="4F8EF7"/>
+              </a:solidFill>
+              <a:latin typeface="Consolas" pitchFamily="34" charset="0"/>
+            </a:endParaRPr>
+          </a:p>
+          <a:p>
+            <a:endParaRPr lang="en-US" sz="1400" dirty="0">
+              <a:solidFill>
+                <a:srgbClr val="4F8EF7"/>
+              </a:solidFill>
+              <a:latin typeface="Consolas" pitchFamily="34" charset="0"/>
+            </a:endParaRPr>
+          </a:p>
+          <a:p>
+            <a:r>
+              <a:rPr lang="en-US" sz="1400" b="1" dirty="0"/>
+              <a:t>⚠️ </a:t>
+            </a:r>
+            <a:r>
+              <a:rPr lang="en-US" b="1" dirty="0">
+                <a:solidFill>
+                  <a:srgbClr val="1A1F36"/>
+                </a:solidFill>
+                <a:latin typeface="Calibri" pitchFamily="34" charset="0"/>
+                <a:ea typeface="Calibri" pitchFamily="34" charset="-122"/>
+                <a:cs typeface="Calibri" pitchFamily="34" charset="-120"/>
+              </a:rPr>
+              <a:t>Why this casting was used?</a:t>
+            </a:r>
+            <a:endParaRPr lang="en-US" dirty="0">
+              <a:solidFill>
+                <a:srgbClr val="1A1F36"/>
+              </a:solidFill>
+              <a:latin typeface="Calibri" pitchFamily="34" charset="0"/>
+              <a:ea typeface="Calibri" pitchFamily="34" charset="-122"/>
+              <a:cs typeface="Calibri" pitchFamily="34" charset="-120"/>
+            </a:endParaRPr>
+          </a:p>
+          <a:p>
+            <a:r>
+              <a:rPr lang="en-US" dirty="0">
+                <a:solidFill>
+                  <a:srgbClr val="1A1F36"/>
+                </a:solidFill>
+                <a:latin typeface="Calibri" pitchFamily="34" charset="0"/>
+                <a:ea typeface="Calibri" pitchFamily="34" charset="-122"/>
+                <a:cs typeface="Calibri" pitchFamily="34" charset="-120"/>
+              </a:rPr>
+              <a:t>The function f according to the project requirements is defined to accept:</a:t>
+            </a:r>
+          </a:p>
+          <a:p>
+            <a:r>
+              <a:rPr lang="en-US" dirty="0">
+                <a:solidFill>
+                  <a:srgbClr val="1A1F36"/>
+                </a:solidFill>
+                <a:latin typeface="Calibri" pitchFamily="34" charset="0"/>
+                <a:ea typeface="Calibri" pitchFamily="34" charset="-122"/>
+                <a:cs typeface="Calibri" pitchFamily="34" charset="-120"/>
+              </a:rPr>
+              <a:t>int, int → </a:t>
+            </a:r>
+            <a:r>
+              <a:rPr lang="en-US" dirty="0"/>
+              <a:t> unsigned long </a:t>
+            </a:r>
+            <a:endParaRPr lang="en-US" dirty="0">
+              <a:solidFill>
+                <a:srgbClr val="1A1F36"/>
+              </a:solidFill>
+              <a:latin typeface="Calibri" pitchFamily="34" charset="0"/>
+              <a:ea typeface="Calibri" pitchFamily="34" charset="-122"/>
+              <a:cs typeface="Calibri" pitchFamily="34" charset="-120"/>
+            </a:endParaRPr>
+          </a:p>
+          <a:p>
+            <a:r>
+              <a:rPr lang="en-US" dirty="0">
+                <a:solidFill>
+                  <a:srgbClr val="1A1F36"/>
+                </a:solidFill>
+                <a:latin typeface="Calibri" pitchFamily="34" charset="0"/>
+                <a:ea typeface="Calibri" pitchFamily="34" charset="-122"/>
+                <a:cs typeface="Calibri" pitchFamily="34" charset="-120"/>
+              </a:rPr>
+              <a:t>But intermediate results are stored as unsigned long </a:t>
+            </a:r>
+          </a:p>
+          <a:p>
+            <a:r>
+              <a:rPr lang="en-US" dirty="0">
+                <a:solidFill>
+                  <a:srgbClr val="1A1F36"/>
+                </a:solidFill>
+                <a:latin typeface="Calibri" pitchFamily="34" charset="0"/>
+                <a:ea typeface="Calibri" pitchFamily="34" charset="-122"/>
+                <a:cs typeface="Calibri" pitchFamily="34" charset="-120"/>
+              </a:rPr>
+              <a:t>Therefore, casting is required to match the required function signature</a:t>
+            </a:r>
+          </a:p>
+          <a:p>
+            <a:r>
+              <a:rPr lang="en-US" b="1" dirty="0">
+                <a:solidFill>
+                  <a:srgbClr val="1A1F36"/>
+                </a:solidFill>
+                <a:latin typeface="Calibri" pitchFamily="34" charset="0"/>
+                <a:ea typeface="Calibri" pitchFamily="34" charset="-122"/>
+                <a:cs typeface="Calibri" pitchFamily="34" charset="-120"/>
+              </a:rPr>
+              <a:t>To avoid casting, we should define a consistent function type:</a:t>
+            </a:r>
+          </a:p>
+          <a:p>
+            <a:r>
+              <a:rPr lang="en-US" sz="1400" dirty="0">
+                <a:solidFill>
+                  <a:srgbClr val="4F8EF7"/>
+                </a:solidFill>
+                <a:latin typeface="Consolas" pitchFamily="34" charset="0"/>
+              </a:rPr>
+              <a:t>unsigned long f(unsigned long a, unsigned long b);</a:t>
+            </a:r>
+          </a:p>
+        </p:txBody>
+      </p:sp>
+      <p:sp>
+        <p:nvSpPr>
+          <p:cNvPr id="7" name="Text 5">
+            <a:extLst>
+              <a:ext uri="{FF2B5EF4-FFF2-40B4-BE49-F238E27FC236}">
+                <a16:creationId xmlns:a16="http://schemas.microsoft.com/office/drawing/2014/main" id="{2E9EE1E0-08FE-DF3E-E3FB-F69E4A5A3D64}"/>
+              </a:ext>
+            </a:extLst>
+          </p:cNvPr>
+          <p:cNvSpPr/>
+          <p:nvPr/>
+        </p:nvSpPr>
+        <p:spPr>
+          <a:xfrm>
+            <a:off x="411480" y="1389888"/>
+            <a:ext cx="3474720" cy="3383280"/>
+          </a:xfrm>
+          <a:prstGeom prst="rect">
+            <a:avLst/>
+          </a:prstGeom>
+          <a:noFill/>
+          <a:ln/>
+        </p:spPr>
+        <p:txBody>
+          <a:bodyPr wrap="square" lIns="0" tIns="0" rIns="0" bIns="0" rtlCol="0" anchor="ctr"/>
+          <a:lstStyle/>
+          <a:p>
+            <a:pPr marL="0" indent="0">
+              <a:buNone/>
+            </a:pPr>
+            <a:endParaRPr lang="en-US" sz="1200" dirty="0"/>
+          </a:p>
+        </p:txBody>
+      </p:sp>
+    </p:spTree>
+    <p:extLst>
+      <p:ext uri="{BB962C8B-B14F-4D97-AF65-F5344CB8AC3E}">
+        <p14:creationId xmlns:p14="http://schemas.microsoft.com/office/powerpoint/2010/main" val="3682197118"/>
+      </p:ext>
+    </p:extLst>
+  </p:cSld>
+  <p:clrMapOvr>
+    <a:masterClrMapping/>
+  </p:clrMapOvr>
+</p:sld>
+</file>
+
+<file path=ppt/slides/slide6.xml><?xml version="1.0" encoding="utf-8"?>
+<p:sld xmlns:a="http://schemas.openxmlformats.org/drawingml/2006/main" xmlns:r="http://schemas.openxmlformats.org/officeDocument/2006/relationships" xmlns:p="http://schemas.openxmlformats.org/presentationml/2006/main">
   <p:cSld name="Slide 5">
     <p:bg>
       <p:bgPr>
@@ -19301,7 +20404,7 @@
 </p:sld>
 </file>
 
-<file path=ppt/slides/slide6.xml><?xml version="1.0" encoding="utf-8"?>
+<file path=ppt/slides/slide7.xml><?xml version="1.0" encoding="utf-8"?>
 <p:sld xmlns:a="http://schemas.openxmlformats.org/drawingml/2006/main" xmlns:r="http://schemas.openxmlformats.org/officeDocument/2006/relationships" xmlns:p="http://schemas.openxmlformats.org/presentationml/2006/main">
   <p:cSld>
     <p:bg>
@@ -19428,7 +20531,7 @@
 </p:sld>
 </file>
 
-<file path=ppt/slides/slide7.xml><?xml version="1.0" encoding="utf-8"?>
+<file path=ppt/slides/slide8.xml><?xml version="1.0" encoding="utf-8"?>
 <p:sld xmlns:a="http://schemas.openxmlformats.org/drawingml/2006/main" xmlns:r="http://schemas.openxmlformats.org/officeDocument/2006/relationships" xmlns:p="http://schemas.openxmlformats.org/presentationml/2006/main">
   <p:cSld>
     <p:spTree>
@@ -19999,7 +21102,7 @@
 </p:sld>
 </file>
 
-<file path=ppt/slides/slide8.xml><?xml version="1.0" encoding="utf-8"?>
+<file path=ppt/slides/slide9.xml><?xml version="1.0" encoding="utf-8"?>
 <p:sld xmlns:a="http://schemas.openxmlformats.org/drawingml/2006/main" xmlns:r="http://schemas.openxmlformats.org/officeDocument/2006/relationships" xmlns:p="http://schemas.openxmlformats.org/presentationml/2006/main">
   <p:cSld>
     <p:spTree>
@@ -20364,525 +21467,6 @@
         <p14:creationId xmlns:p14="http://schemas.microsoft.com/office/powerpoint/2010/main" val="1917002051"/>
       </p:ext>
     </p:extLst>
-  </p:cSld>
-  <p:clrMapOvr>
-    <a:masterClrMapping/>
-  </p:clrMapOvr>
-</p:sld>
-</file>
-
-<file path=ppt/slides/slide9.xml><?xml version="1.0" encoding="utf-8"?>
-<p:sld xmlns:a="http://schemas.openxmlformats.org/drawingml/2006/main" xmlns:r="http://schemas.openxmlformats.org/officeDocument/2006/relationships" xmlns:p="http://schemas.openxmlformats.org/presentationml/2006/main">
-  <p:cSld>
-    <p:spTree>
-      <p:nvGrpSpPr>
-        <p:cNvPr id="1" name=""/>
-        <p:cNvGrpSpPr/>
-        <p:nvPr/>
-      </p:nvGrpSpPr>
-      <p:grpSpPr>
-        <a:xfrm>
-          <a:off x="0" y="0"/>
-          <a:ext cx="0" cy="0"/>
-          <a:chOff x="0" y="0"/>
-          <a:chExt cx="0" cy="0"/>
-        </a:xfrm>
-      </p:grpSpPr>
-      <p:sp>
-        <p:nvSpPr>
-          <p:cNvPr id="2" name="Shape 0"/>
-          <p:cNvSpPr/>
-          <p:nvPr/>
-        </p:nvSpPr>
-        <p:spPr>
-          <a:xfrm>
-            <a:off x="0" y="0"/>
-            <a:ext cx="9144000" cy="777240"/>
-          </a:xfrm>
-          <a:prstGeom prst="rect">
-            <a:avLst/>
-          </a:prstGeom>
-          <a:solidFill>
-            <a:srgbClr val="00A896"/>
-          </a:solidFill>
-          <a:ln w="12700">
-            <a:solidFill>
-              <a:srgbClr val="00A896"/>
-            </a:solidFill>
-            <a:prstDash val="solid"/>
-          </a:ln>
-        </p:spPr>
-        <p:txBody>
-          <a:bodyPr/>
-          <a:lstStyle/>
-          <a:p>
-            <a:endParaRPr lang="en-US"/>
-          </a:p>
-        </p:txBody>
-      </p:sp>
-      <p:sp>
-        <p:nvSpPr>
-          <p:cNvPr id="3" name="Text 1"/>
-          <p:cNvSpPr/>
-          <p:nvPr/>
-        </p:nvSpPr>
-        <p:spPr>
-          <a:xfrm>
-            <a:off x="365760" y="0"/>
-            <a:ext cx="8412480" cy="777240"/>
-          </a:xfrm>
-          <a:prstGeom prst="rect">
-            <a:avLst/>
-          </a:prstGeom>
-          <a:noFill/>
-          <a:ln/>
-        </p:spPr>
-        <p:txBody>
-          <a:bodyPr wrap="square" lIns="0" tIns="0" rIns="0" bIns="0" rtlCol="0" anchor="ctr"/>
-          <a:lstStyle/>
-          <a:p>
-            <a:pPr marL="0" indent="0">
-              <a:buNone/>
-            </a:pPr>
-            <a:r>
-              <a:rPr lang="en-US" sz="2400" b="1" dirty="0">
-                <a:solidFill>
-                  <a:srgbClr val="FFFFFF"/>
-                </a:solidFill>
-                <a:latin typeface="Calibri" pitchFamily="34" charset="0"/>
-                <a:ea typeface="Calibri" pitchFamily="34" charset="-122"/>
-                <a:cs typeface="Calibri" pitchFamily="34" charset="-120"/>
-              </a:rPr>
-              <a:t>02  parallel_compute — Pseudo-code</a:t>
-            </a:r>
-            <a:endParaRPr lang="en-US" sz="2400" dirty="0"/>
-          </a:p>
-        </p:txBody>
-      </p:sp>
-      <p:sp>
-        <p:nvSpPr>
-          <p:cNvPr id="4" name="Shape 2"/>
-          <p:cNvSpPr/>
-          <p:nvPr/>
-        </p:nvSpPr>
-        <p:spPr>
-          <a:xfrm>
-            <a:off x="320040" y="914400"/>
-            <a:ext cx="8503920" cy="3977640"/>
-          </a:xfrm>
-          <a:prstGeom prst="rect">
-            <a:avLst/>
-          </a:prstGeom>
-          <a:solidFill>
-            <a:srgbClr val="111D2A"/>
-          </a:solidFill>
-          <a:ln w="12700">
-            <a:solidFill>
-              <a:srgbClr val="3D5166"/>
-            </a:solidFill>
-            <a:prstDash val="solid"/>
-          </a:ln>
-          <a:effectLst>
-            <a:outerShdw blurRad="101600" dist="38100" dir="8100000" algn="bl" rotWithShape="0">
-              <a:srgbClr val="000000">
-                <a:alpha val="30000"/>
-              </a:srgbClr>
-            </a:outerShdw>
-          </a:effectLst>
-        </p:spPr>
-        <p:txBody>
-          <a:bodyPr/>
-          <a:lstStyle/>
-          <a:p>
-            <a:endParaRPr lang="en-US"/>
-          </a:p>
-        </p:txBody>
-      </p:sp>
-      <p:sp>
-        <p:nvSpPr>
-          <p:cNvPr id="5" name="Text 3"/>
-          <p:cNvSpPr/>
-          <p:nvPr/>
-        </p:nvSpPr>
-        <p:spPr>
-          <a:xfrm>
-            <a:off x="502920" y="1005840"/>
-            <a:ext cx="8229600" cy="3749040"/>
-          </a:xfrm>
-          <a:prstGeom prst="rect">
-            <a:avLst/>
-          </a:prstGeom>
-          <a:noFill/>
-          <a:ln/>
-        </p:spPr>
-        <p:txBody>
-          <a:bodyPr wrap="square" rtlCol="0" anchor="ctr"/>
-          <a:lstStyle/>
-          <a:p>
-            <a:pPr marL="0" indent="0" algn="l">
-              <a:buNone/>
-            </a:pPr>
-            <a:r>
-              <a:rPr lang="en-US" sz="1150" b="1" dirty="0">
-                <a:solidFill>
-                  <a:srgbClr val="FFB347"/>
-                </a:solidFill>
-                <a:latin typeface="Consolas" pitchFamily="34" charset="0"/>
-                <a:ea typeface="Consolas" pitchFamily="34" charset="-122"/>
-                <a:cs typeface="Consolas" pitchFamily="34" charset="-120"/>
-              </a:rPr>
-              <a:t>FUNCTION </a:t>
-            </a:r>
-            <a:r>
-              <a:rPr lang="en-US" sz="1150" b="1" dirty="0">
-                <a:solidFill>
-                  <a:srgbClr val="00C9A7"/>
-                </a:solidFill>
-                <a:latin typeface="Consolas" pitchFamily="34" charset="0"/>
-                <a:ea typeface="Consolas" pitchFamily="34" charset="-122"/>
-                <a:cs typeface="Consolas" pitchFamily="34" charset="-120"/>
-              </a:rPr>
-              <a:t>parallel_compute</a:t>
-            </a:r>
-            <a:r>
-              <a:rPr lang="en-US" sz="1150" dirty="0">
-                <a:solidFill>
-                  <a:srgbClr val="FFFFFF"/>
-                </a:solidFill>
-                <a:latin typeface="Consolas" pitchFamily="34" charset="0"/>
-                <a:ea typeface="Consolas" pitchFamily="34" charset="-122"/>
-                <a:cs typeface="Consolas" pitchFamily="34" charset="-120"/>
-              </a:rPr>
-              <a:t>(filepath, n_proc, f):
-    nums  ← </a:t>
-            </a:r>
-            <a:r>
-              <a:rPr lang="en-US" sz="1150" dirty="0">
-                <a:solidFill>
-                  <a:srgbClr val="00C9A7"/>
-                </a:solidFill>
-                <a:latin typeface="Consolas" pitchFamily="34" charset="0"/>
-                <a:ea typeface="Consolas" pitchFamily="34" charset="-122"/>
-                <a:cs typeface="Consolas" pitchFamily="34" charset="-120"/>
-              </a:rPr>
-              <a:t>read_numbers</a:t>
-            </a:r>
-            <a:r>
-              <a:rPr lang="en-US" sz="1150" dirty="0">
-                <a:solidFill>
-                  <a:srgbClr val="FFFFFF"/>
-                </a:solidFill>
-                <a:latin typeface="Consolas" pitchFamily="34" charset="0"/>
-                <a:ea typeface="Consolas" pitchFamily="34" charset="-122"/>
-                <a:cs typeface="Consolas" pitchFamily="34" charset="-120"/>
-              </a:rPr>
-              <a:t>(filepath)
-    chunk ← len(nums) / n_proc
-    remainder ← len(nums) % n_proc
-</a:t>
-            </a:r>
-            <a:r>
-              <a:rPr lang="en-US" sz="1150" dirty="0">
-                <a:solidFill>
-                  <a:srgbClr val="FFB347"/>
-                </a:solidFill>
-                <a:latin typeface="Consolas" pitchFamily="34" charset="0"/>
-                <a:ea typeface="Consolas" pitchFamily="34" charset="-122"/>
-                <a:cs typeface="Consolas" pitchFamily="34" charset="-120"/>
-              </a:rPr>
-              <a:t>    FOR </a:t>
-            </a:r>
-            <a:r>
-              <a:rPr lang="en-US" sz="1150" dirty="0">
-                <a:solidFill>
-                  <a:srgbClr val="FFFFFF"/>
-                </a:solidFill>
-                <a:latin typeface="Consolas" pitchFamily="34" charset="0"/>
-                <a:ea typeface="Consolas" pitchFamily="34" charset="-122"/>
-                <a:cs typeface="Consolas" pitchFamily="34" charset="-120"/>
-              </a:rPr>
-              <a:t>i = 0 </a:t>
-            </a:r>
-            <a:r>
-              <a:rPr lang="en-US" sz="1150" dirty="0">
-                <a:solidFill>
-                  <a:srgbClr val="FFB347"/>
-                </a:solidFill>
-                <a:latin typeface="Consolas" pitchFamily="34" charset="0"/>
-                <a:ea typeface="Consolas" pitchFamily="34" charset="-122"/>
-                <a:cs typeface="Consolas" pitchFamily="34" charset="-120"/>
-              </a:rPr>
-              <a:t>TO </a:t>
-            </a:r>
-            <a:r>
-              <a:rPr lang="en-US" sz="1150" dirty="0">
-                <a:solidFill>
-                  <a:srgbClr val="FFFFFF"/>
-                </a:solidFill>
-                <a:latin typeface="Consolas" pitchFamily="34" charset="0"/>
-                <a:ea typeface="Consolas" pitchFamily="34" charset="-122"/>
-                <a:cs typeface="Consolas" pitchFamily="34" charset="-120"/>
-              </a:rPr>
-              <a:t>n_proc - 1 :
-</a:t>
-            </a:r>
-            <a:r>
-              <a:rPr lang="en-US" sz="1150" dirty="0">
-                <a:solidFill>
-                  <a:srgbClr val="8BA3B8"/>
-                </a:solidFill>
-                <a:latin typeface="Consolas" pitchFamily="34" charset="0"/>
-                <a:ea typeface="Consolas" pitchFamily="34" charset="-122"/>
-                <a:cs typeface="Consolas" pitchFamily="34" charset="-120"/>
-              </a:rPr>
-              <a:t>        create ctrl_pipe[i], res_pipe[i]
-        fork child i
-</a:t>
-            </a:r>
-            <a:r>
-              <a:rPr lang="en-US" sz="1150" dirty="0">
-                <a:solidFill>
-                  <a:srgbClr val="FFB347"/>
-                </a:solidFill>
-                <a:latin typeface="Consolas" pitchFamily="34" charset="0"/>
-                <a:ea typeface="Consolas" pitchFamily="34" charset="-122"/>
-                <a:cs typeface="Consolas" pitchFamily="34" charset="-120"/>
-              </a:rPr>
-              <a:t>        IF </a:t>
-            </a:r>
-            <a:r>
-              <a:rPr lang="en-US" sz="1150" dirty="0">
-                <a:solidFill>
-                  <a:srgbClr val="FFFFFF"/>
-                </a:solidFill>
-                <a:latin typeface="Consolas" pitchFamily="34" charset="0"/>
-                <a:ea typeface="Consolas" pitchFamily="34" charset="-122"/>
-                <a:cs typeface="Consolas" pitchFamily="34" charset="-120"/>
-              </a:rPr>
-              <a:t>child :
-            start, end ← </a:t>
-            </a:r>
-            <a:r>
-              <a:rPr lang="en-US" sz="1150" dirty="0">
-                <a:solidFill>
-                  <a:srgbClr val="00C9A7"/>
-                </a:solidFill>
-                <a:latin typeface="Consolas" pitchFamily="34" charset="0"/>
-                <a:ea typeface="Consolas" pitchFamily="34" charset="-122"/>
-                <a:cs typeface="Consolas" pitchFamily="34" charset="-120"/>
-              </a:rPr>
-              <a:t>read</a:t>
-            </a:r>
-            <a:r>
-              <a:rPr lang="en-US" sz="1150" dirty="0">
-                <a:solidFill>
-                  <a:srgbClr val="8BA3B8"/>
-                </a:solidFill>
-                <a:latin typeface="Consolas" pitchFamily="34" charset="0"/>
-                <a:ea typeface="Consolas" pitchFamily="34" charset="-122"/>
-                <a:cs typeface="Consolas" pitchFamily="34" charset="-120"/>
-              </a:rPr>
-              <a:t>(ctrl_pipe[i])      // receive slice bounds
-</a:t>
-            </a:r>
-            <a:r>
-              <a:rPr lang="en-US" sz="1150" dirty="0">
-                <a:solidFill>
-                  <a:srgbClr val="FFFFFF"/>
-                </a:solidFill>
-                <a:latin typeface="Consolas" pitchFamily="34" charset="0"/>
-                <a:ea typeface="Consolas" pitchFamily="34" charset="-122"/>
-                <a:cs typeface="Consolas" pitchFamily="34" charset="-120"/>
-              </a:rPr>
-              <a:t>            partial ← sequential_compute(nums[start..end], f)
-            </a:t>
-            </a:r>
-            <a:r>
-              <a:rPr lang="en-US" sz="1150" dirty="0">
-                <a:solidFill>
-                  <a:srgbClr val="00C9A7"/>
-                </a:solidFill>
-                <a:latin typeface="Consolas" pitchFamily="34" charset="0"/>
-                <a:ea typeface="Consolas" pitchFamily="34" charset="-122"/>
-                <a:cs typeface="Consolas" pitchFamily="34" charset="-120"/>
-              </a:rPr>
-              <a:t>write</a:t>
-            </a:r>
-            <a:r>
-              <a:rPr lang="en-US" sz="1150" dirty="0">
-                <a:solidFill>
-                  <a:srgbClr val="FFFFFF"/>
-                </a:solidFill>
-                <a:latin typeface="Consolas" pitchFamily="34" charset="0"/>
-                <a:ea typeface="Consolas" pitchFamily="34" charset="-122"/>
-                <a:cs typeface="Consolas" pitchFamily="34" charset="-120"/>
-              </a:rPr>
-              <a:t>(res_pipe[i], partial) ; exit()
-</a:t>
-            </a:r>
-            <a:r>
-              <a:rPr lang="en-US" sz="1150" dirty="0">
-                <a:solidFill>
-                  <a:srgbClr val="FFB347"/>
-                </a:solidFill>
-                <a:latin typeface="Consolas" pitchFamily="34" charset="0"/>
-                <a:ea typeface="Consolas" pitchFamily="34" charset="-122"/>
-                <a:cs typeface="Consolas" pitchFamily="34" charset="-120"/>
-              </a:rPr>
-              <a:t>        ELSE </a:t>
-            </a:r>
-            <a:r>
-              <a:rPr lang="en-US" sz="1150" dirty="0">
-                <a:solidFill>
-                  <a:srgbClr val="FFFFFF"/>
-                </a:solidFill>
-                <a:latin typeface="Consolas" pitchFamily="34" charset="0"/>
-                <a:ea typeface="Consolas" pitchFamily="34" charset="-122"/>
-                <a:cs typeface="Consolas" pitchFamily="34" charset="-120"/>
-              </a:rPr>
-              <a:t>(parent) : </a:t>
-            </a:r>
-            <a:r>
-              <a:rPr lang="en-US" sz="1150" dirty="0">
-                <a:solidFill>
-                  <a:srgbClr val="00C9A7"/>
-                </a:solidFill>
-                <a:latin typeface="Consolas" pitchFamily="34" charset="0"/>
-                <a:ea typeface="Consolas" pitchFamily="34" charset="-122"/>
-                <a:cs typeface="Consolas" pitchFamily="34" charset="-120"/>
-              </a:rPr>
-              <a:t>write</a:t>
-            </a:r>
-            <a:r>
-              <a:rPr lang="en-US" sz="1150" dirty="0">
-                <a:solidFill>
-                  <a:srgbClr val="FFFFFF"/>
-                </a:solidFill>
-                <a:latin typeface="Consolas" pitchFamily="34" charset="0"/>
-                <a:ea typeface="Consolas" pitchFamily="34" charset="-122"/>
-                <a:cs typeface="Consolas" pitchFamily="34" charset="-120"/>
-              </a:rPr>
-              <a:t>(ctrl_pipe[i], start, end)
-</a:t>
-            </a:r>
-            <a:r>
-              <a:rPr lang="en-US" sz="1150" dirty="0">
-                <a:solidFill>
-                  <a:srgbClr val="00C9A7"/>
-                </a:solidFill>
-                <a:latin typeface="Consolas" pitchFamily="34" charset="0"/>
-                <a:ea typeface="Consolas" pitchFamily="34" charset="-122"/>
-                <a:cs typeface="Consolas" pitchFamily="34" charset="-120"/>
-              </a:rPr>
-              <a:t>    wait</a:t>
-            </a:r>
-            <a:r>
-              <a:rPr lang="en-US" sz="1150" dirty="0">
-                <a:solidFill>
-                  <a:srgbClr val="FFFFFF"/>
-                </a:solidFill>
-                <a:latin typeface="Consolas" pitchFamily="34" charset="0"/>
-                <a:ea typeface="Consolas" pitchFamily="34" charset="-122"/>
-                <a:cs typeface="Consolas" pitchFamily="34" charset="-120"/>
-              </a:rPr>
-              <a:t>() for all children
-    result ← </a:t>
-            </a:r>
-            <a:r>
-              <a:rPr lang="en-US" sz="1150" dirty="0">
-                <a:solidFill>
-                  <a:srgbClr val="00C9A7"/>
-                </a:solidFill>
-                <a:latin typeface="Consolas" pitchFamily="34" charset="0"/>
-                <a:ea typeface="Consolas" pitchFamily="34" charset="-122"/>
-                <a:cs typeface="Consolas" pitchFamily="34" charset="-120"/>
-              </a:rPr>
-              <a:t>read</a:t>
-            </a:r>
-            <a:r>
-              <a:rPr lang="en-US" sz="1150" dirty="0">
-                <a:solidFill>
-                  <a:srgbClr val="FFFFFF"/>
-                </a:solidFill>
-                <a:latin typeface="Consolas" pitchFamily="34" charset="0"/>
-                <a:ea typeface="Consolas" pitchFamily="34" charset="-122"/>
-                <a:cs typeface="Consolas" pitchFamily="34" charset="-120"/>
-              </a:rPr>
-              <a:t>(res_pipe[0])
-</a:t>
-            </a:r>
-            <a:r>
-              <a:rPr lang="en-US" sz="1150" dirty="0">
-                <a:solidFill>
-                  <a:srgbClr val="FFB347"/>
-                </a:solidFill>
-                <a:latin typeface="Consolas" pitchFamily="34" charset="0"/>
-                <a:ea typeface="Consolas" pitchFamily="34" charset="-122"/>
-                <a:cs typeface="Consolas" pitchFamily="34" charset="-120"/>
-              </a:rPr>
-              <a:t>    FOR </a:t>
-            </a:r>
-            <a:r>
-              <a:rPr lang="en-US" sz="1150" dirty="0">
-                <a:solidFill>
-                  <a:srgbClr val="FFFFFF"/>
-                </a:solidFill>
-                <a:latin typeface="Consolas" pitchFamily="34" charset="0"/>
-                <a:ea typeface="Consolas" pitchFamily="34" charset="-122"/>
-                <a:cs typeface="Consolas" pitchFamily="34" charset="-120"/>
-              </a:rPr>
-              <a:t>i = 1 TO n_proc-1 : result ← f(result, </a:t>
-            </a:r>
-            <a:r>
-              <a:rPr lang="en-US" sz="1150" dirty="0">
-                <a:solidFill>
-                  <a:srgbClr val="00C9A7"/>
-                </a:solidFill>
-                <a:latin typeface="Consolas" pitchFamily="34" charset="0"/>
-                <a:ea typeface="Consolas" pitchFamily="34" charset="-122"/>
-                <a:cs typeface="Consolas" pitchFamily="34" charset="-120"/>
-              </a:rPr>
-              <a:t>read</a:t>
-            </a:r>
-            <a:r>
-              <a:rPr lang="en-US" sz="1150" dirty="0">
-                <a:solidFill>
-                  <a:srgbClr val="FFFFFF"/>
-                </a:solidFill>
-                <a:latin typeface="Consolas" pitchFamily="34" charset="0"/>
-                <a:ea typeface="Consolas" pitchFamily="34" charset="-122"/>
-                <a:cs typeface="Consolas" pitchFamily="34" charset="-120"/>
-              </a:rPr>
-              <a:t>(res_pipe[i]))
-</a:t>
-            </a:r>
-            <a:r>
-              <a:rPr lang="en-US" sz="1150" dirty="0">
-                <a:solidFill>
-                  <a:srgbClr val="FFB347"/>
-                </a:solidFill>
-                <a:latin typeface="Consolas" pitchFamily="34" charset="0"/>
-                <a:ea typeface="Consolas" pitchFamily="34" charset="-122"/>
-                <a:cs typeface="Consolas" pitchFamily="34" charset="-120"/>
-              </a:rPr>
-              <a:t>    RETURN </a:t>
-            </a:r>
-            <a:r>
-              <a:rPr lang="en-US" sz="1150" dirty="0">
-                <a:solidFill>
-                  <a:srgbClr val="4CAF86"/>
-                </a:solidFill>
-                <a:latin typeface="Consolas" pitchFamily="34" charset="0"/>
-                <a:ea typeface="Consolas" pitchFamily="34" charset="-122"/>
-                <a:cs typeface="Consolas" pitchFamily="34" charset="-120"/>
-              </a:rPr>
-              <a:t>result</a:t>
-            </a:r>
-            <a:endParaRPr lang="en-US" sz="1150" dirty="0"/>
-          </a:p>
-        </p:txBody>
-      </p:sp>
-    </p:spTree>
   </p:cSld>
   <p:clrMapOvr>
     <a:masterClrMapping/>

</xml_diff>

<commit_message>
adding github repo, updating team roles slide
</commit_message>
<xml_diff>
--- a/project_slides.pptx
+++ b/project_slides.pptx
@@ -5,34 +5,35 @@
     <p:sldMasterId id="2147483648" r:id="rId1"/>
   </p:sldMasterIdLst>
   <p:notesMasterIdLst>
-    <p:notesMasterId r:id="rId27"/>
+    <p:notesMasterId r:id="rId28"/>
   </p:notesMasterIdLst>
   <p:sldIdLst>
     <p:sldId id="256" r:id="rId2"/>
     <p:sldId id="257" r:id="rId3"/>
-    <p:sldId id="258" r:id="rId4"/>
-    <p:sldId id="259" r:id="rId5"/>
-    <p:sldId id="281" r:id="rId6"/>
-    <p:sldId id="260" r:id="rId7"/>
-    <p:sldId id="268" r:id="rId8"/>
-    <p:sldId id="269" r:id="rId9"/>
-    <p:sldId id="273" r:id="rId10"/>
-    <p:sldId id="274" r:id="rId11"/>
-    <p:sldId id="261" r:id="rId12"/>
-    <p:sldId id="263" r:id="rId13"/>
-    <p:sldId id="264" r:id="rId14"/>
-    <p:sldId id="265" r:id="rId15"/>
-    <p:sldId id="266" r:id="rId16"/>
-    <p:sldId id="267" r:id="rId17"/>
-    <p:sldId id="262" r:id="rId18"/>
-    <p:sldId id="277" r:id="rId19"/>
-    <p:sldId id="276" r:id="rId20"/>
-    <p:sldId id="275" r:id="rId21"/>
-    <p:sldId id="270" r:id="rId22"/>
-    <p:sldId id="271" r:id="rId23"/>
-    <p:sldId id="278" r:id="rId24"/>
-    <p:sldId id="279" r:id="rId25"/>
-    <p:sldId id="280" r:id="rId26"/>
+    <p:sldId id="282" r:id="rId4"/>
+    <p:sldId id="258" r:id="rId5"/>
+    <p:sldId id="259" r:id="rId6"/>
+    <p:sldId id="281" r:id="rId7"/>
+    <p:sldId id="260" r:id="rId8"/>
+    <p:sldId id="268" r:id="rId9"/>
+    <p:sldId id="269" r:id="rId10"/>
+    <p:sldId id="273" r:id="rId11"/>
+    <p:sldId id="274" r:id="rId12"/>
+    <p:sldId id="261" r:id="rId13"/>
+    <p:sldId id="263" r:id="rId14"/>
+    <p:sldId id="264" r:id="rId15"/>
+    <p:sldId id="265" r:id="rId16"/>
+    <p:sldId id="266" r:id="rId17"/>
+    <p:sldId id="267" r:id="rId18"/>
+    <p:sldId id="262" r:id="rId19"/>
+    <p:sldId id="277" r:id="rId20"/>
+    <p:sldId id="276" r:id="rId21"/>
+    <p:sldId id="275" r:id="rId22"/>
+    <p:sldId id="270" r:id="rId23"/>
+    <p:sldId id="271" r:id="rId24"/>
+    <p:sldId id="278" r:id="rId25"/>
+    <p:sldId id="279" r:id="rId26"/>
+    <p:sldId id="280" r:id="rId27"/>
   </p:sldIdLst>
   <p:sldSz cx="9144000" cy="5143500" type="screen16x9"/>
   <p:notesSz cx="5143500" cy="9144000"/>
@@ -5946,7 +5947,13 @@
   <p:cSld>
     <p:spTree>
       <p:nvGrpSpPr>
-        <p:cNvPr id="1" name=""/>
+        <p:cNvPr id="1" name="">
+          <a:extLst>
+            <a:ext uri="{FF2B5EF4-FFF2-40B4-BE49-F238E27FC236}">
+              <a16:creationId xmlns:a16="http://schemas.microsoft.com/office/drawing/2014/main" id="{56C8BBE2-7578-9BEB-14BD-464DB3ACA1AC}"/>
+            </a:ext>
+          </a:extLst>
+        </p:cNvPr>
         <p:cNvGrpSpPr/>
         <p:nvPr/>
       </p:nvGrpSpPr>
@@ -5960,7 +5967,13 @@
       </p:grpSpPr>
       <p:sp>
         <p:nvSpPr>
-          <p:cNvPr id="2" name="Slide Image Placeholder 1"/>
+          <p:cNvPr id="2" name="Slide Image Placeholder 1">
+            <a:extLst>
+              <a:ext uri="{FF2B5EF4-FFF2-40B4-BE49-F238E27FC236}">
+                <a16:creationId xmlns:a16="http://schemas.microsoft.com/office/drawing/2014/main" id="{2CB27920-DE4C-B486-AD25-3E2134243777}"/>
+              </a:ext>
+            </a:extLst>
+          </p:cNvPr>
           <p:cNvSpPr>
             <a:spLocks noGrp="1" noRot="1" noChangeAspect="1"/>
           </p:cNvSpPr>
@@ -5972,7 +5985,13 @@
       </p:sp>
       <p:sp>
         <p:nvSpPr>
-          <p:cNvPr id="3" name="Notes Placeholder 2"/>
+          <p:cNvPr id="3" name="Notes Placeholder 2">
+            <a:extLst>
+              <a:ext uri="{FF2B5EF4-FFF2-40B4-BE49-F238E27FC236}">
+                <a16:creationId xmlns:a16="http://schemas.microsoft.com/office/drawing/2014/main" id="{E6031FEF-273E-9FF7-5447-19A6D6A871CD}"/>
+              </a:ext>
+            </a:extLst>
+          </p:cNvPr>
           <p:cNvSpPr>
             <a:spLocks noGrp="1"/>
           </p:cNvSpPr>
@@ -5991,7 +6010,13 @@
       </p:sp>
       <p:sp>
         <p:nvSpPr>
-          <p:cNvPr id="4" name="Slide Number Placeholder 3"/>
+          <p:cNvPr id="4" name="Slide Number Placeholder 3">
+            <a:extLst>
+              <a:ext uri="{FF2B5EF4-FFF2-40B4-BE49-F238E27FC236}">
+                <a16:creationId xmlns:a16="http://schemas.microsoft.com/office/drawing/2014/main" id="{0009025C-3118-B675-5E42-3686485C2256}"/>
+              </a:ext>
+            </a:extLst>
+          </p:cNvPr>
           <p:cNvSpPr>
             <a:spLocks noGrp="1"/>
           </p:cNvSpPr>
@@ -6015,7 +6040,7 @@
     </p:spTree>
     <p:extLst>
       <p:ext uri="{BB962C8B-B14F-4D97-AF65-F5344CB8AC3E}">
-        <p14:creationId xmlns:p14="http://schemas.microsoft.com/office/powerpoint/2010/main" val="1024086991"/>
+        <p14:creationId xmlns:p14="http://schemas.microsoft.com/office/powerpoint/2010/main" val="3630224614"/>
       </p:ext>
     </p:extLst>
   </p:cSld>
@@ -6114,6 +6139,90 @@
   <p:cSld>
     <p:spTree>
       <p:nvGrpSpPr>
+        <p:cNvPr id="1" name=""/>
+        <p:cNvGrpSpPr/>
+        <p:nvPr/>
+      </p:nvGrpSpPr>
+      <p:grpSpPr>
+        <a:xfrm>
+          <a:off x="0" y="0"/>
+          <a:ext cx="0" cy="0"/>
+          <a:chOff x="0" y="0"/>
+          <a:chExt cx="0" cy="0"/>
+        </a:xfrm>
+      </p:grpSpPr>
+      <p:sp>
+        <p:nvSpPr>
+          <p:cNvPr id="2" name="Slide Image Placeholder 1"/>
+          <p:cNvSpPr>
+            <a:spLocks noGrp="1" noRot="1" noChangeAspect="1"/>
+          </p:cNvSpPr>
+          <p:nvPr>
+            <p:ph type="sldImg"/>
+          </p:nvPr>
+        </p:nvSpPr>
+        <p:spPr/>
+      </p:sp>
+      <p:sp>
+        <p:nvSpPr>
+          <p:cNvPr id="3" name="Notes Placeholder 2"/>
+          <p:cNvSpPr>
+            <a:spLocks noGrp="1"/>
+          </p:cNvSpPr>
+          <p:nvPr>
+            <p:ph type="body" idx="1"/>
+          </p:nvPr>
+        </p:nvSpPr>
+        <p:spPr/>
+        <p:txBody>
+          <a:bodyPr/>
+          <a:lstStyle/>
+          <a:p>
+            <a:endParaRPr lang="en-US" dirty="0"/>
+          </a:p>
+        </p:txBody>
+      </p:sp>
+      <p:sp>
+        <p:nvSpPr>
+          <p:cNvPr id="4" name="Slide Number Placeholder 3"/>
+          <p:cNvSpPr>
+            <a:spLocks noGrp="1"/>
+          </p:cNvSpPr>
+          <p:nvPr>
+            <p:ph type="sldNum" sz="quarter" idx="10"/>
+          </p:nvPr>
+        </p:nvSpPr>
+        <p:spPr/>
+        <p:txBody>
+          <a:bodyPr/>
+          <a:lstStyle/>
+          <a:p>
+            <a:fld id="{F7021451-1387-4CA6-816F-3879F97B5CBC}" type="slidenum">
+              <a:rPr lang="en-US"/>
+              <a:t>12</a:t>
+            </a:fld>
+            <a:endParaRPr lang="en-US"/>
+          </a:p>
+        </p:txBody>
+      </p:sp>
+    </p:spTree>
+    <p:extLst>
+      <p:ext uri="{BB962C8B-B14F-4D97-AF65-F5344CB8AC3E}">
+        <p14:creationId xmlns:p14="http://schemas.microsoft.com/office/powerpoint/2010/main" val="1024086991"/>
+      </p:ext>
+    </p:extLst>
+  </p:cSld>
+  <p:clrMapOvr>
+    <a:masterClrMapping/>
+  </p:clrMapOvr>
+</p:notes>
+</file>
+
+<file path=ppt/notesSlides/notesSlide13.xml><?xml version="1.0" encoding="utf-8"?>
+<p:notes xmlns:a="http://schemas.openxmlformats.org/drawingml/2006/main" xmlns:r="http://schemas.openxmlformats.org/officeDocument/2006/relationships" xmlns:p="http://schemas.openxmlformats.org/presentationml/2006/main">
+  <p:cSld>
+    <p:spTree>
+      <p:nvGrpSpPr>
         <p:cNvPr id="1" name="">
           <a:extLst>
             <a:ext uri="{FF2B5EF4-FFF2-40B4-BE49-F238E27FC236}">
@@ -6198,7 +6307,7 @@
           <a:p>
             <a:fld id="{F7021451-1387-4CA6-816F-3879F97B5CBC}" type="slidenum">
               <a:rPr lang="en-US"/>
-              <a:t>12</a:t>
+              <a:t>13</a:t>
             </a:fld>
             <a:endParaRPr lang="en-US"/>
           </a:p>
@@ -6217,7 +6326,7 @@
 </p:notes>
 </file>
 
-<file path=ppt/notesSlides/notesSlide13.xml><?xml version="1.0" encoding="utf-8"?>
+<file path=ppt/notesSlides/notesSlide14.xml><?xml version="1.0" encoding="utf-8"?>
 <p:notes xmlns:a="http://schemas.openxmlformats.org/drawingml/2006/main" xmlns:r="http://schemas.openxmlformats.org/officeDocument/2006/relationships" xmlns:p="http://schemas.openxmlformats.org/presentationml/2006/main">
   <p:cSld>
     <p:spTree>
@@ -6306,7 +6415,7 @@
           <a:p>
             <a:fld id="{F7021451-1387-4CA6-816F-3879F97B5CBC}" type="slidenum">
               <a:rPr lang="en-US"/>
-              <a:t>13</a:t>
+              <a:t>14</a:t>
             </a:fld>
             <a:endParaRPr lang="en-US"/>
           </a:p>
@@ -6325,7 +6434,7 @@
 </p:notes>
 </file>
 
-<file path=ppt/notesSlides/notesSlide14.xml><?xml version="1.0" encoding="utf-8"?>
+<file path=ppt/notesSlides/notesSlide15.xml><?xml version="1.0" encoding="utf-8"?>
 <p:notes xmlns:a="http://schemas.openxmlformats.org/drawingml/2006/main" xmlns:r="http://schemas.openxmlformats.org/officeDocument/2006/relationships" xmlns:p="http://schemas.openxmlformats.org/presentationml/2006/main">
   <p:cSld>
     <p:spTree>
@@ -6414,7 +6523,7 @@
           <a:p>
             <a:fld id="{F7021451-1387-4CA6-816F-3879F97B5CBC}" type="slidenum">
               <a:rPr lang="en-US"/>
-              <a:t>14</a:t>
+              <a:t>15</a:t>
             </a:fld>
             <a:endParaRPr lang="en-US"/>
           </a:p>
@@ -6433,7 +6542,7 @@
 </p:notes>
 </file>
 
-<file path=ppt/notesSlides/notesSlide15.xml><?xml version="1.0" encoding="utf-8"?>
+<file path=ppt/notesSlides/notesSlide16.xml><?xml version="1.0" encoding="utf-8"?>
 <p:notes xmlns:a="http://schemas.openxmlformats.org/drawingml/2006/main" xmlns:r="http://schemas.openxmlformats.org/officeDocument/2006/relationships" xmlns:p="http://schemas.openxmlformats.org/presentationml/2006/main">
   <p:cSld>
     <p:spTree>
@@ -6522,7 +6631,7 @@
           <a:p>
             <a:fld id="{F7021451-1387-4CA6-816F-3879F97B5CBC}" type="slidenum">
               <a:rPr lang="en-US"/>
-              <a:t>15</a:t>
+              <a:t>16</a:t>
             </a:fld>
             <a:endParaRPr lang="en-US"/>
           </a:p>
@@ -6541,7 +6650,7 @@
 </p:notes>
 </file>
 
-<file path=ppt/notesSlides/notesSlide16.xml><?xml version="1.0" encoding="utf-8"?>
+<file path=ppt/notesSlides/notesSlide17.xml><?xml version="1.0" encoding="utf-8"?>
 <p:notes xmlns:a="http://schemas.openxmlformats.org/drawingml/2006/main" xmlns:r="http://schemas.openxmlformats.org/officeDocument/2006/relationships" xmlns:p="http://schemas.openxmlformats.org/presentationml/2006/main">
   <p:cSld>
     <p:spTree>
@@ -6630,7 +6739,7 @@
           <a:p>
             <a:fld id="{F7021451-1387-4CA6-816F-3879F97B5CBC}" type="slidenum">
               <a:rPr lang="en-US"/>
-              <a:t>16</a:t>
+              <a:t>17</a:t>
             </a:fld>
             <a:endParaRPr lang="en-US"/>
           </a:p>
@@ -6649,7 +6758,7 @@
 </p:notes>
 </file>
 
-<file path=ppt/notesSlides/notesSlide17.xml><?xml version="1.0" encoding="utf-8"?>
+<file path=ppt/notesSlides/notesSlide18.xml><?xml version="1.0" encoding="utf-8"?>
 <p:notes xmlns:a="http://schemas.openxmlformats.org/drawingml/2006/main" xmlns:r="http://schemas.openxmlformats.org/officeDocument/2006/relationships" xmlns:p="http://schemas.openxmlformats.org/presentationml/2006/main">
   <p:cSld>
     <p:spTree>
@@ -6714,7 +6823,7 @@
           <a:p>
             <a:fld id="{F7021451-1387-4CA6-816F-3879F97B5CBC}" type="slidenum">
               <a:rPr lang="en-US"/>
-              <a:t>17</a:t>
+              <a:t>18</a:t>
             </a:fld>
             <a:endParaRPr lang="en-US"/>
           </a:p>
@@ -6733,7 +6842,7 @@
 </p:notes>
 </file>
 
-<file path=ppt/notesSlides/notesSlide18.xml><?xml version="1.0" encoding="utf-8"?>
+<file path=ppt/notesSlides/notesSlide19.xml><?xml version="1.0" encoding="utf-8"?>
 <p:notes xmlns:a="http://schemas.openxmlformats.org/drawingml/2006/main" xmlns:r="http://schemas.openxmlformats.org/officeDocument/2006/relationships" xmlns:p="http://schemas.openxmlformats.org/presentationml/2006/main">
   <p:cSld>
     <p:spTree>
@@ -6822,7 +6931,7 @@
           <a:p>
             <a:fld id="{F7021451-1387-4CA6-816F-3879F97B5CBC}" type="slidenum">
               <a:rPr lang="en-US"/>
-              <a:t>18</a:t>
+              <a:t>19</a:t>
             </a:fld>
             <a:endParaRPr lang="en-US"/>
           </a:p>
@@ -6832,114 +6941,6 @@
     <p:extLst>
       <p:ext uri="{BB962C8B-B14F-4D97-AF65-F5344CB8AC3E}">
         <p14:creationId xmlns:p14="http://schemas.microsoft.com/office/powerpoint/2010/main" val="1051995170"/>
-      </p:ext>
-    </p:extLst>
-  </p:cSld>
-  <p:clrMapOvr>
-    <a:masterClrMapping/>
-  </p:clrMapOvr>
-</p:notes>
-</file>
-
-<file path=ppt/notesSlides/notesSlide19.xml><?xml version="1.0" encoding="utf-8"?>
-<p:notes xmlns:a="http://schemas.openxmlformats.org/drawingml/2006/main" xmlns:r="http://schemas.openxmlformats.org/officeDocument/2006/relationships" xmlns:p="http://schemas.openxmlformats.org/presentationml/2006/main">
-  <p:cSld>
-    <p:spTree>
-      <p:nvGrpSpPr>
-        <p:cNvPr id="1" name="">
-          <a:extLst>
-            <a:ext uri="{FF2B5EF4-FFF2-40B4-BE49-F238E27FC236}">
-              <a16:creationId xmlns:a16="http://schemas.microsoft.com/office/drawing/2014/main" id="{8EEECF95-0FFF-AF7E-D63B-A342C012B726}"/>
-            </a:ext>
-          </a:extLst>
-        </p:cNvPr>
-        <p:cNvGrpSpPr/>
-        <p:nvPr/>
-      </p:nvGrpSpPr>
-      <p:grpSpPr>
-        <a:xfrm>
-          <a:off x="0" y="0"/>
-          <a:ext cx="0" cy="0"/>
-          <a:chOff x="0" y="0"/>
-          <a:chExt cx="0" cy="0"/>
-        </a:xfrm>
-      </p:grpSpPr>
-      <p:sp>
-        <p:nvSpPr>
-          <p:cNvPr id="2" name="Slide Image Placeholder 1">
-            <a:extLst>
-              <a:ext uri="{FF2B5EF4-FFF2-40B4-BE49-F238E27FC236}">
-                <a16:creationId xmlns:a16="http://schemas.microsoft.com/office/drawing/2014/main" id="{40C31A08-1589-DFE0-DF70-6E0B5677F14C}"/>
-              </a:ext>
-            </a:extLst>
-          </p:cNvPr>
-          <p:cNvSpPr>
-            <a:spLocks noGrp="1" noRot="1" noChangeAspect="1"/>
-          </p:cNvSpPr>
-          <p:nvPr>
-            <p:ph type="sldImg"/>
-          </p:nvPr>
-        </p:nvSpPr>
-        <p:spPr/>
-      </p:sp>
-      <p:sp>
-        <p:nvSpPr>
-          <p:cNvPr id="3" name="Notes Placeholder 2">
-            <a:extLst>
-              <a:ext uri="{FF2B5EF4-FFF2-40B4-BE49-F238E27FC236}">
-                <a16:creationId xmlns:a16="http://schemas.microsoft.com/office/drawing/2014/main" id="{B9F6F86F-BACD-6D2A-D2D5-A49398FF7027}"/>
-              </a:ext>
-            </a:extLst>
-          </p:cNvPr>
-          <p:cNvSpPr>
-            <a:spLocks noGrp="1"/>
-          </p:cNvSpPr>
-          <p:nvPr>
-            <p:ph type="body" idx="1"/>
-          </p:nvPr>
-        </p:nvSpPr>
-        <p:spPr/>
-        <p:txBody>
-          <a:bodyPr/>
-          <a:lstStyle/>
-          <a:p>
-            <a:endParaRPr lang="en-US" dirty="0"/>
-          </a:p>
-        </p:txBody>
-      </p:sp>
-      <p:sp>
-        <p:nvSpPr>
-          <p:cNvPr id="4" name="Slide Number Placeholder 3">
-            <a:extLst>
-              <a:ext uri="{FF2B5EF4-FFF2-40B4-BE49-F238E27FC236}">
-                <a16:creationId xmlns:a16="http://schemas.microsoft.com/office/drawing/2014/main" id="{7DA6E4E8-6CE6-07EE-B311-373B9954E2BC}"/>
-              </a:ext>
-            </a:extLst>
-          </p:cNvPr>
-          <p:cNvSpPr>
-            <a:spLocks noGrp="1"/>
-          </p:cNvSpPr>
-          <p:nvPr>
-            <p:ph type="sldNum" sz="quarter" idx="10"/>
-          </p:nvPr>
-        </p:nvSpPr>
-        <p:spPr/>
-        <p:txBody>
-          <a:bodyPr/>
-          <a:lstStyle/>
-          <a:p>
-            <a:fld id="{F7021451-1387-4CA6-816F-3879F97B5CBC}" type="slidenum">
-              <a:rPr lang="en-US"/>
-              <a:t>19</a:t>
-            </a:fld>
-            <a:endParaRPr lang="en-US"/>
-          </a:p>
-        </p:txBody>
-      </p:sp>
-    </p:spTree>
-    <p:extLst>
-      <p:ext uri="{BB962C8B-B14F-4D97-AF65-F5344CB8AC3E}">
-        <p14:creationId xmlns:p14="http://schemas.microsoft.com/office/powerpoint/2010/main" val="1212680079"/>
       </p:ext>
     </p:extLst>
   </p:cSld>
@@ -7038,6 +7039,114 @@
   <p:cSld>
     <p:spTree>
       <p:nvGrpSpPr>
+        <p:cNvPr id="1" name="">
+          <a:extLst>
+            <a:ext uri="{FF2B5EF4-FFF2-40B4-BE49-F238E27FC236}">
+              <a16:creationId xmlns:a16="http://schemas.microsoft.com/office/drawing/2014/main" id="{8EEECF95-0FFF-AF7E-D63B-A342C012B726}"/>
+            </a:ext>
+          </a:extLst>
+        </p:cNvPr>
+        <p:cNvGrpSpPr/>
+        <p:nvPr/>
+      </p:nvGrpSpPr>
+      <p:grpSpPr>
+        <a:xfrm>
+          <a:off x="0" y="0"/>
+          <a:ext cx="0" cy="0"/>
+          <a:chOff x="0" y="0"/>
+          <a:chExt cx="0" cy="0"/>
+        </a:xfrm>
+      </p:grpSpPr>
+      <p:sp>
+        <p:nvSpPr>
+          <p:cNvPr id="2" name="Slide Image Placeholder 1">
+            <a:extLst>
+              <a:ext uri="{FF2B5EF4-FFF2-40B4-BE49-F238E27FC236}">
+                <a16:creationId xmlns:a16="http://schemas.microsoft.com/office/drawing/2014/main" id="{40C31A08-1589-DFE0-DF70-6E0B5677F14C}"/>
+              </a:ext>
+            </a:extLst>
+          </p:cNvPr>
+          <p:cNvSpPr>
+            <a:spLocks noGrp="1" noRot="1" noChangeAspect="1"/>
+          </p:cNvSpPr>
+          <p:nvPr>
+            <p:ph type="sldImg"/>
+          </p:nvPr>
+        </p:nvSpPr>
+        <p:spPr/>
+      </p:sp>
+      <p:sp>
+        <p:nvSpPr>
+          <p:cNvPr id="3" name="Notes Placeholder 2">
+            <a:extLst>
+              <a:ext uri="{FF2B5EF4-FFF2-40B4-BE49-F238E27FC236}">
+                <a16:creationId xmlns:a16="http://schemas.microsoft.com/office/drawing/2014/main" id="{B9F6F86F-BACD-6D2A-D2D5-A49398FF7027}"/>
+              </a:ext>
+            </a:extLst>
+          </p:cNvPr>
+          <p:cNvSpPr>
+            <a:spLocks noGrp="1"/>
+          </p:cNvSpPr>
+          <p:nvPr>
+            <p:ph type="body" idx="1"/>
+          </p:nvPr>
+        </p:nvSpPr>
+        <p:spPr/>
+        <p:txBody>
+          <a:bodyPr/>
+          <a:lstStyle/>
+          <a:p>
+            <a:endParaRPr lang="en-US" dirty="0"/>
+          </a:p>
+        </p:txBody>
+      </p:sp>
+      <p:sp>
+        <p:nvSpPr>
+          <p:cNvPr id="4" name="Slide Number Placeholder 3">
+            <a:extLst>
+              <a:ext uri="{FF2B5EF4-FFF2-40B4-BE49-F238E27FC236}">
+                <a16:creationId xmlns:a16="http://schemas.microsoft.com/office/drawing/2014/main" id="{7DA6E4E8-6CE6-07EE-B311-373B9954E2BC}"/>
+              </a:ext>
+            </a:extLst>
+          </p:cNvPr>
+          <p:cNvSpPr>
+            <a:spLocks noGrp="1"/>
+          </p:cNvSpPr>
+          <p:nvPr>
+            <p:ph type="sldNum" sz="quarter" idx="10"/>
+          </p:nvPr>
+        </p:nvSpPr>
+        <p:spPr/>
+        <p:txBody>
+          <a:bodyPr/>
+          <a:lstStyle/>
+          <a:p>
+            <a:fld id="{F7021451-1387-4CA6-816F-3879F97B5CBC}" type="slidenum">
+              <a:rPr lang="en-US"/>
+              <a:t>20</a:t>
+            </a:fld>
+            <a:endParaRPr lang="en-US"/>
+          </a:p>
+        </p:txBody>
+      </p:sp>
+    </p:spTree>
+    <p:extLst>
+      <p:ext uri="{BB962C8B-B14F-4D97-AF65-F5344CB8AC3E}">
+        <p14:creationId xmlns:p14="http://schemas.microsoft.com/office/powerpoint/2010/main" val="1212680079"/>
+      </p:ext>
+    </p:extLst>
+  </p:cSld>
+  <p:clrMapOvr>
+    <a:masterClrMapping/>
+  </p:clrMapOvr>
+</p:notes>
+</file>
+
+<file path=ppt/notesSlides/notesSlide21.xml><?xml version="1.0" encoding="utf-8"?>
+<p:notes xmlns:a="http://schemas.openxmlformats.org/drawingml/2006/main" xmlns:r="http://schemas.openxmlformats.org/officeDocument/2006/relationships" xmlns:p="http://schemas.openxmlformats.org/presentationml/2006/main">
+  <p:cSld>
+    <p:spTree>
+      <p:nvGrpSpPr>
         <p:cNvPr id="1" name=""/>
         <p:cNvGrpSpPr/>
         <p:nvPr/>
@@ -7098,7 +7207,7 @@
           <a:p>
             <a:fld id="{F7021451-1387-4CA6-816F-3879F97B5CBC}" type="slidenum">
               <a:rPr lang="en-US"/>
-              <a:t>20</a:t>
+              <a:t>21</a:t>
             </a:fld>
             <a:endParaRPr lang="en-US"/>
           </a:p>
@@ -7117,7 +7226,7 @@
 </p:notes>
 </file>
 
-<file path=ppt/notesSlides/notesSlide21.xml><?xml version="1.0" encoding="utf-8"?>
+<file path=ppt/notesSlides/notesSlide22.xml><?xml version="1.0" encoding="utf-8"?>
 <p:notes xmlns:a="http://schemas.openxmlformats.org/drawingml/2006/main" xmlns:r="http://schemas.openxmlformats.org/officeDocument/2006/relationships" xmlns:p="http://schemas.openxmlformats.org/presentationml/2006/main">
   <p:cSld>
     <p:spTree>
@@ -7253,7 +7362,7 @@
                 <a:tabLst/>
                 <a:defRPr/>
               </a:pPr>
-              <a:t>21</a:t>
+              <a:t>22</a:t>
             </a:fld>
             <a:endParaRPr kumimoji="0" lang="en-US" sz="1800" b="0" i="0" u="none" strike="noStrike" kern="1200" cap="none" spc="0" normalizeH="0" baseline="0" noProof="0">
               <a:ln>
@@ -7285,7 +7394,7 @@
 </p:notes>
 </file>
 
-<file path=ppt/notesSlides/notesSlide22.xml><?xml version="1.0" encoding="utf-8"?>
+<file path=ppt/notesSlides/notesSlide23.xml><?xml version="1.0" encoding="utf-8"?>
 <p:notes xmlns:a="http://schemas.openxmlformats.org/drawingml/2006/main" xmlns:r="http://schemas.openxmlformats.org/officeDocument/2006/relationships" xmlns:p="http://schemas.openxmlformats.org/presentationml/2006/main">
   <p:cSld>
     <p:spTree>
@@ -7374,7 +7483,7 @@
           <a:p>
             <a:fld id="{F7021451-1387-4CA6-816F-3879F97B5CBC}" type="slidenum">
               <a:rPr lang="en-US"/>
-              <a:t>22</a:t>
+              <a:t>23</a:t>
             </a:fld>
             <a:endParaRPr lang="en-US"/>
           </a:p>
@@ -7393,7 +7502,7 @@
 </p:notes>
 </file>
 
-<file path=ppt/notesSlides/notesSlide23.xml><?xml version="1.0" encoding="utf-8"?>
+<file path=ppt/notesSlides/notesSlide24.xml><?xml version="1.0" encoding="utf-8"?>
 <p:notes xmlns:a="http://schemas.openxmlformats.org/drawingml/2006/main" xmlns:r="http://schemas.openxmlformats.org/officeDocument/2006/relationships" xmlns:p="http://schemas.openxmlformats.org/presentationml/2006/main">
   <p:cSld>
     <p:spTree>
@@ -7482,7 +7591,7 @@
           <a:p>
             <a:fld id="{F7021451-1387-4CA6-816F-3879F97B5CBC}" type="slidenum">
               <a:rPr lang="en-US"/>
-              <a:t>23</a:t>
+              <a:t>24</a:t>
             </a:fld>
             <a:endParaRPr lang="en-US"/>
           </a:p>
@@ -7501,7 +7610,7 @@
 </p:notes>
 </file>
 
-<file path=ppt/notesSlides/notesSlide24.xml><?xml version="1.0" encoding="utf-8"?>
+<file path=ppt/notesSlides/notesSlide25.xml><?xml version="1.0" encoding="utf-8"?>
 <p:notes xmlns:a="http://schemas.openxmlformats.org/drawingml/2006/main" xmlns:r="http://schemas.openxmlformats.org/officeDocument/2006/relationships" xmlns:p="http://schemas.openxmlformats.org/presentationml/2006/main">
   <p:cSld>
     <p:spTree>
@@ -7590,7 +7699,7 @@
           <a:p>
             <a:fld id="{F7021451-1387-4CA6-816F-3879F97B5CBC}" type="slidenum">
               <a:rPr lang="en-US"/>
-              <a:t>24</a:t>
+              <a:t>25</a:t>
             </a:fld>
             <a:endParaRPr lang="en-US"/>
           </a:p>
@@ -7609,7 +7718,7 @@
 </p:notes>
 </file>
 
-<file path=ppt/notesSlides/notesSlide25.xml><?xml version="1.0" encoding="utf-8"?>
+<file path=ppt/notesSlides/notesSlide26.xml><?xml version="1.0" encoding="utf-8"?>
 <p:notes xmlns:a="http://schemas.openxmlformats.org/drawingml/2006/main" xmlns:r="http://schemas.openxmlformats.org/officeDocument/2006/relationships" xmlns:p="http://schemas.openxmlformats.org/presentationml/2006/main">
   <p:cSld>
     <p:spTree>
@@ -7698,7 +7807,7 @@
           <a:p>
             <a:fld id="{F7021451-1387-4CA6-816F-3879F97B5CBC}" type="slidenum">
               <a:rPr lang="en-US"/>
-              <a:t>25</a:t>
+              <a:t>26</a:t>
             </a:fld>
             <a:endParaRPr lang="en-US"/>
           </a:p>
@@ -7722,7 +7831,13 @@
   <p:cSld>
     <p:spTree>
       <p:nvGrpSpPr>
-        <p:cNvPr id="1" name=""/>
+        <p:cNvPr id="1" name="">
+          <a:extLst>
+            <a:ext uri="{FF2B5EF4-FFF2-40B4-BE49-F238E27FC236}">
+              <a16:creationId xmlns:a16="http://schemas.microsoft.com/office/drawing/2014/main" id="{AC44768D-33E9-D2FD-8428-A75204FE5C57}"/>
+            </a:ext>
+          </a:extLst>
+        </p:cNvPr>
         <p:cNvGrpSpPr/>
         <p:nvPr/>
       </p:nvGrpSpPr>
@@ -7736,7 +7851,13 @@
       </p:grpSpPr>
       <p:sp>
         <p:nvSpPr>
-          <p:cNvPr id="2" name="Slide Image Placeholder 1"/>
+          <p:cNvPr id="2" name="Slide Image Placeholder 1">
+            <a:extLst>
+              <a:ext uri="{FF2B5EF4-FFF2-40B4-BE49-F238E27FC236}">
+                <a16:creationId xmlns:a16="http://schemas.microsoft.com/office/drawing/2014/main" id="{D68C863F-F82C-13E3-BD8C-CD676F6FDD31}"/>
+              </a:ext>
+            </a:extLst>
+          </p:cNvPr>
           <p:cNvSpPr>
             <a:spLocks noGrp="1" noRot="1" noChangeAspect="1"/>
           </p:cNvSpPr>
@@ -7748,7 +7869,13 @@
       </p:sp>
       <p:sp>
         <p:nvSpPr>
-          <p:cNvPr id="3" name="Notes Placeholder 2"/>
+          <p:cNvPr id="3" name="Notes Placeholder 2">
+            <a:extLst>
+              <a:ext uri="{FF2B5EF4-FFF2-40B4-BE49-F238E27FC236}">
+                <a16:creationId xmlns:a16="http://schemas.microsoft.com/office/drawing/2014/main" id="{27A525F9-94A6-2AE4-E9CE-A803A31A5AFC}"/>
+              </a:ext>
+            </a:extLst>
+          </p:cNvPr>
           <p:cNvSpPr>
             <a:spLocks noGrp="1"/>
           </p:cNvSpPr>
@@ -7767,7 +7894,13 @@
       </p:sp>
       <p:sp>
         <p:nvSpPr>
-          <p:cNvPr id="4" name="Slide Number Placeholder 3"/>
+          <p:cNvPr id="4" name="Slide Number Placeholder 3">
+            <a:extLst>
+              <a:ext uri="{FF2B5EF4-FFF2-40B4-BE49-F238E27FC236}">
+                <a16:creationId xmlns:a16="http://schemas.microsoft.com/office/drawing/2014/main" id="{ED9C13AA-27F8-0350-011A-4075D1CB4AC2}"/>
+              </a:ext>
+            </a:extLst>
+          </p:cNvPr>
           <p:cNvSpPr>
             <a:spLocks noGrp="1"/>
           </p:cNvSpPr>
@@ -7791,7 +7924,7 @@
     </p:spTree>
     <p:extLst>
       <p:ext uri="{BB962C8B-B14F-4D97-AF65-F5344CB8AC3E}">
-        <p14:creationId xmlns:p14="http://schemas.microsoft.com/office/powerpoint/2010/main" val="1024086991"/>
+        <p14:creationId xmlns:p14="http://schemas.microsoft.com/office/powerpoint/2010/main" val="2746938789"/>
       </p:ext>
     </p:extLst>
   </p:cSld>
@@ -7890,6 +8023,90 @@
   <p:cSld>
     <p:spTree>
       <p:nvGrpSpPr>
+        <p:cNvPr id="1" name=""/>
+        <p:cNvGrpSpPr/>
+        <p:nvPr/>
+      </p:nvGrpSpPr>
+      <p:grpSpPr>
+        <a:xfrm>
+          <a:off x="0" y="0"/>
+          <a:ext cx="0" cy="0"/>
+          <a:chOff x="0" y="0"/>
+          <a:chExt cx="0" cy="0"/>
+        </a:xfrm>
+      </p:grpSpPr>
+      <p:sp>
+        <p:nvSpPr>
+          <p:cNvPr id="2" name="Slide Image Placeholder 1"/>
+          <p:cNvSpPr>
+            <a:spLocks noGrp="1" noRot="1" noChangeAspect="1"/>
+          </p:cNvSpPr>
+          <p:nvPr>
+            <p:ph type="sldImg"/>
+          </p:nvPr>
+        </p:nvSpPr>
+        <p:spPr/>
+      </p:sp>
+      <p:sp>
+        <p:nvSpPr>
+          <p:cNvPr id="3" name="Notes Placeholder 2"/>
+          <p:cNvSpPr>
+            <a:spLocks noGrp="1"/>
+          </p:cNvSpPr>
+          <p:nvPr>
+            <p:ph type="body" idx="1"/>
+          </p:nvPr>
+        </p:nvSpPr>
+        <p:spPr/>
+        <p:txBody>
+          <a:bodyPr/>
+          <a:lstStyle/>
+          <a:p>
+            <a:endParaRPr lang="en-US" dirty="0"/>
+          </a:p>
+        </p:txBody>
+      </p:sp>
+      <p:sp>
+        <p:nvSpPr>
+          <p:cNvPr id="4" name="Slide Number Placeholder 3"/>
+          <p:cNvSpPr>
+            <a:spLocks noGrp="1"/>
+          </p:cNvSpPr>
+          <p:nvPr>
+            <p:ph type="sldNum" sz="quarter" idx="10"/>
+          </p:nvPr>
+        </p:nvSpPr>
+        <p:spPr/>
+        <p:txBody>
+          <a:bodyPr/>
+          <a:lstStyle/>
+          <a:p>
+            <a:fld id="{F7021451-1387-4CA6-816F-3879F97B5CBC}" type="slidenum">
+              <a:rPr lang="en-US"/>
+              <a:t>5</a:t>
+            </a:fld>
+            <a:endParaRPr lang="en-US"/>
+          </a:p>
+        </p:txBody>
+      </p:sp>
+    </p:spTree>
+    <p:extLst>
+      <p:ext uri="{BB962C8B-B14F-4D97-AF65-F5344CB8AC3E}">
+        <p14:creationId xmlns:p14="http://schemas.microsoft.com/office/powerpoint/2010/main" val="1024086991"/>
+      </p:ext>
+    </p:extLst>
+  </p:cSld>
+  <p:clrMapOvr>
+    <a:masterClrMapping/>
+  </p:clrMapOvr>
+</p:notes>
+</file>
+
+<file path=ppt/notesSlides/notesSlide6.xml><?xml version="1.0" encoding="utf-8"?>
+<p:notes xmlns:a="http://schemas.openxmlformats.org/drawingml/2006/main" xmlns:r="http://schemas.openxmlformats.org/officeDocument/2006/relationships" xmlns:p="http://schemas.openxmlformats.org/presentationml/2006/main">
+  <p:cSld>
+    <p:spTree>
+      <p:nvGrpSpPr>
         <p:cNvPr id="1" name="">
           <a:extLst>
             <a:ext uri="{FF2B5EF4-FFF2-40B4-BE49-F238E27FC236}">
@@ -7974,7 +8191,7 @@
           <a:p>
             <a:fld id="{F7021451-1387-4CA6-816F-3879F97B5CBC}" type="slidenum">
               <a:rPr lang="en-US"/>
-              <a:t>5</a:t>
+              <a:t>6</a:t>
             </a:fld>
             <a:endParaRPr lang="en-US"/>
           </a:p>
@@ -7993,7 +8210,7 @@
 </p:notes>
 </file>
 
-<file path=ppt/notesSlides/notesSlide6.xml><?xml version="1.0" encoding="utf-8"?>
+<file path=ppt/notesSlides/notesSlide7.xml><?xml version="1.0" encoding="utf-8"?>
 <p:notes xmlns:a="http://schemas.openxmlformats.org/drawingml/2006/main" xmlns:r="http://schemas.openxmlformats.org/officeDocument/2006/relationships" xmlns:p="http://schemas.openxmlformats.org/presentationml/2006/main">
   <p:cSld>
     <p:spTree>
@@ -8058,7 +8275,7 @@
           <a:p>
             <a:fld id="{F7021451-1387-4CA6-816F-3879F97B5CBC}" type="slidenum">
               <a:rPr lang="en-US"/>
-              <a:t>6</a:t>
+              <a:t>7</a:t>
             </a:fld>
             <a:endParaRPr lang="en-US"/>
           </a:p>
@@ -8077,7 +8294,7 @@
 </p:notes>
 </file>
 
-<file path=ppt/notesSlides/notesSlide7.xml><?xml version="1.0" encoding="utf-8"?>
+<file path=ppt/notesSlides/notesSlide8.xml><?xml version="1.0" encoding="utf-8"?>
 <p:notes xmlns:a="http://schemas.openxmlformats.org/drawingml/2006/main" xmlns:r="http://schemas.openxmlformats.org/officeDocument/2006/relationships" xmlns:p="http://schemas.openxmlformats.org/presentationml/2006/main">
   <p:cSld>
     <p:spTree>
@@ -8166,7 +8383,7 @@
           <a:p>
             <a:fld id="{F7021451-1387-4CA6-816F-3879F97B5CBC}" type="slidenum">
               <a:rPr lang="en-US"/>
-              <a:t>7</a:t>
+              <a:t>8</a:t>
             </a:fld>
             <a:endParaRPr lang="en-US"/>
           </a:p>
@@ -8185,7 +8402,7 @@
 </p:notes>
 </file>
 
-<file path=ppt/notesSlides/notesSlide8.xml><?xml version="1.0" encoding="utf-8"?>
+<file path=ppt/notesSlides/notesSlide9.xml><?xml version="1.0" encoding="utf-8"?>
 <p:notes xmlns:a="http://schemas.openxmlformats.org/drawingml/2006/main" xmlns:r="http://schemas.openxmlformats.org/officeDocument/2006/relationships" xmlns:p="http://schemas.openxmlformats.org/presentationml/2006/main">
   <p:cSld>
     <p:spTree>
@@ -8250,7 +8467,7 @@
           <a:p>
             <a:fld id="{F7021451-1387-4CA6-816F-3879F97B5CBC}" type="slidenum">
               <a:rPr lang="en-US"/>
-              <a:t>8</a:t>
+              <a:t>9</a:t>
             </a:fld>
             <a:endParaRPr lang="en-US"/>
           </a:p>
@@ -8260,114 +8477,6 @@
     <p:extLst>
       <p:ext uri="{BB962C8B-B14F-4D97-AF65-F5344CB8AC3E}">
         <p14:creationId xmlns:p14="http://schemas.microsoft.com/office/powerpoint/2010/main" val="1024086991"/>
-      </p:ext>
-    </p:extLst>
-  </p:cSld>
-  <p:clrMapOvr>
-    <a:masterClrMapping/>
-  </p:clrMapOvr>
-</p:notes>
-</file>
-
-<file path=ppt/notesSlides/notesSlide9.xml><?xml version="1.0" encoding="utf-8"?>
-<p:notes xmlns:a="http://schemas.openxmlformats.org/drawingml/2006/main" xmlns:r="http://schemas.openxmlformats.org/officeDocument/2006/relationships" xmlns:p="http://schemas.openxmlformats.org/presentationml/2006/main">
-  <p:cSld>
-    <p:spTree>
-      <p:nvGrpSpPr>
-        <p:cNvPr id="1" name="">
-          <a:extLst>
-            <a:ext uri="{FF2B5EF4-FFF2-40B4-BE49-F238E27FC236}">
-              <a16:creationId xmlns:a16="http://schemas.microsoft.com/office/drawing/2014/main" id="{56C8BBE2-7578-9BEB-14BD-464DB3ACA1AC}"/>
-            </a:ext>
-          </a:extLst>
-        </p:cNvPr>
-        <p:cNvGrpSpPr/>
-        <p:nvPr/>
-      </p:nvGrpSpPr>
-      <p:grpSpPr>
-        <a:xfrm>
-          <a:off x="0" y="0"/>
-          <a:ext cx="0" cy="0"/>
-          <a:chOff x="0" y="0"/>
-          <a:chExt cx="0" cy="0"/>
-        </a:xfrm>
-      </p:grpSpPr>
-      <p:sp>
-        <p:nvSpPr>
-          <p:cNvPr id="2" name="Slide Image Placeholder 1">
-            <a:extLst>
-              <a:ext uri="{FF2B5EF4-FFF2-40B4-BE49-F238E27FC236}">
-                <a16:creationId xmlns:a16="http://schemas.microsoft.com/office/drawing/2014/main" id="{2CB27920-DE4C-B486-AD25-3E2134243777}"/>
-              </a:ext>
-            </a:extLst>
-          </p:cNvPr>
-          <p:cNvSpPr>
-            <a:spLocks noGrp="1" noRot="1" noChangeAspect="1"/>
-          </p:cNvSpPr>
-          <p:nvPr>
-            <p:ph type="sldImg"/>
-          </p:nvPr>
-        </p:nvSpPr>
-        <p:spPr/>
-      </p:sp>
-      <p:sp>
-        <p:nvSpPr>
-          <p:cNvPr id="3" name="Notes Placeholder 2">
-            <a:extLst>
-              <a:ext uri="{FF2B5EF4-FFF2-40B4-BE49-F238E27FC236}">
-                <a16:creationId xmlns:a16="http://schemas.microsoft.com/office/drawing/2014/main" id="{E6031FEF-273E-9FF7-5447-19A6D6A871CD}"/>
-              </a:ext>
-            </a:extLst>
-          </p:cNvPr>
-          <p:cNvSpPr>
-            <a:spLocks noGrp="1"/>
-          </p:cNvSpPr>
-          <p:nvPr>
-            <p:ph type="body" idx="1"/>
-          </p:nvPr>
-        </p:nvSpPr>
-        <p:spPr/>
-        <p:txBody>
-          <a:bodyPr/>
-          <a:lstStyle/>
-          <a:p>
-            <a:endParaRPr lang="en-US" dirty="0"/>
-          </a:p>
-        </p:txBody>
-      </p:sp>
-      <p:sp>
-        <p:nvSpPr>
-          <p:cNvPr id="4" name="Slide Number Placeholder 3">
-            <a:extLst>
-              <a:ext uri="{FF2B5EF4-FFF2-40B4-BE49-F238E27FC236}">
-                <a16:creationId xmlns:a16="http://schemas.microsoft.com/office/drawing/2014/main" id="{0009025C-3118-B675-5E42-3686485C2256}"/>
-              </a:ext>
-            </a:extLst>
-          </p:cNvPr>
-          <p:cNvSpPr>
-            <a:spLocks noGrp="1"/>
-          </p:cNvSpPr>
-          <p:nvPr>
-            <p:ph type="sldNum" sz="quarter" idx="10"/>
-          </p:nvPr>
-        </p:nvSpPr>
-        <p:spPr/>
-        <p:txBody>
-          <a:bodyPr/>
-          <a:lstStyle/>
-          <a:p>
-            <a:fld id="{F7021451-1387-4CA6-816F-3879F97B5CBC}" type="slidenum">
-              <a:rPr lang="en-US"/>
-              <a:t>9</a:t>
-            </a:fld>
-            <a:endParaRPr lang="en-US"/>
-          </a:p>
-        </p:txBody>
-      </p:sp>
-    </p:spTree>
-    <p:extLst>
-      <p:ext uri="{BB962C8B-B14F-4D97-AF65-F5344CB8AC3E}">
-        <p14:creationId xmlns:p14="http://schemas.microsoft.com/office/powerpoint/2010/main" val="3630224614"/>
       </p:ext>
     </p:extLst>
   </p:cSld>
@@ -9025,6 +9134,378 @@
   <p:cSld>
     <p:spTree>
       <p:nvGrpSpPr>
+        <p:cNvPr id="1" name="">
+          <a:extLst>
+            <a:ext uri="{FF2B5EF4-FFF2-40B4-BE49-F238E27FC236}">
+              <a16:creationId xmlns:a16="http://schemas.microsoft.com/office/drawing/2014/main" id="{725B3854-6ADE-1361-C926-BC58365BF789}"/>
+            </a:ext>
+          </a:extLst>
+        </p:cNvPr>
+        <p:cNvGrpSpPr/>
+        <p:nvPr/>
+      </p:nvGrpSpPr>
+      <p:grpSpPr>
+        <a:xfrm>
+          <a:off x="0" y="0"/>
+          <a:ext cx="0" cy="0"/>
+          <a:chOff x="0" y="0"/>
+          <a:chExt cx="0" cy="0"/>
+        </a:xfrm>
+      </p:grpSpPr>
+      <p:sp>
+        <p:nvSpPr>
+          <p:cNvPr id="2" name="Shape 0">
+            <a:extLst>
+              <a:ext uri="{FF2B5EF4-FFF2-40B4-BE49-F238E27FC236}">
+                <a16:creationId xmlns:a16="http://schemas.microsoft.com/office/drawing/2014/main" id="{6478A43A-06D6-0B79-0B1C-69F930775618}"/>
+              </a:ext>
+            </a:extLst>
+          </p:cNvPr>
+          <p:cNvSpPr/>
+          <p:nvPr/>
+        </p:nvSpPr>
+        <p:spPr>
+          <a:xfrm>
+            <a:off x="0" y="0"/>
+            <a:ext cx="9144000" cy="777240"/>
+          </a:xfrm>
+          <a:prstGeom prst="rect">
+            <a:avLst/>
+          </a:prstGeom>
+          <a:solidFill>
+            <a:srgbClr val="00A896"/>
+          </a:solidFill>
+          <a:ln w="12700">
+            <a:solidFill>
+              <a:srgbClr val="00A896"/>
+            </a:solidFill>
+            <a:prstDash val="solid"/>
+          </a:ln>
+        </p:spPr>
+        <p:txBody>
+          <a:bodyPr/>
+          <a:lstStyle/>
+          <a:p>
+            <a:endParaRPr lang="en-US"/>
+          </a:p>
+        </p:txBody>
+      </p:sp>
+      <p:sp>
+        <p:nvSpPr>
+          <p:cNvPr id="3" name="Text 1">
+            <a:extLst>
+              <a:ext uri="{FF2B5EF4-FFF2-40B4-BE49-F238E27FC236}">
+                <a16:creationId xmlns:a16="http://schemas.microsoft.com/office/drawing/2014/main" id="{320303AF-3C5C-D3B3-2594-B705F57EB492}"/>
+              </a:ext>
+            </a:extLst>
+          </p:cNvPr>
+          <p:cNvSpPr/>
+          <p:nvPr/>
+        </p:nvSpPr>
+        <p:spPr>
+          <a:xfrm>
+            <a:off x="365760" y="0"/>
+            <a:ext cx="8412480" cy="777240"/>
+          </a:xfrm>
+          <a:prstGeom prst="rect">
+            <a:avLst/>
+          </a:prstGeom>
+          <a:noFill/>
+          <a:ln/>
+        </p:spPr>
+        <p:txBody>
+          <a:bodyPr wrap="square" lIns="0" tIns="0" rIns="0" bIns="0" rtlCol="0" anchor="ctr"/>
+          <a:lstStyle/>
+          <a:p>
+            <a:pPr marL="0" indent="0">
+              <a:buNone/>
+            </a:pPr>
+            <a:r>
+              <a:rPr lang="en-US" sz="2400" b="1" dirty="0">
+                <a:solidFill>
+                  <a:srgbClr val="FFFFFF"/>
+                </a:solidFill>
+                <a:latin typeface="Calibri" pitchFamily="34" charset="0"/>
+                <a:ea typeface="Calibri" pitchFamily="34" charset="-122"/>
+                <a:cs typeface="Calibri" pitchFamily="34" charset="-120"/>
+              </a:rPr>
+              <a:t>02  Parallel Compute - Description</a:t>
+            </a:r>
+            <a:endParaRPr lang="en-US" sz="2400" dirty="0"/>
+          </a:p>
+        </p:txBody>
+      </p:sp>
+      <p:sp>
+        <p:nvSpPr>
+          <p:cNvPr id="4" name="Shape 2">
+            <a:extLst>
+              <a:ext uri="{FF2B5EF4-FFF2-40B4-BE49-F238E27FC236}">
+                <a16:creationId xmlns:a16="http://schemas.microsoft.com/office/drawing/2014/main" id="{AA68B348-F7F1-BA22-450B-F651397AFFD9}"/>
+              </a:ext>
+            </a:extLst>
+          </p:cNvPr>
+          <p:cNvSpPr/>
+          <p:nvPr/>
+        </p:nvSpPr>
+        <p:spPr>
+          <a:xfrm>
+            <a:off x="457200" y="1325880"/>
+            <a:ext cx="8015068" cy="3017521"/>
+          </a:xfrm>
+          <a:prstGeom prst="rect">
+            <a:avLst/>
+          </a:prstGeom>
+          <a:solidFill>
+            <a:srgbClr val="1C2E3E"/>
+          </a:solidFill>
+          <a:ln w="12700">
+            <a:solidFill>
+              <a:srgbClr val="3D5166"/>
+            </a:solidFill>
+            <a:prstDash val="solid"/>
+          </a:ln>
+        </p:spPr>
+        <p:txBody>
+          <a:bodyPr/>
+          <a:lstStyle/>
+          <a:p>
+            <a:endParaRPr lang="en-US"/>
+          </a:p>
+        </p:txBody>
+      </p:sp>
+      <p:sp>
+        <p:nvSpPr>
+          <p:cNvPr id="5" name="Text 3">
+            <a:extLst>
+              <a:ext uri="{FF2B5EF4-FFF2-40B4-BE49-F238E27FC236}">
+                <a16:creationId xmlns:a16="http://schemas.microsoft.com/office/drawing/2014/main" id="{B3B31F22-1334-30EB-0ED4-0FC625DB0246}"/>
+              </a:ext>
+            </a:extLst>
+          </p:cNvPr>
+          <p:cNvSpPr/>
+          <p:nvPr/>
+        </p:nvSpPr>
+        <p:spPr>
+          <a:xfrm>
+            <a:off x="594360" y="1456008"/>
+            <a:ext cx="3657600" cy="365760"/>
+          </a:xfrm>
+          <a:prstGeom prst="rect">
+            <a:avLst/>
+          </a:prstGeom>
+          <a:noFill/>
+          <a:ln/>
+        </p:spPr>
+        <p:txBody>
+          <a:bodyPr wrap="square" rtlCol="0" anchor="ctr"/>
+          <a:lstStyle/>
+          <a:p>
+            <a:pPr marL="0" indent="0">
+              <a:buNone/>
+            </a:pPr>
+            <a:r>
+              <a:rPr lang="en-US" sz="2000" b="1" dirty="0">
+                <a:solidFill>
+                  <a:srgbClr val="00C9A7"/>
+                </a:solidFill>
+                <a:latin typeface="Calibri" pitchFamily="34" charset="0"/>
+                <a:ea typeface="Calibri" pitchFamily="34" charset="-122"/>
+                <a:cs typeface="Calibri" pitchFamily="34" charset="-120"/>
+              </a:rPr>
+              <a:t>What it does</a:t>
+            </a:r>
+            <a:endParaRPr lang="en-US" sz="2000" dirty="0"/>
+          </a:p>
+        </p:txBody>
+      </p:sp>
+      <p:sp>
+        <p:nvSpPr>
+          <p:cNvPr id="6" name="Text 4">
+            <a:extLst>
+              <a:ext uri="{FF2B5EF4-FFF2-40B4-BE49-F238E27FC236}">
+                <a16:creationId xmlns:a16="http://schemas.microsoft.com/office/drawing/2014/main" id="{ADA7DDB5-7839-A085-F6AE-B26DCE933E60}"/>
+              </a:ext>
+            </a:extLst>
+          </p:cNvPr>
+          <p:cNvSpPr/>
+          <p:nvPr/>
+        </p:nvSpPr>
+        <p:spPr>
+          <a:xfrm>
+            <a:off x="1041009" y="2440745"/>
+            <a:ext cx="7336302" cy="1515794"/>
+          </a:xfrm>
+          <a:prstGeom prst="rect">
+            <a:avLst/>
+          </a:prstGeom>
+          <a:noFill/>
+          <a:ln/>
+        </p:spPr>
+        <p:txBody>
+          <a:bodyPr wrap="square" rtlCol="0" anchor="ctr"/>
+          <a:lstStyle/>
+          <a:p>
+            <a:r>
+              <a:rPr lang="en-US" dirty="0">
+                <a:solidFill>
+                  <a:schemeClr val="bg1"/>
+                </a:solidFill>
+              </a:rPr>
+              <a:t>Takes:</a:t>
+            </a:r>
+            <a:endParaRPr lang="en-US" sz="1400" dirty="0">
+              <a:solidFill>
+                <a:schemeClr val="bg1"/>
+              </a:solidFill>
+            </a:endParaRPr>
+          </a:p>
+          <a:p>
+            <a:pPr marL="285750" indent="-285750" fontAlgn="base">
+              <a:buFontTx/>
+              <a:buChar char="-"/>
+            </a:pPr>
+            <a:r>
+              <a:rPr lang="en-US" dirty="0">
+                <a:solidFill>
+                  <a:schemeClr val="bg1"/>
+                </a:solidFill>
+              </a:rPr>
+              <a:t>The path of a file containing N numbers separated by new lines (or commas)</a:t>
+            </a:r>
+          </a:p>
+          <a:p>
+            <a:pPr marL="285750" indent="-285750" fontAlgn="base">
+              <a:buFontTx/>
+              <a:buChar char="-"/>
+            </a:pPr>
+            <a:r>
+              <a:rPr lang="en-US" dirty="0">
+                <a:solidFill>
+                  <a:schemeClr val="bg1"/>
+                </a:solidFill>
+              </a:rPr>
+              <a:t>Number of processes </a:t>
+            </a:r>
+            <a:r>
+              <a:rPr lang="en-US" dirty="0" err="1">
+                <a:solidFill>
+                  <a:schemeClr val="bg1"/>
+                </a:solidFill>
+              </a:rPr>
+              <a:t>n_proc</a:t>
+            </a:r>
+            <a:r>
+              <a:rPr lang="en-US" dirty="0">
+                <a:solidFill>
+                  <a:schemeClr val="bg1"/>
+                </a:solidFill>
+              </a:rPr>
+              <a:t>.</a:t>
+            </a:r>
+          </a:p>
+          <a:p>
+            <a:pPr marL="285750" indent="-285750" fontAlgn="base">
+              <a:buFontTx/>
+              <a:buChar char="-"/>
+            </a:pPr>
+            <a:r>
+              <a:rPr lang="en-US" dirty="0">
+                <a:solidFill>
+                  <a:schemeClr val="bg1"/>
+                </a:solidFill>
+              </a:rPr>
+              <a:t>A pointer to a function f that takes 2 numbers and returns a number.</a:t>
+            </a:r>
+          </a:p>
+          <a:p>
+            <a:pPr fontAlgn="base"/>
+            <a:endParaRPr lang="en-US" dirty="0">
+              <a:solidFill>
+                <a:schemeClr val="bg1"/>
+              </a:solidFill>
+            </a:endParaRPr>
+          </a:p>
+          <a:p>
+            <a:r>
+              <a:rPr lang="en-US" dirty="0">
+                <a:solidFill>
+                  <a:schemeClr val="bg1"/>
+                </a:solidFill>
+              </a:rPr>
+              <a:t>then does the same as </a:t>
+            </a:r>
+            <a:r>
+              <a:rPr lang="en-US" dirty="0" err="1">
+                <a:solidFill>
+                  <a:schemeClr val="bg1"/>
+                </a:solidFill>
+              </a:rPr>
+              <a:t>sequential_compute</a:t>
+            </a:r>
+            <a:r>
+              <a:rPr lang="en-US" dirty="0">
+                <a:solidFill>
+                  <a:schemeClr val="bg1"/>
+                </a:solidFill>
+              </a:rPr>
+              <a:t> except that it splits the computation over </a:t>
+            </a:r>
+            <a:r>
+              <a:rPr lang="en-US" dirty="0" err="1">
+                <a:solidFill>
+                  <a:schemeClr val="bg1"/>
+                </a:solidFill>
+              </a:rPr>
+              <a:t>n_proc</a:t>
+            </a:r>
+            <a:r>
+              <a:rPr lang="en-US" dirty="0">
+                <a:solidFill>
+                  <a:schemeClr val="bg1"/>
+                </a:solidFill>
+              </a:rPr>
+              <a:t> processes as evenly as possible.</a:t>
+            </a:r>
+            <a:endParaRPr lang="en-US" sz="1400" dirty="0">
+              <a:solidFill>
+                <a:schemeClr val="bg1"/>
+              </a:solidFill>
+            </a:endParaRPr>
+          </a:p>
+          <a:p>
+            <a:br>
+              <a:rPr lang="en-US" sz="1400" dirty="0">
+                <a:solidFill>
+                  <a:schemeClr val="bg1"/>
+                </a:solidFill>
+              </a:rPr>
+            </a:br>
+            <a:endParaRPr lang="en-US" sz="1400" dirty="0">
+              <a:solidFill>
+                <a:schemeClr val="bg1"/>
+              </a:solidFill>
+            </a:endParaRPr>
+          </a:p>
+        </p:txBody>
+      </p:sp>
+    </p:spTree>
+    <p:extLst>
+      <p:ext uri="{BB962C8B-B14F-4D97-AF65-F5344CB8AC3E}">
+        <p14:creationId xmlns:p14="http://schemas.microsoft.com/office/powerpoint/2010/main" val="1917002051"/>
+      </p:ext>
+    </p:extLst>
+  </p:cSld>
+  <p:clrMapOvr>
+    <a:masterClrMapping/>
+  </p:clrMapOvr>
+</p:sld>
+</file>
+
+<file path=ppt/slides/slide11.xml><?xml version="1.0" encoding="utf-8"?>
+<p:sld xmlns:a="http://schemas.openxmlformats.org/drawingml/2006/main" xmlns:r="http://schemas.openxmlformats.org/officeDocument/2006/relationships" xmlns:p="http://schemas.openxmlformats.org/presentationml/2006/main">
+  <p:cSld>
+    <p:spTree>
+      <p:nvGrpSpPr>
         <p:cNvPr id="1" name=""/>
         <p:cNvGrpSpPr/>
         <p:nvPr/>
@@ -9539,7 +10020,7 @@
 </p:sld>
 </file>
 
-<file path=ppt/slides/slide11.xml><?xml version="1.0" encoding="utf-8"?>
+<file path=ppt/slides/slide12.xml><?xml version="1.0" encoding="utf-8"?>
 <p:sld xmlns:a="http://schemas.openxmlformats.org/drawingml/2006/main" xmlns:r="http://schemas.openxmlformats.org/officeDocument/2006/relationships" xmlns:p="http://schemas.openxmlformats.org/presentationml/2006/main">
   <p:cSld name="Slide 6">
     <p:bg>
@@ -10718,7 +11199,7 @@
 </p:sld>
 </file>
 
-<file path=ppt/slides/slide12.xml><?xml version="1.0" encoding="utf-8"?>
+<file path=ppt/slides/slide13.xml><?xml version="1.0" encoding="utf-8"?>
 <p:sld xmlns:a="http://schemas.openxmlformats.org/drawingml/2006/main" xmlns:r="http://schemas.openxmlformats.org/officeDocument/2006/relationships" xmlns:p="http://schemas.openxmlformats.org/presentationml/2006/main">
   <p:cSld>
     <p:bg>
@@ -10905,7 +11386,7 @@
 </p:sld>
 </file>
 
-<file path=ppt/slides/slide13.xml><?xml version="1.0" encoding="utf-8"?>
+<file path=ppt/slides/slide14.xml><?xml version="1.0" encoding="utf-8"?>
 <p:sld xmlns:a="http://schemas.openxmlformats.org/drawingml/2006/main" xmlns:r="http://schemas.openxmlformats.org/officeDocument/2006/relationships" xmlns:p="http://schemas.openxmlformats.org/presentationml/2006/main">
   <p:cSld>
     <p:bg>
@@ -11062,7 +11543,7 @@
 </p:sld>
 </file>
 
-<file path=ppt/slides/slide14.xml><?xml version="1.0" encoding="utf-8"?>
+<file path=ppt/slides/slide15.xml><?xml version="1.0" encoding="utf-8"?>
 <p:sld xmlns:a="http://schemas.openxmlformats.org/drawingml/2006/main" xmlns:r="http://schemas.openxmlformats.org/officeDocument/2006/relationships" xmlns:p="http://schemas.openxmlformats.org/presentationml/2006/main">
   <p:cSld>
     <p:bg>
@@ -11219,7 +11700,7 @@
 </p:sld>
 </file>
 
-<file path=ppt/slides/slide15.xml><?xml version="1.0" encoding="utf-8"?>
+<file path=ppt/slides/slide16.xml><?xml version="1.0" encoding="utf-8"?>
 <p:sld xmlns:a="http://schemas.openxmlformats.org/drawingml/2006/main" xmlns:r="http://schemas.openxmlformats.org/officeDocument/2006/relationships" xmlns:p="http://schemas.openxmlformats.org/presentationml/2006/main">
   <p:cSld>
     <p:bg>
@@ -11376,7 +11857,7 @@
 </p:sld>
 </file>
 
-<file path=ppt/slides/slide16.xml><?xml version="1.0" encoding="utf-8"?>
+<file path=ppt/slides/slide17.xml><?xml version="1.0" encoding="utf-8"?>
 <p:sld xmlns:a="http://schemas.openxmlformats.org/drawingml/2006/main" xmlns:r="http://schemas.openxmlformats.org/officeDocument/2006/relationships" xmlns:p="http://schemas.openxmlformats.org/presentationml/2006/main">
   <p:cSld>
     <p:bg>
@@ -11533,7 +12014,7 @@
 </p:sld>
 </file>
 
-<file path=ppt/slides/slide17.xml><?xml version="1.0" encoding="utf-8"?>
+<file path=ppt/slides/slide18.xml><?xml version="1.0" encoding="utf-8"?>
 <p:sld xmlns:a="http://schemas.openxmlformats.org/drawingml/2006/main" xmlns:r="http://schemas.openxmlformats.org/officeDocument/2006/relationships" xmlns:p="http://schemas.openxmlformats.org/presentationml/2006/main">
   <p:cSld name="Slide 7">
     <p:bg>
@@ -12973,7 +13454,7 @@
 </p:sld>
 </file>
 
-<file path=ppt/slides/slide18.xml><?xml version="1.0" encoding="utf-8"?>
+<file path=ppt/slides/slide19.xml><?xml version="1.0" encoding="utf-8"?>
 <p:sld xmlns:a="http://schemas.openxmlformats.org/drawingml/2006/main" xmlns:r="http://schemas.openxmlformats.org/officeDocument/2006/relationships" xmlns:p="http://schemas.openxmlformats.org/presentationml/2006/main">
   <p:cSld>
     <p:bg>
@@ -13130,125 +13611,6 @@
 </p:sld>
 </file>
 
-<file path=ppt/slides/slide19.xml><?xml version="1.0" encoding="utf-8"?>
-<p:sld xmlns:a="http://schemas.openxmlformats.org/drawingml/2006/main" xmlns:r="http://schemas.openxmlformats.org/officeDocument/2006/relationships" xmlns:p="http://schemas.openxmlformats.org/presentationml/2006/main">
-  <p:cSld>
-    <p:spTree>
-      <p:nvGrpSpPr>
-        <p:cNvPr id="1" name="">
-          <a:extLst>
-            <a:ext uri="{FF2B5EF4-FFF2-40B4-BE49-F238E27FC236}">
-              <a16:creationId xmlns:a16="http://schemas.microsoft.com/office/drawing/2014/main" id="{E326FC6C-D093-832E-0B3B-B500D302448F}"/>
-            </a:ext>
-          </a:extLst>
-        </p:cNvPr>
-        <p:cNvGrpSpPr/>
-        <p:nvPr/>
-      </p:nvGrpSpPr>
-      <p:grpSpPr>
-        <a:xfrm>
-          <a:off x="0" y="0"/>
-          <a:ext cx="0" cy="0"/>
-          <a:chOff x="0" y="0"/>
-          <a:chExt cx="0" cy="0"/>
-        </a:xfrm>
-      </p:grpSpPr>
-      <p:sp>
-        <p:nvSpPr>
-          <p:cNvPr id="2" name="Shape 0">
-            <a:extLst>
-              <a:ext uri="{FF2B5EF4-FFF2-40B4-BE49-F238E27FC236}">
-                <a16:creationId xmlns:a16="http://schemas.microsoft.com/office/drawing/2014/main" id="{14C6021D-8419-C0B9-C931-A025F26BA5DC}"/>
-              </a:ext>
-            </a:extLst>
-          </p:cNvPr>
-          <p:cNvSpPr/>
-          <p:nvPr/>
-        </p:nvSpPr>
-        <p:spPr>
-          <a:xfrm>
-            <a:off x="0" y="2137410"/>
-            <a:ext cx="9144000" cy="868680"/>
-          </a:xfrm>
-          <a:prstGeom prst="rect">
-            <a:avLst/>
-          </a:prstGeom>
-          <a:solidFill>
-            <a:srgbClr val="1A1F36"/>
-          </a:solidFill>
-          <a:ln w="12700">
-            <a:solidFill>
-              <a:srgbClr val="1A1F36"/>
-            </a:solidFill>
-            <a:prstDash val="solid"/>
-          </a:ln>
-        </p:spPr>
-        <p:txBody>
-          <a:bodyPr/>
-          <a:lstStyle/>
-          <a:p>
-            <a:endParaRPr lang="en-US"/>
-          </a:p>
-        </p:txBody>
-      </p:sp>
-      <p:sp>
-        <p:nvSpPr>
-          <p:cNvPr id="3" name="Text 1">
-            <a:extLst>
-              <a:ext uri="{FF2B5EF4-FFF2-40B4-BE49-F238E27FC236}">
-                <a16:creationId xmlns:a16="http://schemas.microsoft.com/office/drawing/2014/main" id="{F7D57CF1-F629-C6FB-D2AA-59CB795B6E81}"/>
-              </a:ext>
-            </a:extLst>
-          </p:cNvPr>
-          <p:cNvSpPr/>
-          <p:nvPr/>
-        </p:nvSpPr>
-        <p:spPr>
-          <a:xfrm>
-            <a:off x="365760" y="2247138"/>
-            <a:ext cx="8412480" cy="640080"/>
-          </a:xfrm>
-          <a:prstGeom prst="rect">
-            <a:avLst/>
-          </a:prstGeom>
-          <a:noFill/>
-          <a:ln/>
-        </p:spPr>
-        <p:txBody>
-          <a:bodyPr wrap="square" lIns="0" tIns="0" rIns="0" bIns="0" rtlCol="0" anchor="ctr"/>
-          <a:lstStyle/>
-          <a:p>
-            <a:pPr marL="0" indent="0" algn="ctr">
-              <a:buNone/>
-            </a:pPr>
-            <a:r>
-              <a:rPr lang="en-US" sz="4000" b="1" dirty="0">
-                <a:solidFill>
-                  <a:srgbClr val="FFFFFF"/>
-                </a:solidFill>
-                <a:latin typeface="Calibri" pitchFamily="34" charset="0"/>
-                <a:ea typeface="Calibri" pitchFamily="34" charset="-122"/>
-                <a:cs typeface="Calibri" pitchFamily="34" charset="-120"/>
-              </a:rPr>
-              <a:t>From the pervious project</a:t>
-            </a:r>
-            <a:endParaRPr lang="en-US" sz="4000" dirty="0"/>
-          </a:p>
-        </p:txBody>
-      </p:sp>
-    </p:spTree>
-    <p:extLst>
-      <p:ext uri="{BB962C8B-B14F-4D97-AF65-F5344CB8AC3E}">
-        <p14:creationId xmlns:p14="http://schemas.microsoft.com/office/powerpoint/2010/main" val="898139506"/>
-      </p:ext>
-    </p:extLst>
-  </p:cSld>
-  <p:clrMapOvr>
-    <a:masterClrMapping/>
-  </p:clrMapOvr>
-</p:sld>
-</file>
-
 <file path=ppt/slides/slide2.xml><?xml version="1.0" encoding="utf-8"?>
 <p:sld xmlns:a="http://schemas.openxmlformats.org/drawingml/2006/main" xmlns:r="http://schemas.openxmlformats.org/officeDocument/2006/relationships" xmlns:p="http://schemas.openxmlformats.org/presentationml/2006/main">
   <p:cSld name="Slide 2">
@@ -13582,9 +13944,27 @@
                 <a:ea typeface="Calibri" pitchFamily="34" charset="-122"/>
                 <a:cs typeface="Calibri" pitchFamily="34" charset="-120"/>
               </a:rPr>
-              <a:t>Implemented threads_compute</a:t>
-            </a:r>
-            <a:endParaRPr lang="en-US" sz="1250" dirty="0"/>
+              <a:t>Implemented </a:t>
+            </a:r>
+            <a:r>
+              <a:rPr lang="en-US" sz="1250" dirty="0" err="1">
+                <a:solidFill>
+                  <a:srgbClr val="1A1F36"/>
+                </a:solidFill>
+                <a:latin typeface="Calibri" pitchFamily="34" charset="0"/>
+                <a:ea typeface="Calibri" pitchFamily="34" charset="-122"/>
+                <a:cs typeface="Calibri" pitchFamily="34" charset="-120"/>
+              </a:rPr>
+              <a:t>threads_compute</a:t>
+            </a:r>
+            <a:endParaRPr lang="en-US" sz="1250" dirty="0">
+              <a:solidFill>
+                <a:srgbClr val="1A1F36"/>
+              </a:solidFill>
+              <a:latin typeface="Calibri" pitchFamily="34" charset="0"/>
+              <a:ea typeface="Calibri" pitchFamily="34" charset="-122"/>
+              <a:cs typeface="Calibri" pitchFamily="34" charset="-120"/>
+            </a:endParaRPr>
           </a:p>
           <a:p>
             <a:pPr marL="342900" indent="-342900">
@@ -13603,9 +13983,8 @@
                 <a:ea typeface="Calibri" pitchFamily="34" charset="-122"/>
                 <a:cs typeface="Calibri" pitchFamily="34" charset="-120"/>
               </a:rPr>
-              <a:t>Updated parse.h (read_numbers_ul)</a:t>
-            </a:r>
-            <a:endParaRPr lang="en-US" sz="1250" dirty="0"/>
+              <a:t>Requirements 2, 3, 4, and 5 in the slides.</a:t>
+            </a:r>
           </a:p>
           <a:p>
             <a:pPr marL="342900" indent="-342900">
@@ -14003,6 +14382,125 @@
 </file>
 
 <file path=ppt/slides/slide20.xml><?xml version="1.0" encoding="utf-8"?>
+<p:sld xmlns:a="http://schemas.openxmlformats.org/drawingml/2006/main" xmlns:r="http://schemas.openxmlformats.org/officeDocument/2006/relationships" xmlns:p="http://schemas.openxmlformats.org/presentationml/2006/main">
+  <p:cSld>
+    <p:spTree>
+      <p:nvGrpSpPr>
+        <p:cNvPr id="1" name="">
+          <a:extLst>
+            <a:ext uri="{FF2B5EF4-FFF2-40B4-BE49-F238E27FC236}">
+              <a16:creationId xmlns:a16="http://schemas.microsoft.com/office/drawing/2014/main" id="{E326FC6C-D093-832E-0B3B-B500D302448F}"/>
+            </a:ext>
+          </a:extLst>
+        </p:cNvPr>
+        <p:cNvGrpSpPr/>
+        <p:nvPr/>
+      </p:nvGrpSpPr>
+      <p:grpSpPr>
+        <a:xfrm>
+          <a:off x="0" y="0"/>
+          <a:ext cx="0" cy="0"/>
+          <a:chOff x="0" y="0"/>
+          <a:chExt cx="0" cy="0"/>
+        </a:xfrm>
+      </p:grpSpPr>
+      <p:sp>
+        <p:nvSpPr>
+          <p:cNvPr id="2" name="Shape 0">
+            <a:extLst>
+              <a:ext uri="{FF2B5EF4-FFF2-40B4-BE49-F238E27FC236}">
+                <a16:creationId xmlns:a16="http://schemas.microsoft.com/office/drawing/2014/main" id="{14C6021D-8419-C0B9-C931-A025F26BA5DC}"/>
+              </a:ext>
+            </a:extLst>
+          </p:cNvPr>
+          <p:cNvSpPr/>
+          <p:nvPr/>
+        </p:nvSpPr>
+        <p:spPr>
+          <a:xfrm>
+            <a:off x="0" y="2137410"/>
+            <a:ext cx="9144000" cy="868680"/>
+          </a:xfrm>
+          <a:prstGeom prst="rect">
+            <a:avLst/>
+          </a:prstGeom>
+          <a:solidFill>
+            <a:srgbClr val="1A1F36"/>
+          </a:solidFill>
+          <a:ln w="12700">
+            <a:solidFill>
+              <a:srgbClr val="1A1F36"/>
+            </a:solidFill>
+            <a:prstDash val="solid"/>
+          </a:ln>
+        </p:spPr>
+        <p:txBody>
+          <a:bodyPr/>
+          <a:lstStyle/>
+          <a:p>
+            <a:endParaRPr lang="en-US"/>
+          </a:p>
+        </p:txBody>
+      </p:sp>
+      <p:sp>
+        <p:nvSpPr>
+          <p:cNvPr id="3" name="Text 1">
+            <a:extLst>
+              <a:ext uri="{FF2B5EF4-FFF2-40B4-BE49-F238E27FC236}">
+                <a16:creationId xmlns:a16="http://schemas.microsoft.com/office/drawing/2014/main" id="{F7D57CF1-F629-C6FB-D2AA-59CB795B6E81}"/>
+              </a:ext>
+            </a:extLst>
+          </p:cNvPr>
+          <p:cNvSpPr/>
+          <p:nvPr/>
+        </p:nvSpPr>
+        <p:spPr>
+          <a:xfrm>
+            <a:off x="365760" y="2247138"/>
+            <a:ext cx="8412480" cy="640080"/>
+          </a:xfrm>
+          <a:prstGeom prst="rect">
+            <a:avLst/>
+          </a:prstGeom>
+          <a:noFill/>
+          <a:ln/>
+        </p:spPr>
+        <p:txBody>
+          <a:bodyPr wrap="square" lIns="0" tIns="0" rIns="0" bIns="0" rtlCol="0" anchor="ctr"/>
+          <a:lstStyle/>
+          <a:p>
+            <a:pPr marL="0" indent="0" algn="ctr">
+              <a:buNone/>
+            </a:pPr>
+            <a:r>
+              <a:rPr lang="en-US" sz="4000" b="1" dirty="0">
+                <a:solidFill>
+                  <a:srgbClr val="FFFFFF"/>
+                </a:solidFill>
+                <a:latin typeface="Calibri" pitchFamily="34" charset="0"/>
+                <a:ea typeface="Calibri" pitchFamily="34" charset="-122"/>
+                <a:cs typeface="Calibri" pitchFamily="34" charset="-120"/>
+              </a:rPr>
+              <a:t>From the pervious project</a:t>
+            </a:r>
+            <a:endParaRPr lang="en-US" sz="4000" dirty="0"/>
+          </a:p>
+        </p:txBody>
+      </p:sp>
+    </p:spTree>
+    <p:extLst>
+      <p:ext uri="{BB962C8B-B14F-4D97-AF65-F5344CB8AC3E}">
+        <p14:creationId xmlns:p14="http://schemas.microsoft.com/office/powerpoint/2010/main" val="898139506"/>
+      </p:ext>
+    </p:extLst>
+  </p:cSld>
+  <p:clrMapOvr>
+    <a:masterClrMapping/>
+  </p:clrMapOvr>
+</p:sld>
+</file>
+
+<file path=ppt/slides/slide21.xml><?xml version="1.0" encoding="utf-8"?>
 <p:sld xmlns:a="http://schemas.openxmlformats.org/drawingml/2006/main" xmlns:r="http://schemas.openxmlformats.org/officeDocument/2006/relationships" xmlns:p="http://schemas.openxmlformats.org/presentationml/2006/main">
   <p:cSld>
     <p:spTree>
@@ -14128,7 +14626,7 @@
 </p:sld>
 </file>
 
-<file path=ppt/slides/slide21.xml><?xml version="1.0" encoding="utf-8"?>
+<file path=ppt/slides/slide22.xml><?xml version="1.0" encoding="utf-8"?>
 <p:sld xmlns:a="http://schemas.openxmlformats.org/drawingml/2006/main" xmlns:r="http://schemas.openxmlformats.org/officeDocument/2006/relationships" xmlns:p="http://schemas.openxmlformats.org/presentationml/2006/main">
   <p:cSld>
     <p:spTree>
@@ -14310,7 +14808,7 @@
 </p:sld>
 </file>
 
-<file path=ppt/slides/slide22.xml><?xml version="1.0" encoding="utf-8"?>
+<file path=ppt/slides/slide23.xml><?xml version="1.0" encoding="utf-8"?>
 <p:sld xmlns:a="http://schemas.openxmlformats.org/drawingml/2006/main" xmlns:r="http://schemas.openxmlformats.org/officeDocument/2006/relationships" xmlns:p="http://schemas.openxmlformats.org/presentationml/2006/main">
   <p:cSld>
     <p:spTree>
@@ -14722,7 +15220,7 @@
 </p:sld>
 </file>
 
-<file path=ppt/slides/slide23.xml><?xml version="1.0" encoding="utf-8"?>
+<file path=ppt/slides/slide24.xml><?xml version="1.0" encoding="utf-8"?>
 <p:sld xmlns:a="http://schemas.openxmlformats.org/drawingml/2006/main" xmlns:r="http://schemas.openxmlformats.org/officeDocument/2006/relationships" xmlns:p="http://schemas.openxmlformats.org/presentationml/2006/main">
   <p:cSld>
     <p:spTree>
@@ -15123,7 +15621,7 @@
 </p:sld>
 </file>
 
-<file path=ppt/slides/slide24.xml><?xml version="1.0" encoding="utf-8"?>
+<file path=ppt/slides/slide25.xml><?xml version="1.0" encoding="utf-8"?>
 <p:sld xmlns:a="http://schemas.openxmlformats.org/drawingml/2006/main" xmlns:r="http://schemas.openxmlformats.org/officeDocument/2006/relationships" xmlns:p="http://schemas.openxmlformats.org/presentationml/2006/main">
   <p:cSld>
     <p:spTree>
@@ -15588,7 +16086,7 @@
 </p:sld>
 </file>
 
-<file path=ppt/slides/slide25.xml><?xml version="1.0" encoding="utf-8"?>
+<file path=ppt/slides/slide26.xml><?xml version="1.0" encoding="utf-8"?>
 <p:sld xmlns:a="http://schemas.openxmlformats.org/drawingml/2006/main" xmlns:r="http://schemas.openxmlformats.org/officeDocument/2006/relationships" xmlns:p="http://schemas.openxmlformats.org/presentationml/2006/main">
   <p:cSld>
     <p:spTree>
@@ -16126,6 +16624,269 @@
 </file>
 
 <file path=ppt/slides/slide3.xml><?xml version="1.0" encoding="utf-8"?>
+<p:sld xmlns:a="http://schemas.openxmlformats.org/drawingml/2006/main" xmlns:r="http://schemas.openxmlformats.org/officeDocument/2006/relationships" xmlns:p="http://schemas.openxmlformats.org/presentationml/2006/main">
+  <p:cSld>
+    <p:bg>
+      <p:bgPr>
+        <a:solidFill>
+          <a:srgbClr val="F0F4FF"/>
+        </a:solidFill>
+        <a:effectLst/>
+      </p:bgPr>
+    </p:bg>
+    <p:spTree>
+      <p:nvGrpSpPr>
+        <p:cNvPr id="1" name="">
+          <a:extLst>
+            <a:ext uri="{FF2B5EF4-FFF2-40B4-BE49-F238E27FC236}">
+              <a16:creationId xmlns:a16="http://schemas.microsoft.com/office/drawing/2014/main" id="{0D6A99A5-72B3-62AA-23C7-C811F24472B1}"/>
+            </a:ext>
+          </a:extLst>
+        </p:cNvPr>
+        <p:cNvGrpSpPr/>
+        <p:nvPr/>
+      </p:nvGrpSpPr>
+      <p:grpSpPr>
+        <a:xfrm>
+          <a:off x="0" y="0"/>
+          <a:ext cx="0" cy="0"/>
+          <a:chOff x="0" y="0"/>
+          <a:chExt cx="0" cy="0"/>
+        </a:xfrm>
+      </p:grpSpPr>
+      <p:sp>
+        <p:nvSpPr>
+          <p:cNvPr id="2" name="Shape 0">
+            <a:extLst>
+              <a:ext uri="{FF2B5EF4-FFF2-40B4-BE49-F238E27FC236}">
+                <a16:creationId xmlns:a16="http://schemas.microsoft.com/office/drawing/2014/main" id="{A141E49C-97F8-210D-B9EC-89D735E099BC}"/>
+              </a:ext>
+            </a:extLst>
+          </p:cNvPr>
+          <p:cNvSpPr/>
+          <p:nvPr/>
+        </p:nvSpPr>
+        <p:spPr>
+          <a:xfrm>
+            <a:off x="0" y="0"/>
+            <a:ext cx="9144000" cy="868680"/>
+          </a:xfrm>
+          <a:prstGeom prst="rect">
+            <a:avLst/>
+          </a:prstGeom>
+          <a:solidFill>
+            <a:srgbClr val="1A1F36"/>
+          </a:solidFill>
+          <a:ln w="12700">
+            <a:solidFill>
+              <a:srgbClr val="1A1F36"/>
+            </a:solidFill>
+            <a:prstDash val="solid"/>
+          </a:ln>
+        </p:spPr>
+        <p:txBody>
+          <a:bodyPr/>
+          <a:lstStyle/>
+          <a:p>
+            <a:endParaRPr lang="en-US"/>
+          </a:p>
+        </p:txBody>
+      </p:sp>
+      <p:sp>
+        <p:nvSpPr>
+          <p:cNvPr id="3" name="Text 1">
+            <a:extLst>
+              <a:ext uri="{FF2B5EF4-FFF2-40B4-BE49-F238E27FC236}">
+                <a16:creationId xmlns:a16="http://schemas.microsoft.com/office/drawing/2014/main" id="{F8AEE429-C215-621B-D23C-639C79692D31}"/>
+              </a:ext>
+            </a:extLst>
+          </p:cNvPr>
+          <p:cNvSpPr/>
+          <p:nvPr/>
+        </p:nvSpPr>
+        <p:spPr>
+          <a:xfrm>
+            <a:off x="365760" y="109728"/>
+            <a:ext cx="8229600" cy="640080"/>
+          </a:xfrm>
+          <a:prstGeom prst="rect">
+            <a:avLst/>
+          </a:prstGeom>
+          <a:noFill/>
+          <a:ln/>
+        </p:spPr>
+        <p:txBody>
+          <a:bodyPr wrap="square" lIns="0" tIns="0" rIns="0" bIns="0" rtlCol="0" anchor="ctr"/>
+          <a:lstStyle/>
+          <a:p>
+            <a:pPr marL="0" indent="0">
+              <a:buNone/>
+            </a:pPr>
+            <a:r>
+              <a:rPr lang="en-US" sz="2600" b="1" dirty="0" err="1">
+                <a:solidFill>
+                  <a:srgbClr val="FFFFFF"/>
+                </a:solidFill>
+                <a:latin typeface="Calibri" pitchFamily="34" charset="0"/>
+                <a:ea typeface="Calibri" pitchFamily="34" charset="-122"/>
+                <a:cs typeface="Calibri" pitchFamily="34" charset="-120"/>
+              </a:rPr>
+              <a:t>Github</a:t>
+            </a:r>
+            <a:r>
+              <a:rPr lang="en-US" sz="2600" b="1" dirty="0">
+                <a:solidFill>
+                  <a:srgbClr val="FFFFFF"/>
+                </a:solidFill>
+                <a:latin typeface="Calibri" pitchFamily="34" charset="0"/>
+                <a:ea typeface="Calibri" pitchFamily="34" charset="-122"/>
+                <a:cs typeface="Calibri" pitchFamily="34" charset="-120"/>
+              </a:rPr>
+              <a:t> Repo Link:</a:t>
+            </a:r>
+            <a:endParaRPr lang="en-US" sz="2600" dirty="0"/>
+          </a:p>
+        </p:txBody>
+      </p:sp>
+      <p:sp>
+        <p:nvSpPr>
+          <p:cNvPr id="4" name="Shape 2">
+            <a:extLst>
+              <a:ext uri="{FF2B5EF4-FFF2-40B4-BE49-F238E27FC236}">
+                <a16:creationId xmlns:a16="http://schemas.microsoft.com/office/drawing/2014/main" id="{8727915E-1074-3BBF-FBF7-53C47BADE9CA}"/>
+              </a:ext>
+            </a:extLst>
+          </p:cNvPr>
+          <p:cNvSpPr/>
+          <p:nvPr/>
+        </p:nvSpPr>
+        <p:spPr>
+          <a:xfrm>
+            <a:off x="495886" y="2235356"/>
+            <a:ext cx="8152228" cy="1456006"/>
+          </a:xfrm>
+          <a:prstGeom prst="rect">
+            <a:avLst/>
+          </a:prstGeom>
+          <a:solidFill>
+            <a:srgbClr val="FFFFFF"/>
+          </a:solidFill>
+          <a:ln w="12700">
+            <a:solidFill>
+              <a:srgbClr val="E0E6F8"/>
+            </a:solidFill>
+            <a:prstDash val="solid"/>
+          </a:ln>
+          <a:effectLst>
+            <a:outerShdw blurRad="101600" dist="38100" dir="8100000" algn="bl" rotWithShape="0">
+              <a:srgbClr val="000000">
+                <a:alpha val="18000"/>
+              </a:srgbClr>
+            </a:outerShdw>
+          </a:effectLst>
+        </p:spPr>
+        <p:txBody>
+          <a:bodyPr/>
+          <a:lstStyle/>
+          <a:p>
+            <a:endParaRPr lang="en-US"/>
+          </a:p>
+        </p:txBody>
+      </p:sp>
+      <p:sp>
+        <p:nvSpPr>
+          <p:cNvPr id="5" name="Shape 3">
+            <a:extLst>
+              <a:ext uri="{FF2B5EF4-FFF2-40B4-BE49-F238E27FC236}">
+                <a16:creationId xmlns:a16="http://schemas.microsoft.com/office/drawing/2014/main" id="{977CFD76-40EE-D0BD-7B1C-0A874B2662EA}"/>
+              </a:ext>
+            </a:extLst>
+          </p:cNvPr>
+          <p:cNvSpPr/>
+          <p:nvPr/>
+        </p:nvSpPr>
+        <p:spPr>
+          <a:xfrm>
+            <a:off x="495886" y="2243796"/>
+            <a:ext cx="4023360" cy="109728"/>
+          </a:xfrm>
+          <a:prstGeom prst="rect">
+            <a:avLst/>
+          </a:prstGeom>
+          <a:solidFill>
+            <a:srgbClr val="4F8EF7"/>
+          </a:solidFill>
+          <a:ln w="12700">
+            <a:solidFill>
+              <a:srgbClr val="4F8EF7"/>
+            </a:solidFill>
+            <a:prstDash val="solid"/>
+          </a:ln>
+        </p:spPr>
+        <p:txBody>
+          <a:bodyPr/>
+          <a:lstStyle/>
+          <a:p>
+            <a:endParaRPr lang="en-US"/>
+          </a:p>
+        </p:txBody>
+      </p:sp>
+      <p:sp>
+        <p:nvSpPr>
+          <p:cNvPr id="6" name="Text 4">
+            <a:extLst>
+              <a:ext uri="{FF2B5EF4-FFF2-40B4-BE49-F238E27FC236}">
+                <a16:creationId xmlns:a16="http://schemas.microsoft.com/office/drawing/2014/main" id="{7BD92DE5-5EF3-18E4-1642-DAA58437744A}"/>
+              </a:ext>
+            </a:extLst>
+          </p:cNvPr>
+          <p:cNvSpPr/>
+          <p:nvPr/>
+        </p:nvSpPr>
+        <p:spPr>
+          <a:xfrm>
+            <a:off x="993178" y="2838508"/>
+            <a:ext cx="7600775" cy="320040"/>
+          </a:xfrm>
+          <a:prstGeom prst="rect">
+            <a:avLst/>
+          </a:prstGeom>
+          <a:noFill/>
+          <a:ln/>
+        </p:spPr>
+        <p:txBody>
+          <a:bodyPr wrap="square" lIns="0" tIns="0" rIns="0" bIns="0" rtlCol="0" anchor="ctr"/>
+          <a:lstStyle/>
+          <a:p>
+            <a:r>
+              <a:rPr lang="en-US" sz="1600" b="1" dirty="0">
+                <a:solidFill>
+                  <a:srgbClr val="4F8EF7"/>
+                </a:solidFill>
+                <a:latin typeface="Calibri" pitchFamily="34" charset="0"/>
+                <a:ea typeface="Calibri" pitchFamily="34" charset="-122"/>
+                <a:cs typeface="Calibri" pitchFamily="34" charset="-120"/>
+              </a:rPr>
+              <a:t>https://github.com/Sama3mad/Project-5---IPC-via-Shared-Memory-POSIX-Threads-.git</a:t>
+            </a:r>
+            <a:endParaRPr lang="en-US" sz="1600" dirty="0"/>
+          </a:p>
+        </p:txBody>
+      </p:sp>
+    </p:spTree>
+    <p:extLst>
+      <p:ext uri="{BB962C8B-B14F-4D97-AF65-F5344CB8AC3E}">
+        <p14:creationId xmlns:p14="http://schemas.microsoft.com/office/powerpoint/2010/main" val="1925994685"/>
+      </p:ext>
+    </p:extLst>
+  </p:cSld>
+  <p:clrMapOvr>
+    <a:masterClrMapping/>
+  </p:clrMapOvr>
+</p:sld>
+</file>
+
+<file path=ppt/slides/slide4.xml><?xml version="1.0" encoding="utf-8"?>
 <p:sld xmlns:a="http://schemas.openxmlformats.org/drawingml/2006/main" xmlns:r="http://schemas.openxmlformats.org/officeDocument/2006/relationships" xmlns:p="http://schemas.openxmlformats.org/presentationml/2006/main">
   <p:cSld name="Slide 3">
     <p:bg>
@@ -17905,7 +18666,7 @@
 </p:sld>
 </file>
 
-<file path=ppt/slides/slide4.xml><?xml version="1.0" encoding="utf-8"?>
+<file path=ppt/slides/slide5.xml><?xml version="1.0" encoding="utf-8"?>
 <p:sld xmlns:a="http://schemas.openxmlformats.org/drawingml/2006/main" xmlns:r="http://schemas.openxmlformats.org/officeDocument/2006/relationships" xmlns:p="http://schemas.openxmlformats.org/presentationml/2006/main">
   <p:cSld name="Slide 4">
     <p:bg>
@@ -18749,7 +19510,7 @@
 </p:sld>
 </file>
 
-<file path=ppt/slides/slide5.xml><?xml version="1.0" encoding="utf-8"?>
+<file path=ppt/slides/slide6.xml><?xml version="1.0" encoding="utf-8"?>
 <p:sld xmlns:a="http://schemas.openxmlformats.org/drawingml/2006/main" xmlns:r="http://schemas.openxmlformats.org/officeDocument/2006/relationships" xmlns:p="http://schemas.openxmlformats.org/presentationml/2006/main">
   <p:cSld>
     <p:bg>
@@ -19224,7 +19985,7 @@
 </p:sld>
 </file>
 
-<file path=ppt/slides/slide6.xml><?xml version="1.0" encoding="utf-8"?>
+<file path=ppt/slides/slide7.xml><?xml version="1.0" encoding="utf-8"?>
 <p:sld xmlns:a="http://schemas.openxmlformats.org/drawingml/2006/main" xmlns:r="http://schemas.openxmlformats.org/officeDocument/2006/relationships" xmlns:p="http://schemas.openxmlformats.org/presentationml/2006/main">
   <p:cSld name="Slide 5">
     <p:bg>
@@ -20404,7 +21165,7 @@
 </p:sld>
 </file>
 
-<file path=ppt/slides/slide7.xml><?xml version="1.0" encoding="utf-8"?>
+<file path=ppt/slides/slide8.xml><?xml version="1.0" encoding="utf-8"?>
 <p:sld xmlns:a="http://schemas.openxmlformats.org/drawingml/2006/main" xmlns:r="http://schemas.openxmlformats.org/officeDocument/2006/relationships" xmlns:p="http://schemas.openxmlformats.org/presentationml/2006/main">
   <p:cSld>
     <p:bg>
@@ -20531,7 +21292,7 @@
 </p:sld>
 </file>
 
-<file path=ppt/slides/slide8.xml><?xml version="1.0" encoding="utf-8"?>
+<file path=ppt/slides/slide9.xml><?xml version="1.0" encoding="utf-8"?>
 <p:sld xmlns:a="http://schemas.openxmlformats.org/drawingml/2006/main" xmlns:r="http://schemas.openxmlformats.org/officeDocument/2006/relationships" xmlns:p="http://schemas.openxmlformats.org/presentationml/2006/main">
   <p:cSld>
     <p:spTree>
@@ -21095,378 +21856,6 @@
         </p:txBody>
       </p:sp>
     </p:spTree>
-  </p:cSld>
-  <p:clrMapOvr>
-    <a:masterClrMapping/>
-  </p:clrMapOvr>
-</p:sld>
-</file>
-
-<file path=ppt/slides/slide9.xml><?xml version="1.0" encoding="utf-8"?>
-<p:sld xmlns:a="http://schemas.openxmlformats.org/drawingml/2006/main" xmlns:r="http://schemas.openxmlformats.org/officeDocument/2006/relationships" xmlns:p="http://schemas.openxmlformats.org/presentationml/2006/main">
-  <p:cSld>
-    <p:spTree>
-      <p:nvGrpSpPr>
-        <p:cNvPr id="1" name="">
-          <a:extLst>
-            <a:ext uri="{FF2B5EF4-FFF2-40B4-BE49-F238E27FC236}">
-              <a16:creationId xmlns:a16="http://schemas.microsoft.com/office/drawing/2014/main" id="{725B3854-6ADE-1361-C926-BC58365BF789}"/>
-            </a:ext>
-          </a:extLst>
-        </p:cNvPr>
-        <p:cNvGrpSpPr/>
-        <p:nvPr/>
-      </p:nvGrpSpPr>
-      <p:grpSpPr>
-        <a:xfrm>
-          <a:off x="0" y="0"/>
-          <a:ext cx="0" cy="0"/>
-          <a:chOff x="0" y="0"/>
-          <a:chExt cx="0" cy="0"/>
-        </a:xfrm>
-      </p:grpSpPr>
-      <p:sp>
-        <p:nvSpPr>
-          <p:cNvPr id="2" name="Shape 0">
-            <a:extLst>
-              <a:ext uri="{FF2B5EF4-FFF2-40B4-BE49-F238E27FC236}">
-                <a16:creationId xmlns:a16="http://schemas.microsoft.com/office/drawing/2014/main" id="{6478A43A-06D6-0B79-0B1C-69F930775618}"/>
-              </a:ext>
-            </a:extLst>
-          </p:cNvPr>
-          <p:cNvSpPr/>
-          <p:nvPr/>
-        </p:nvSpPr>
-        <p:spPr>
-          <a:xfrm>
-            <a:off x="0" y="0"/>
-            <a:ext cx="9144000" cy="777240"/>
-          </a:xfrm>
-          <a:prstGeom prst="rect">
-            <a:avLst/>
-          </a:prstGeom>
-          <a:solidFill>
-            <a:srgbClr val="00A896"/>
-          </a:solidFill>
-          <a:ln w="12700">
-            <a:solidFill>
-              <a:srgbClr val="00A896"/>
-            </a:solidFill>
-            <a:prstDash val="solid"/>
-          </a:ln>
-        </p:spPr>
-        <p:txBody>
-          <a:bodyPr/>
-          <a:lstStyle/>
-          <a:p>
-            <a:endParaRPr lang="en-US"/>
-          </a:p>
-        </p:txBody>
-      </p:sp>
-      <p:sp>
-        <p:nvSpPr>
-          <p:cNvPr id="3" name="Text 1">
-            <a:extLst>
-              <a:ext uri="{FF2B5EF4-FFF2-40B4-BE49-F238E27FC236}">
-                <a16:creationId xmlns:a16="http://schemas.microsoft.com/office/drawing/2014/main" id="{320303AF-3C5C-D3B3-2594-B705F57EB492}"/>
-              </a:ext>
-            </a:extLst>
-          </p:cNvPr>
-          <p:cNvSpPr/>
-          <p:nvPr/>
-        </p:nvSpPr>
-        <p:spPr>
-          <a:xfrm>
-            <a:off x="365760" y="0"/>
-            <a:ext cx="8412480" cy="777240"/>
-          </a:xfrm>
-          <a:prstGeom prst="rect">
-            <a:avLst/>
-          </a:prstGeom>
-          <a:noFill/>
-          <a:ln/>
-        </p:spPr>
-        <p:txBody>
-          <a:bodyPr wrap="square" lIns="0" tIns="0" rIns="0" bIns="0" rtlCol="0" anchor="ctr"/>
-          <a:lstStyle/>
-          <a:p>
-            <a:pPr marL="0" indent="0">
-              <a:buNone/>
-            </a:pPr>
-            <a:r>
-              <a:rPr lang="en-US" sz="2400" b="1" dirty="0">
-                <a:solidFill>
-                  <a:srgbClr val="FFFFFF"/>
-                </a:solidFill>
-                <a:latin typeface="Calibri" pitchFamily="34" charset="0"/>
-                <a:ea typeface="Calibri" pitchFamily="34" charset="-122"/>
-                <a:cs typeface="Calibri" pitchFamily="34" charset="-120"/>
-              </a:rPr>
-              <a:t>02  Parallel Compute - Description</a:t>
-            </a:r>
-            <a:endParaRPr lang="en-US" sz="2400" dirty="0"/>
-          </a:p>
-        </p:txBody>
-      </p:sp>
-      <p:sp>
-        <p:nvSpPr>
-          <p:cNvPr id="4" name="Shape 2">
-            <a:extLst>
-              <a:ext uri="{FF2B5EF4-FFF2-40B4-BE49-F238E27FC236}">
-                <a16:creationId xmlns:a16="http://schemas.microsoft.com/office/drawing/2014/main" id="{AA68B348-F7F1-BA22-450B-F651397AFFD9}"/>
-              </a:ext>
-            </a:extLst>
-          </p:cNvPr>
-          <p:cNvSpPr/>
-          <p:nvPr/>
-        </p:nvSpPr>
-        <p:spPr>
-          <a:xfrm>
-            <a:off x="457200" y="1325880"/>
-            <a:ext cx="8015068" cy="3017521"/>
-          </a:xfrm>
-          <a:prstGeom prst="rect">
-            <a:avLst/>
-          </a:prstGeom>
-          <a:solidFill>
-            <a:srgbClr val="1C2E3E"/>
-          </a:solidFill>
-          <a:ln w="12700">
-            <a:solidFill>
-              <a:srgbClr val="3D5166"/>
-            </a:solidFill>
-            <a:prstDash val="solid"/>
-          </a:ln>
-        </p:spPr>
-        <p:txBody>
-          <a:bodyPr/>
-          <a:lstStyle/>
-          <a:p>
-            <a:endParaRPr lang="en-US"/>
-          </a:p>
-        </p:txBody>
-      </p:sp>
-      <p:sp>
-        <p:nvSpPr>
-          <p:cNvPr id="5" name="Text 3">
-            <a:extLst>
-              <a:ext uri="{FF2B5EF4-FFF2-40B4-BE49-F238E27FC236}">
-                <a16:creationId xmlns:a16="http://schemas.microsoft.com/office/drawing/2014/main" id="{B3B31F22-1334-30EB-0ED4-0FC625DB0246}"/>
-              </a:ext>
-            </a:extLst>
-          </p:cNvPr>
-          <p:cNvSpPr/>
-          <p:nvPr/>
-        </p:nvSpPr>
-        <p:spPr>
-          <a:xfrm>
-            <a:off x="594360" y="1456008"/>
-            <a:ext cx="3657600" cy="365760"/>
-          </a:xfrm>
-          <a:prstGeom prst="rect">
-            <a:avLst/>
-          </a:prstGeom>
-          <a:noFill/>
-          <a:ln/>
-        </p:spPr>
-        <p:txBody>
-          <a:bodyPr wrap="square" rtlCol="0" anchor="ctr"/>
-          <a:lstStyle/>
-          <a:p>
-            <a:pPr marL="0" indent="0">
-              <a:buNone/>
-            </a:pPr>
-            <a:r>
-              <a:rPr lang="en-US" sz="2000" b="1" dirty="0">
-                <a:solidFill>
-                  <a:srgbClr val="00C9A7"/>
-                </a:solidFill>
-                <a:latin typeface="Calibri" pitchFamily="34" charset="0"/>
-                <a:ea typeface="Calibri" pitchFamily="34" charset="-122"/>
-                <a:cs typeface="Calibri" pitchFamily="34" charset="-120"/>
-              </a:rPr>
-              <a:t>What it does</a:t>
-            </a:r>
-            <a:endParaRPr lang="en-US" sz="2000" dirty="0"/>
-          </a:p>
-        </p:txBody>
-      </p:sp>
-      <p:sp>
-        <p:nvSpPr>
-          <p:cNvPr id="6" name="Text 4">
-            <a:extLst>
-              <a:ext uri="{FF2B5EF4-FFF2-40B4-BE49-F238E27FC236}">
-                <a16:creationId xmlns:a16="http://schemas.microsoft.com/office/drawing/2014/main" id="{ADA7DDB5-7839-A085-F6AE-B26DCE933E60}"/>
-              </a:ext>
-            </a:extLst>
-          </p:cNvPr>
-          <p:cNvSpPr/>
-          <p:nvPr/>
-        </p:nvSpPr>
-        <p:spPr>
-          <a:xfrm>
-            <a:off x="1041009" y="2440745"/>
-            <a:ext cx="7336302" cy="1515794"/>
-          </a:xfrm>
-          <a:prstGeom prst="rect">
-            <a:avLst/>
-          </a:prstGeom>
-          <a:noFill/>
-          <a:ln/>
-        </p:spPr>
-        <p:txBody>
-          <a:bodyPr wrap="square" rtlCol="0" anchor="ctr"/>
-          <a:lstStyle/>
-          <a:p>
-            <a:r>
-              <a:rPr lang="en-US" dirty="0">
-                <a:solidFill>
-                  <a:schemeClr val="bg1"/>
-                </a:solidFill>
-              </a:rPr>
-              <a:t>Takes:</a:t>
-            </a:r>
-            <a:endParaRPr lang="en-US" sz="1400" dirty="0">
-              <a:solidFill>
-                <a:schemeClr val="bg1"/>
-              </a:solidFill>
-            </a:endParaRPr>
-          </a:p>
-          <a:p>
-            <a:pPr marL="285750" indent="-285750" fontAlgn="base">
-              <a:buFontTx/>
-              <a:buChar char="-"/>
-            </a:pPr>
-            <a:r>
-              <a:rPr lang="en-US" dirty="0">
-                <a:solidFill>
-                  <a:schemeClr val="bg1"/>
-                </a:solidFill>
-              </a:rPr>
-              <a:t>The path of a file containing N numbers separated by new lines (or commas)</a:t>
-            </a:r>
-          </a:p>
-          <a:p>
-            <a:pPr marL="285750" indent="-285750" fontAlgn="base">
-              <a:buFontTx/>
-              <a:buChar char="-"/>
-            </a:pPr>
-            <a:r>
-              <a:rPr lang="en-US" dirty="0">
-                <a:solidFill>
-                  <a:schemeClr val="bg1"/>
-                </a:solidFill>
-              </a:rPr>
-              <a:t>Number of processes </a:t>
-            </a:r>
-            <a:r>
-              <a:rPr lang="en-US" dirty="0" err="1">
-                <a:solidFill>
-                  <a:schemeClr val="bg1"/>
-                </a:solidFill>
-              </a:rPr>
-              <a:t>n_proc</a:t>
-            </a:r>
-            <a:r>
-              <a:rPr lang="en-US" dirty="0">
-                <a:solidFill>
-                  <a:schemeClr val="bg1"/>
-                </a:solidFill>
-              </a:rPr>
-              <a:t>.</a:t>
-            </a:r>
-          </a:p>
-          <a:p>
-            <a:pPr marL="285750" indent="-285750" fontAlgn="base">
-              <a:buFontTx/>
-              <a:buChar char="-"/>
-            </a:pPr>
-            <a:r>
-              <a:rPr lang="en-US" dirty="0">
-                <a:solidFill>
-                  <a:schemeClr val="bg1"/>
-                </a:solidFill>
-              </a:rPr>
-              <a:t>A pointer to a function f that takes 2 numbers and returns a number.</a:t>
-            </a:r>
-          </a:p>
-          <a:p>
-            <a:pPr fontAlgn="base"/>
-            <a:endParaRPr lang="en-US" dirty="0">
-              <a:solidFill>
-                <a:schemeClr val="bg1"/>
-              </a:solidFill>
-            </a:endParaRPr>
-          </a:p>
-          <a:p>
-            <a:r>
-              <a:rPr lang="en-US" dirty="0">
-                <a:solidFill>
-                  <a:schemeClr val="bg1"/>
-                </a:solidFill>
-              </a:rPr>
-              <a:t>then does the same as </a:t>
-            </a:r>
-            <a:r>
-              <a:rPr lang="en-US" dirty="0" err="1">
-                <a:solidFill>
-                  <a:schemeClr val="bg1"/>
-                </a:solidFill>
-              </a:rPr>
-              <a:t>sequential_compute</a:t>
-            </a:r>
-            <a:r>
-              <a:rPr lang="en-US" dirty="0">
-                <a:solidFill>
-                  <a:schemeClr val="bg1"/>
-                </a:solidFill>
-              </a:rPr>
-              <a:t> except that it splits the computation over </a:t>
-            </a:r>
-            <a:r>
-              <a:rPr lang="en-US" dirty="0" err="1">
-                <a:solidFill>
-                  <a:schemeClr val="bg1"/>
-                </a:solidFill>
-              </a:rPr>
-              <a:t>n_proc</a:t>
-            </a:r>
-            <a:r>
-              <a:rPr lang="en-US" dirty="0">
-                <a:solidFill>
-                  <a:schemeClr val="bg1"/>
-                </a:solidFill>
-              </a:rPr>
-              <a:t> processes as evenly as possible.</a:t>
-            </a:r>
-            <a:endParaRPr lang="en-US" sz="1400" dirty="0">
-              <a:solidFill>
-                <a:schemeClr val="bg1"/>
-              </a:solidFill>
-            </a:endParaRPr>
-          </a:p>
-          <a:p>
-            <a:br>
-              <a:rPr lang="en-US" sz="1400" dirty="0">
-                <a:solidFill>
-                  <a:schemeClr val="bg1"/>
-                </a:solidFill>
-              </a:rPr>
-            </a:br>
-            <a:endParaRPr lang="en-US" sz="1400" dirty="0">
-              <a:solidFill>
-                <a:schemeClr val="bg1"/>
-              </a:solidFill>
-            </a:endParaRPr>
-          </a:p>
-        </p:txBody>
-      </p:sp>
-    </p:spTree>
-    <p:extLst>
-      <p:ext uri="{BB962C8B-B14F-4D97-AF65-F5344CB8AC3E}">
-        <p14:creationId xmlns:p14="http://schemas.microsoft.com/office/powerpoint/2010/main" val="1917002051"/>
-      </p:ext>
-    </p:extLst>
   </p:cSld>
   <p:clrMapOvr>
     <a:masterClrMapping/>

</xml_diff>